<commit_message>
Add competitive analysis (Appendix D), revise proposal with 10 new features, update pitch deck to match
</commit_message>
<xml_diff>
--- a/RFP/IoTeye - Arc Mercer Pitch.pptx
+++ b/RFP/IoTeye - Arc Mercer Pitch.pptx
@@ -3403,7 +3403,7 @@
               </a:defRPr>
             </a:pPr>
             <a:r>
-              <a:t>Rewards Marketplace</a:t>
+              <a:t>Rewards Marketplace — Digital, Café &amp; In-Person Store</a:t>
             </a:r>
           </a:p>
         </p:txBody>
@@ -3453,7 +3453,7 @@
         <p:spPr>
           <a:xfrm>
             <a:off x="365760" y="1691640"/>
-            <a:ext cx="5029200" cy="2011680"/>
+            <a:ext cx="5029200" cy="1371600"/>
           </a:xfrm>
           <a:prstGeom prst="rect">
             <a:avLst/>
@@ -3468,7 +3468,7 @@
           <a:p>
             <a:pPr algn="l">
               <a:spcAft>
-                <a:spcPts val="800"/>
+                <a:spcPts val="600"/>
               </a:spcAft>
               <a:defRPr sz="1400" b="0">
                 <a:solidFill>
@@ -3484,7 +3484,7 @@
           <a:p>
             <a:pPr>
               <a:spcAft>
-                <a:spcPts val="800"/>
+                <a:spcPts val="600"/>
               </a:spcAft>
               <a:defRPr sz="1400">
                 <a:solidFill>
@@ -3500,7 +3500,7 @@
           <a:p>
             <a:pPr>
               <a:spcAft>
-                <a:spcPts val="800"/>
+                <a:spcPts val="600"/>
               </a:spcAft>
               <a:defRPr sz="1400">
                 <a:solidFill>
@@ -3516,7 +3516,7 @@
           <a:p>
             <a:pPr>
               <a:spcAft>
-                <a:spcPts val="800"/>
+                <a:spcPts val="600"/>
               </a:spcAft>
               <a:defRPr sz="1400">
                 <a:solidFill>
@@ -3529,10 +3529,85 @@
               <a:t>• One-tap redemption with confirmation</a:t>
             </a:r>
           </a:p>
+        </p:txBody>
+      </p:sp>
+      <p:sp>
+        <p:nvSpPr>
+          <p:cNvPr id="6" name="TextBox 5"/>
+          <p:cNvSpPr txBox="1"/>
+          <p:nvPr/>
+        </p:nvSpPr>
+        <p:spPr>
+          <a:xfrm>
+            <a:off x="365760" y="3063240"/>
+            <a:ext cx="5029200" cy="411480"/>
+          </a:xfrm>
+          <a:prstGeom prst="rect">
+            <a:avLst/>
+          </a:prstGeom>
+          <a:noFill/>
+        </p:spPr>
+        <p:txBody>
+          <a:bodyPr wrap="square">
+            <a:spAutoFit/>
+          </a:bodyPr>
+          <a:lstStyle/>
+          <a:p>
+            <a:pPr algn="l">
+              <a:defRPr sz="2200" b="1">
+                <a:solidFill>
+                  <a:srgbClr val="2E86C1"/>
+                </a:solidFill>
+                <a:latin typeface="Calibri"/>
+              </a:defRPr>
+            </a:pPr>
+            <a:r>
+              <a:t>Café Cashier Redemption Screen</a:t>
+            </a:r>
+          </a:p>
+        </p:txBody>
+      </p:sp>
+      <p:sp>
+        <p:nvSpPr>
+          <p:cNvPr id="7" name="TextBox 6"/>
+          <p:cNvSpPr txBox="1"/>
+          <p:nvPr/>
+        </p:nvSpPr>
+        <p:spPr>
+          <a:xfrm>
+            <a:off x="365760" y="3520440"/>
+            <a:ext cx="5029200" cy="1188720"/>
+          </a:xfrm>
+          <a:prstGeom prst="rect">
+            <a:avLst/>
+          </a:prstGeom>
+          <a:noFill/>
+        </p:spPr>
+        <p:txBody>
+          <a:bodyPr wrap="square">
+            <a:spAutoFit/>
+          </a:bodyPr>
+          <a:lstStyle/>
+          <a:p>
+            <a:pPr algn="l">
+              <a:spcAft>
+                <a:spcPts val="600"/>
+              </a:spcAft>
+              <a:defRPr sz="1400" b="0">
+                <a:solidFill>
+                  <a:srgbClr val="333333"/>
+                </a:solidFill>
+                <a:latin typeface="Calibri"/>
+              </a:defRPr>
+            </a:pPr>
+            <a:r>
+              <a:t>• Tablet-friendly cashier interface for meal redemptions</a:t>
+            </a:r>
+          </a:p>
           <a:p>
             <a:pPr>
               <a:spcAft>
-                <a:spcPts val="800"/>
+                <a:spcPts val="600"/>
               </a:spcAft>
               <a:defRPr sz="1400">
                 <a:solidFill>
@@ -3542,20 +3617,52 @@
               </a:defRPr>
             </a:pPr>
             <a:r>
-              <a:t>• Order history for employees</a:t>
-            </a:r>
-          </a:p>
-        </p:txBody>
-      </p:sp>
-      <p:sp>
-        <p:nvSpPr>
-          <p:cNvPr id="6" name="TextBox 5"/>
-          <p:cNvSpPr txBox="1"/>
-          <p:nvPr/>
-        </p:nvSpPr>
-        <p:spPr>
-          <a:xfrm>
-            <a:off x="365760" y="3749039"/>
+              <a:t>• Employee lookup by name, badge ID, or QR code</a:t>
+            </a:r>
+          </a:p>
+          <a:p>
+            <a:pPr>
+              <a:spcAft>
+                <a:spcPts val="600"/>
+              </a:spcAft>
+              <a:defRPr sz="1400">
+                <a:solidFill>
+                  <a:srgbClr val="333333"/>
+                </a:solidFill>
+                <a:latin typeface="Calibri"/>
+              </a:defRPr>
+            </a:pPr>
+            <a:r>
+              <a:t>• Balance display → meal selection → point deduction</a:t>
+            </a:r>
+          </a:p>
+          <a:p>
+            <a:pPr>
+              <a:spcAft>
+                <a:spcPts val="600"/>
+              </a:spcAft>
+              <a:defRPr sz="1400">
+                <a:solidFill>
+                  <a:srgbClr val="333333"/>
+                </a:solidFill>
+                <a:latin typeface="Calibri"/>
+              </a:defRPr>
+            </a:pPr>
+            <a:r>
+              <a:t>• No POS integration required — standalone operation</a:t>
+            </a:r>
+          </a:p>
+        </p:txBody>
+      </p:sp>
+      <p:sp>
+        <p:nvSpPr>
+          <p:cNvPr id="8" name="TextBox 7"/>
+          <p:cNvSpPr txBox="1"/>
+          <p:nvPr/>
+        </p:nvSpPr>
+        <p:spPr>
+          <a:xfrm>
+            <a:off x="365760" y="4709160"/>
             <a:ext cx="5029200" cy="411480"/>
           </a:xfrm>
           <a:prstGeom prst="rect">
@@ -3578,21 +3685,21 @@
               </a:defRPr>
             </a:pPr>
             <a:r>
-              <a:t>Admin Fulfillment Tools</a:t>
-            </a:r>
-          </a:p>
-        </p:txBody>
-      </p:sp>
-      <p:sp>
-        <p:nvSpPr>
-          <p:cNvPr id="7" name="TextBox 6"/>
-          <p:cNvSpPr txBox="1"/>
-          <p:nvPr/>
-        </p:nvSpPr>
-        <p:spPr>
-          <a:xfrm>
-            <a:off x="365760" y="4206240"/>
-            <a:ext cx="5029200" cy="2286000"/>
+              <a:t>In-Person Store &amp; QR Redemption</a:t>
+            </a:r>
+          </a:p>
+        </p:txBody>
+      </p:sp>
+      <p:sp>
+        <p:nvSpPr>
+          <p:cNvPr id="9" name="TextBox 8"/>
+          <p:cNvSpPr txBox="1"/>
+          <p:nvPr/>
+        </p:nvSpPr>
+        <p:spPr>
+          <a:xfrm>
+            <a:off x="365760" y="5166360"/>
+            <a:ext cx="5029200" cy="1188720"/>
           </a:xfrm>
           <a:prstGeom prst="rect">
             <a:avLst/>
@@ -3607,7 +3714,7 @@
           <a:p>
             <a:pPr algn="l">
               <a:spcAft>
-                <a:spcPts val="800"/>
+                <a:spcPts val="600"/>
               </a:spcAft>
               <a:defRPr sz="1400" b="0">
                 <a:solidFill>
@@ -3617,13 +3724,13 @@
               </a:defRPr>
             </a:pPr>
             <a:r>
-              <a:t>• Inventory management (add/edit items, stock levels)</a:t>
+              <a:t>• Employee QR code on profile / home screen</a:t>
             </a:r>
           </a:p>
           <a:p>
             <a:pPr>
               <a:spcAft>
-                <a:spcPts val="800"/>
+                <a:spcPts val="600"/>
               </a:spcAft>
               <a:defRPr sz="1400">
                 <a:solidFill>
@@ -3633,13 +3740,13 @@
               </a:defRPr>
             </a:pPr>
             <a:r>
-              <a:t>• Low-stock alerts, out-of-stock auto-hiding</a:t>
+              <a:t>• Store attendant scans QR → select item → confirm</a:t>
             </a:r>
           </a:p>
           <a:p>
             <a:pPr>
               <a:spcAft>
-                <a:spcPts val="800"/>
+                <a:spcPts val="600"/>
               </a:spcAft>
               <a:defRPr sz="1400">
                 <a:solidFill>
@@ -3649,46 +3756,14 @@
               </a:defRPr>
             </a:pPr>
             <a:r>
-              <a:t>• Order queue: Pending → Processing → Fulfilled</a:t>
-            </a:r>
-          </a:p>
-          <a:p>
-            <a:pPr>
-              <a:spcAft>
-                <a:spcPts val="800"/>
-              </a:spcAft>
-              <a:defRPr sz="1400">
-                <a:solidFill>
-                  <a:srgbClr val="333333"/>
-                </a:solidFill>
-                <a:latin typeface="Calibri"/>
-              </a:defRPr>
-            </a:pPr>
-            <a:r>
-              <a:t>• Digital gift card: API-based instant delivery</a:t>
-            </a:r>
-          </a:p>
-          <a:p>
-            <a:pPr>
-              <a:spcAft>
-                <a:spcPts val="800"/>
-              </a:spcAft>
-              <a:defRPr sz="1400">
-                <a:solidFill>
-                  <a:srgbClr val="333333"/>
-                </a:solidFill>
-                <a:latin typeface="Calibri"/>
-              </a:defRPr>
-            </a:pPr>
-            <a:r>
-              <a:t>• Gift card fees: 3-5% vendor markup (pass-through)</a:t>
+              <a:t>• Inventory sync: physical store + digital storefront</a:t>
             </a:r>
           </a:p>
         </p:txBody>
       </p:sp>
       <p:pic>
         <p:nvPicPr>
-          <p:cNvPr id="8" name="Picture 7" descr="reward_4.png"/>
+          <p:cNvPr id="10" name="Picture 9" descr="reward_4.png"/>
           <p:cNvPicPr>
             <a:picLocks noChangeAspect="1"/>
           </p:cNvPicPr>
@@ -3810,7 +3885,7 @@
               </a:defRPr>
             </a:pPr>
             <a:r>
-              <a:t>Paycom Integration &amp; SSO</a:t>
+              <a:t>Paycom Integration &amp; Authentication</a:t>
             </a:r>
           </a:p>
         </p:txBody>
@@ -4096,21 +4171,100 @@
               </a:defRPr>
             </a:pPr>
             <a:r>
-              <a:t>Single Sign-On (SSO)</a:t>
-            </a:r>
-          </a:p>
-        </p:txBody>
-      </p:sp>
-      <p:sp>
-        <p:nvSpPr>
-          <p:cNvPr id="9" name="TextBox 8"/>
-          <p:cNvSpPr txBox="1"/>
+              <a:t>Three Login Paths</a:t>
+            </a:r>
+          </a:p>
+        </p:txBody>
+      </p:sp>
+      <p:sp>
+        <p:nvSpPr>
+          <p:cNvPr id="9" name="Rectangle 8"/>
+          <p:cNvSpPr/>
           <p:nvPr/>
         </p:nvSpPr>
         <p:spPr>
           <a:xfrm>
             <a:off x="6400800" y="1828800"/>
-            <a:ext cx="5029200" cy="4114800"/>
+            <a:ext cx="5029200" cy="1234440"/>
+          </a:xfrm>
+          <a:prstGeom prst="rect">
+            <a:avLst/>
+          </a:prstGeom>
+          <a:solidFill>
+            <a:srgbClr val="D6EAF8"/>
+          </a:solidFill>
+          <a:ln>
+            <a:noFill/>
+          </a:ln>
+        </p:spPr>
+        <p:style>
+          <a:lnRef idx="1">
+            <a:schemeClr val="accent1"/>
+          </a:lnRef>
+          <a:fillRef idx="3">
+            <a:schemeClr val="accent1"/>
+          </a:fillRef>
+          <a:effectRef idx="2">
+            <a:schemeClr val="accent1"/>
+          </a:effectRef>
+          <a:fontRef idx="minor">
+            <a:schemeClr val="lt1"/>
+          </a:fontRef>
+        </p:style>
+        <p:txBody>
+          <a:bodyPr rtlCol="0" anchor="ctr"/>
+          <a:lstStyle/>
+          <a:p>
+            <a:pPr algn="ctr"/>
+          </a:p>
+        </p:txBody>
+      </p:sp>
+      <p:sp>
+        <p:nvSpPr>
+          <p:cNvPr id="10" name="TextBox 9"/>
+          <p:cNvSpPr txBox="1"/>
+          <p:nvPr/>
+        </p:nvSpPr>
+        <p:spPr>
+          <a:xfrm>
+            <a:off x="6537960" y="1874519"/>
+            <a:ext cx="4754880" cy="320040"/>
+          </a:xfrm>
+          <a:prstGeom prst="rect">
+            <a:avLst/>
+          </a:prstGeom>
+          <a:noFill/>
+        </p:spPr>
+        <p:txBody>
+          <a:bodyPr wrap="square">
+            <a:spAutoFit/>
+          </a:bodyPr>
+          <a:lstStyle/>
+          <a:p>
+            <a:pPr algn="l">
+              <a:defRPr sz="1600" b="1">
+                <a:solidFill>
+                  <a:srgbClr val="1B2A4A"/>
+                </a:solidFill>
+                <a:latin typeface="Calibri"/>
+              </a:defRPr>
+            </a:pPr>
+            <a:r>
+              <a:t>➀  Badge ID + PIN (Frontline Staff)</a:t>
+            </a:r>
+          </a:p>
+        </p:txBody>
+      </p:sp>
+      <p:sp>
+        <p:nvSpPr>
+          <p:cNvPr id="11" name="TextBox 10"/>
+          <p:cNvSpPr txBox="1"/>
+          <p:nvPr/>
+        </p:nvSpPr>
+        <p:spPr>
+          <a:xfrm>
+            <a:off x="6537960" y="2194560"/>
+            <a:ext cx="4754880" cy="822960"/>
           </a:xfrm>
           <a:prstGeom prst="rect">
             <a:avLst/>
@@ -4125,97 +4279,381 @@
           <a:p>
             <a:pPr algn="l">
               <a:spcAft>
-                <a:spcPts val="1000"/>
+                <a:spcPts val="400"/>
               </a:spcAft>
-              <a:defRPr sz="1500" b="0">
-                <a:solidFill>
-                  <a:srgbClr val="333333"/>
-                </a:solidFill>
-                <a:latin typeface="Calibri"/>
-              </a:defRPr>
-            </a:pPr>
-            <a:r>
-              <a:t>• Supabase Auth: SAML 2.0, OAuth 2.0, OIDC</a:t>
+              <a:defRPr sz="1300" b="0">
+                <a:solidFill>
+                  <a:srgbClr val="333333"/>
+                </a:solidFill>
+                <a:latin typeface="Calibri"/>
+              </a:defRPr>
+            </a:pPr>
+            <a:r>
+              <a:t>• Paycom badge ID — the ID they already carry daily</a:t>
             </a:r>
           </a:p>
           <a:p>
             <a:pPr>
               <a:spcAft>
-                <a:spcPts val="1000"/>
+                <a:spcPts val="400"/>
               </a:spcAft>
-              <a:defRPr sz="1500">
-                <a:solidFill>
-                  <a:srgbClr val="333333"/>
-                </a:solidFill>
-                <a:latin typeface="Calibri"/>
-              </a:defRPr>
-            </a:pPr>
-            <a:r>
-              <a:t>• Initial: Google Workspace SSO (current provider)</a:t>
+              <a:defRPr sz="1300">
+                <a:solidFill>
+                  <a:srgbClr val="333333"/>
+                </a:solidFill>
+                <a:latin typeface="Calibri"/>
+              </a:defRPr>
+            </a:pPr>
+            <a:r>
+              <a:t>• Self-set 4–6 digit PIN, no email required</a:t>
             </a:r>
           </a:p>
           <a:p>
             <a:pPr>
               <a:spcAft>
-                <a:spcPts val="1000"/>
+                <a:spcPts val="400"/>
               </a:spcAft>
-              <a:defRPr sz="1500">
-                <a:solidFill>
-                  <a:srgbClr val="333333"/>
-                </a:solidFill>
-                <a:latin typeface="Calibri"/>
-              </a:defRPr>
-            </a:pPr>
-            <a:r>
-              <a:t>• Future: Microsoft Entra ID — zero-downtime migration</a:t>
+              <a:defRPr sz="1300">
+                <a:solidFill>
+                  <a:srgbClr val="333333"/>
+                </a:solidFill>
+                <a:latin typeface="Calibri"/>
+              </a:defRPr>
+            </a:pPr>
+            <a:r>
+              <a:t>• Hashed/salted PINs, lockout after 5 failed attempts</a:t>
+            </a:r>
+          </a:p>
+        </p:txBody>
+      </p:sp>
+      <p:sp>
+        <p:nvSpPr>
+          <p:cNvPr id="12" name="Rectangle 11"/>
+          <p:cNvSpPr/>
+          <p:nvPr/>
+        </p:nvSpPr>
+        <p:spPr>
+          <a:xfrm>
+            <a:off x="6400800" y="3200400"/>
+            <a:ext cx="5029200" cy="1097280"/>
+          </a:xfrm>
+          <a:prstGeom prst="rect">
+            <a:avLst/>
+          </a:prstGeom>
+          <a:solidFill>
+            <a:srgbClr val="F2F2F2"/>
+          </a:solidFill>
+          <a:ln>
+            <a:noFill/>
+          </a:ln>
+        </p:spPr>
+        <p:style>
+          <a:lnRef idx="1">
+            <a:schemeClr val="accent1"/>
+          </a:lnRef>
+          <a:fillRef idx="3">
+            <a:schemeClr val="accent1"/>
+          </a:fillRef>
+          <a:effectRef idx="2">
+            <a:schemeClr val="accent1"/>
+          </a:effectRef>
+          <a:fontRef idx="minor">
+            <a:schemeClr val="lt1"/>
+          </a:fontRef>
+        </p:style>
+        <p:txBody>
+          <a:bodyPr rtlCol="0" anchor="ctr"/>
+          <a:lstStyle/>
+          <a:p>
+            <a:pPr algn="ctr"/>
+          </a:p>
+        </p:txBody>
+      </p:sp>
+      <p:sp>
+        <p:nvSpPr>
+          <p:cNvPr id="13" name="TextBox 12"/>
+          <p:cNvSpPr txBox="1"/>
+          <p:nvPr/>
+        </p:nvSpPr>
+        <p:spPr>
+          <a:xfrm>
+            <a:off x="6537960" y="3246120"/>
+            <a:ext cx="4754880" cy="320040"/>
+          </a:xfrm>
+          <a:prstGeom prst="rect">
+            <a:avLst/>
+          </a:prstGeom>
+          <a:noFill/>
+        </p:spPr>
+        <p:txBody>
+          <a:bodyPr wrap="square">
+            <a:spAutoFit/>
+          </a:bodyPr>
+          <a:lstStyle/>
+          <a:p>
+            <a:pPr algn="l">
+              <a:defRPr sz="1600" b="1">
+                <a:solidFill>
+                  <a:srgbClr val="1B2A4A"/>
+                </a:solidFill>
+                <a:latin typeface="Calibri"/>
+              </a:defRPr>
+            </a:pPr>
+            <a:r>
+              <a:t>➁  Google Workspace SSO (Admin &amp; Mgmt)</a:t>
+            </a:r>
+          </a:p>
+        </p:txBody>
+      </p:sp>
+      <p:sp>
+        <p:nvSpPr>
+          <p:cNvPr id="14" name="TextBox 13"/>
+          <p:cNvSpPr txBox="1"/>
+          <p:nvPr/>
+        </p:nvSpPr>
+        <p:spPr>
+          <a:xfrm>
+            <a:off x="6537960" y="3566160"/>
+            <a:ext cx="4754880" cy="640080"/>
+          </a:xfrm>
+          <a:prstGeom prst="rect">
+            <a:avLst/>
+          </a:prstGeom>
+          <a:noFill/>
+        </p:spPr>
+        <p:txBody>
+          <a:bodyPr wrap="square">
+            <a:spAutoFit/>
+          </a:bodyPr>
+          <a:lstStyle/>
+          <a:p>
+            <a:pPr algn="l">
+              <a:spcAft>
+                <a:spcPts val="400"/>
+              </a:spcAft>
+              <a:defRPr sz="1300" b="0">
+                <a:solidFill>
+                  <a:srgbClr val="333333"/>
+                </a:solidFill>
+                <a:latin typeface="Calibri"/>
+              </a:defRPr>
+            </a:pPr>
+            <a:r>
+              <a:t>• Supabase Auth: SAML 2.0, OAuth 2.0, OIDC</a:t>
             </a:r>
           </a:p>
           <a:p>
             <a:pPr>
               <a:spcAft>
-                <a:spcPts val="1000"/>
+                <a:spcPts val="400"/>
               </a:spcAft>
-              <a:defRPr sz="1500">
-                <a:solidFill>
-                  <a:srgbClr val="333333"/>
-                </a:solidFill>
-                <a:latin typeface="Calibri"/>
-              </a:defRPr>
-            </a:pPr>
-            <a:r>
-              <a:t>• Both providers can run in parallel during transition</a:t>
-            </a:r>
-          </a:p>
-          <a:p>
-            <a:pPr>
-              <a:spcAft>
-                <a:spcPts val="1000"/>
-              </a:spcAft>
-              <a:defRPr sz="1500">
-                <a:solidFill>
-                  <a:srgbClr val="333333"/>
-                </a:solidFill>
-                <a:latin typeface="Calibri"/>
-              </a:defRPr>
-            </a:pPr>
-            <a:r>
-              <a:t>• Fallback: email/password for part-time staff</a:t>
-            </a:r>
-          </a:p>
-          <a:p>
-            <a:pPr>
-              <a:spcAft>
-                <a:spcPts val="1000"/>
-              </a:spcAft>
-              <a:defRPr sz="1500">
-                <a:solidFill>
-                  <a:srgbClr val="333333"/>
-                </a:solidFill>
-                <a:latin typeface="Calibri"/>
-              </a:defRPr>
-            </a:pPr>
-            <a:r>
-              <a:t>• Employee clicks 'Sign In' → Google login → done</a:t>
+              <a:defRPr sz="1300">
+                <a:solidFill>
+                  <a:srgbClr val="333333"/>
+                </a:solidFill>
+                <a:latin typeface="Calibri"/>
+              </a:defRPr>
+            </a:pPr>
+            <a:r>
+              <a:t>• Future: Microsoft Entra ID — zero-downtime migration</a:t>
+            </a:r>
+          </a:p>
+        </p:txBody>
+      </p:sp>
+      <p:sp>
+        <p:nvSpPr>
+          <p:cNvPr id="15" name="Rectangle 14"/>
+          <p:cNvSpPr/>
+          <p:nvPr/>
+        </p:nvSpPr>
+        <p:spPr>
+          <a:xfrm>
+            <a:off x="6400800" y="4434840"/>
+            <a:ext cx="5029200" cy="640080"/>
+          </a:xfrm>
+          <a:prstGeom prst="rect">
+            <a:avLst/>
+          </a:prstGeom>
+          <a:solidFill>
+            <a:srgbClr val="F2F2F2"/>
+          </a:solidFill>
+          <a:ln>
+            <a:noFill/>
+          </a:ln>
+        </p:spPr>
+        <p:style>
+          <a:lnRef idx="1">
+            <a:schemeClr val="accent1"/>
+          </a:lnRef>
+          <a:fillRef idx="3">
+            <a:schemeClr val="accent1"/>
+          </a:fillRef>
+          <a:effectRef idx="2">
+            <a:schemeClr val="accent1"/>
+          </a:effectRef>
+          <a:fontRef idx="minor">
+            <a:schemeClr val="lt1"/>
+          </a:fontRef>
+        </p:style>
+        <p:txBody>
+          <a:bodyPr rtlCol="0" anchor="ctr"/>
+          <a:lstStyle/>
+          <a:p>
+            <a:pPr algn="ctr"/>
+          </a:p>
+        </p:txBody>
+      </p:sp>
+      <p:sp>
+        <p:nvSpPr>
+          <p:cNvPr id="16" name="TextBox 15"/>
+          <p:cNvSpPr txBox="1"/>
+          <p:nvPr/>
+        </p:nvSpPr>
+        <p:spPr>
+          <a:xfrm>
+            <a:off x="6537960" y="4480560"/>
+            <a:ext cx="4754880" cy="320040"/>
+          </a:xfrm>
+          <a:prstGeom prst="rect">
+            <a:avLst/>
+          </a:prstGeom>
+          <a:noFill/>
+        </p:spPr>
+        <p:txBody>
+          <a:bodyPr wrap="square">
+            <a:spAutoFit/>
+          </a:bodyPr>
+          <a:lstStyle/>
+          <a:p>
+            <a:pPr algn="l">
+              <a:defRPr sz="1600" b="1">
+                <a:solidFill>
+                  <a:srgbClr val="1B2A4A"/>
+                </a:solidFill>
+                <a:latin typeface="Calibri"/>
+              </a:defRPr>
+            </a:pPr>
+            <a:r>
+              <a:t>➂  Email / Password Fallback</a:t>
+            </a:r>
+          </a:p>
+        </p:txBody>
+      </p:sp>
+      <p:sp>
+        <p:nvSpPr>
+          <p:cNvPr id="17" name="TextBox 16"/>
+          <p:cNvSpPr txBox="1"/>
+          <p:nvPr/>
+        </p:nvSpPr>
+        <p:spPr>
+          <a:xfrm>
+            <a:off x="6537960" y="4800600"/>
+            <a:ext cx="4754880" cy="274320"/>
+          </a:xfrm>
+          <a:prstGeom prst="rect">
+            <a:avLst/>
+          </a:prstGeom>
+          <a:noFill/>
+        </p:spPr>
+        <p:txBody>
+          <a:bodyPr wrap="square">
+            <a:spAutoFit/>
+          </a:bodyPr>
+          <a:lstStyle/>
+          <a:p>
+            <a:pPr algn="l">
+              <a:defRPr sz="1300" b="0">
+                <a:solidFill>
+                  <a:srgbClr val="333333"/>
+                </a:solidFill>
+                <a:latin typeface="Calibri"/>
+              </a:defRPr>
+            </a:pPr>
+            <a:r>
+              <a:t>For part-time or seasonal staff with email but not on SSO</a:t>
+            </a:r>
+          </a:p>
+        </p:txBody>
+      </p:sp>
+      <p:sp>
+        <p:nvSpPr>
+          <p:cNvPr id="18" name="Rectangle 17"/>
+          <p:cNvSpPr/>
+          <p:nvPr/>
+        </p:nvSpPr>
+        <p:spPr>
+          <a:xfrm>
+            <a:off x="6400800" y="5303520"/>
+            <a:ext cx="5029200" cy="731520"/>
+          </a:xfrm>
+          <a:prstGeom prst="rect">
+            <a:avLst/>
+          </a:prstGeom>
+          <a:solidFill>
+            <a:srgbClr val="27AE60"/>
+          </a:solidFill>
+          <a:ln>
+            <a:noFill/>
+          </a:ln>
+        </p:spPr>
+        <p:style>
+          <a:lnRef idx="1">
+            <a:schemeClr val="accent1"/>
+          </a:lnRef>
+          <a:fillRef idx="3">
+            <a:schemeClr val="accent1"/>
+          </a:fillRef>
+          <a:effectRef idx="2">
+            <a:schemeClr val="accent1"/>
+          </a:effectRef>
+          <a:fontRef idx="minor">
+            <a:schemeClr val="lt1"/>
+          </a:fontRef>
+        </p:style>
+        <p:txBody>
+          <a:bodyPr rtlCol="0" anchor="ctr"/>
+          <a:lstStyle/>
+          <a:p>
+            <a:pPr algn="ctr"/>
+          </a:p>
+        </p:txBody>
+      </p:sp>
+      <p:sp>
+        <p:nvSpPr>
+          <p:cNvPr id="19" name="TextBox 18"/>
+          <p:cNvSpPr txBox="1"/>
+          <p:nvPr/>
+        </p:nvSpPr>
+        <p:spPr>
+          <a:xfrm>
+            <a:off x="6537960" y="5349240"/>
+            <a:ext cx="4754880" cy="594360"/>
+          </a:xfrm>
+          <a:prstGeom prst="rect">
+            <a:avLst/>
+          </a:prstGeom>
+          <a:noFill/>
+        </p:spPr>
+        <p:txBody>
+          <a:bodyPr wrap="square">
+            <a:spAutoFit/>
+          </a:bodyPr>
+          <a:lstStyle/>
+          <a:p>
+            <a:pPr algn="l">
+              <a:defRPr sz="1400" b="1">
+                <a:solidFill>
+                  <a:srgbClr val="FFFFFF"/>
+                </a:solidFill>
+                <a:latin typeface="Calibri"/>
+              </a:defRPr>
+            </a:pPr>
+            <a:r>
+              <a:t>★ Every employee can access the platform —</a:t>
+            </a:r>
+            <a:br/>
+            <a:r>
+              <a:t>no matter their tech level or email situation</a:t>
             </a:r>
           </a:p>
         </p:txBody>
@@ -4320,7 +4758,7 @@
               </a:defRPr>
             </a:pPr>
             <a:r>
-              <a:t>Accessibility &amp; Mobile-First Design</a:t>
+              <a:t>Accessibility, Dark Mode &amp; Mobile-First Design</a:t>
             </a:r>
           </a:p>
         </p:txBody>
@@ -4634,7 +5072,7 @@
               </a:defRPr>
             </a:pPr>
             <a:r>
-              <a:t>• Bottom nav: Home, Nominate, Store, Points, Profile</a:t>
+              <a:t>• Dark mode / light mode toggle for night shifts</a:t>
             </a:r>
           </a:p>
           <a:p>
@@ -4650,7 +5088,7 @@
               </a:defRPr>
             </a:pPr>
             <a:r>
-              <a:t>• Touch-optimized: swipe, pull-to-refresh</a:t>
+              <a:t>• System preference detection, persisted per user</a:t>
             </a:r>
           </a:p>
           <a:p>
@@ -5475,7 +5913,7 @@
               </a:defRPr>
             </a:pPr>
             <a:r>
-              <a:t>• QA queue (approve/return/decline)</a:t>
+              <a:t>• Selection committee ranked-choice voting</a:t>
             </a:r>
           </a:p>
           <a:p>
@@ -5491,7 +5929,7 @@
               </a:defRPr>
             </a:pPr>
             <a:r>
-              <a:t>• Paycom SFTP sync</a:t>
+              <a:t>• QA queue + revise-and-resubmit workflow</a:t>
             </a:r>
           </a:p>
           <a:p>
@@ -5507,7 +5945,7 @@
               </a:defRPr>
             </a:pPr>
             <a:r>
-              <a:t>• Google Workspace SSO</a:t>
+              <a:t>• Paycom SFTP sync</a:t>
             </a:r>
           </a:p>
           <a:p>
@@ -5523,82 +5961,7 @@
               </a:defRPr>
             </a:pPr>
             <a:r>
-              <a:t>• Manual point bestowal + audit trail</a:t>
-            </a:r>
-          </a:p>
-        </p:txBody>
-      </p:sp>
-      <p:sp>
-        <p:nvSpPr>
-          <p:cNvPr id="12" name="TextBox 11"/>
-          <p:cNvSpPr txBox="1"/>
-          <p:nvPr/>
-        </p:nvSpPr>
-        <p:spPr>
-          <a:xfrm>
-            <a:off x="4572000" y="4389120"/>
-            <a:ext cx="3474720" cy="365760"/>
-          </a:xfrm>
-          <a:prstGeom prst="rect">
-            <a:avLst/>
-          </a:prstGeom>
-          <a:noFill/>
-        </p:spPr>
-        <p:txBody>
-          <a:bodyPr wrap="square">
-            <a:spAutoFit/>
-          </a:bodyPr>
-          <a:lstStyle/>
-          <a:p>
-            <a:pPr algn="l">
-              <a:defRPr sz="1600" b="1">
-                <a:solidFill>
-                  <a:srgbClr val="14735A"/>
-                </a:solidFill>
-                <a:latin typeface="Calibri"/>
-              </a:defRPr>
-            </a:pPr>
-            <a:r>
-              <a:t>Phase 2 Deliverables</a:t>
-            </a:r>
-          </a:p>
-        </p:txBody>
-      </p:sp>
-      <p:sp>
-        <p:nvSpPr>
-          <p:cNvPr id="13" name="TextBox 12"/>
-          <p:cNvSpPr txBox="1"/>
-          <p:nvPr/>
-        </p:nvSpPr>
-        <p:spPr>
-          <a:xfrm>
-            <a:off x="4572000" y="4754880"/>
-            <a:ext cx="3474720" cy="2286000"/>
-          </a:xfrm>
-          <a:prstGeom prst="rect">
-            <a:avLst/>
-          </a:prstGeom>
-          <a:noFill/>
-        </p:spPr>
-        <p:txBody>
-          <a:bodyPr wrap="square">
-            <a:spAutoFit/>
-          </a:bodyPr>
-          <a:lstStyle/>
-          <a:p>
-            <a:pPr algn="l">
-              <a:spcAft>
-                <a:spcPts val="400"/>
-              </a:spcAft>
-              <a:defRPr sz="1300" b="0">
-                <a:solidFill>
-                  <a:srgbClr val="333333"/>
-                </a:solidFill>
-                <a:latin typeface="Calibri"/>
-              </a:defRPr>
-            </a:pPr>
-            <a:r>
-              <a:t>• Employee dashboards</a:t>
+              <a:t>• Badge ID + PIN auth (frontline staff)</a:t>
             </a:r>
           </a:p>
           <a:p>
@@ -5614,7 +5977,7 @@
               </a:defRPr>
             </a:pPr>
             <a:r>
-              <a:t>• Leadership analytics</a:t>
+              <a:t>• Google Workspace SSO</a:t>
             </a:r>
           </a:p>
           <a:p>
@@ -5630,7 +5993,82 @@
               </a:defRPr>
             </a:pPr>
             <a:r>
-              <a:t>• Automated birthday/anniversary awards</a:t>
+              <a:t>• Manual point bestowal + audit trail</a:t>
+            </a:r>
+          </a:p>
+        </p:txBody>
+      </p:sp>
+      <p:sp>
+        <p:nvSpPr>
+          <p:cNvPr id="12" name="TextBox 11"/>
+          <p:cNvSpPr txBox="1"/>
+          <p:nvPr/>
+        </p:nvSpPr>
+        <p:spPr>
+          <a:xfrm>
+            <a:off x="4572000" y="4389120"/>
+            <a:ext cx="3474720" cy="365760"/>
+          </a:xfrm>
+          <a:prstGeom prst="rect">
+            <a:avLst/>
+          </a:prstGeom>
+          <a:noFill/>
+        </p:spPr>
+        <p:txBody>
+          <a:bodyPr wrap="square">
+            <a:spAutoFit/>
+          </a:bodyPr>
+          <a:lstStyle/>
+          <a:p>
+            <a:pPr algn="l">
+              <a:defRPr sz="1600" b="1">
+                <a:solidFill>
+                  <a:srgbClr val="14735A"/>
+                </a:solidFill>
+                <a:latin typeface="Calibri"/>
+              </a:defRPr>
+            </a:pPr>
+            <a:r>
+              <a:t>Phase 2 Deliverables</a:t>
+            </a:r>
+          </a:p>
+        </p:txBody>
+      </p:sp>
+      <p:sp>
+        <p:nvSpPr>
+          <p:cNvPr id="13" name="TextBox 12"/>
+          <p:cNvSpPr txBox="1"/>
+          <p:nvPr/>
+        </p:nvSpPr>
+        <p:spPr>
+          <a:xfrm>
+            <a:off x="4572000" y="4754880"/>
+            <a:ext cx="3474720" cy="2286000"/>
+          </a:xfrm>
+          <a:prstGeom prst="rect">
+            <a:avLst/>
+          </a:prstGeom>
+          <a:noFill/>
+        </p:spPr>
+        <p:txBody>
+          <a:bodyPr wrap="square">
+            <a:spAutoFit/>
+          </a:bodyPr>
+          <a:lstStyle/>
+          <a:p>
+            <a:pPr algn="l">
+              <a:spcAft>
+                <a:spcPts val="400"/>
+              </a:spcAft>
+              <a:defRPr sz="1300" b="0">
+                <a:solidFill>
+                  <a:srgbClr val="333333"/>
+                </a:solidFill>
+                <a:latin typeface="Calibri"/>
+              </a:defRPr>
+            </a:pPr>
+            <a:r>
+              <a:t>• Employee &amp; leadership dashboards</a:t>
             </a:r>
           </a:p>
           <a:p>
@@ -5646,7 +6084,7 @@
               </a:defRPr>
             </a:pPr>
             <a:r>
-              <a:t>• TAC attendance &amp; trivia tracking</a:t>
+              <a:t>• Dark mode / light mode toggle</a:t>
             </a:r>
           </a:p>
           <a:p>
@@ -5662,82 +6100,7 @@
               </a:defRPr>
             </a:pPr>
             <a:r>
-              <a:t>• Push/email notifications</a:t>
-            </a:r>
-          </a:p>
-        </p:txBody>
-      </p:sp>
-      <p:sp>
-        <p:nvSpPr>
-          <p:cNvPr id="14" name="TextBox 13"/>
-          <p:cNvSpPr txBox="1"/>
-          <p:nvPr/>
-        </p:nvSpPr>
-        <p:spPr>
-          <a:xfrm>
-            <a:off x="8412480" y="4389120"/>
-            <a:ext cx="3474720" cy="365760"/>
-          </a:xfrm>
-          <a:prstGeom prst="rect">
-            <a:avLst/>
-          </a:prstGeom>
-          <a:noFill/>
-        </p:spPr>
-        <p:txBody>
-          <a:bodyPr wrap="square">
-            <a:spAutoFit/>
-          </a:bodyPr>
-          <a:lstStyle/>
-          <a:p>
-            <a:pPr algn="l">
-              <a:defRPr sz="1600" b="1">
-                <a:solidFill>
-                  <a:srgbClr val="E67E22"/>
-                </a:solidFill>
-                <a:latin typeface="Calibri"/>
-              </a:defRPr>
-            </a:pPr>
-            <a:r>
-              <a:t>Phase 3 Deliverables</a:t>
-            </a:r>
-          </a:p>
-        </p:txBody>
-      </p:sp>
-      <p:sp>
-        <p:nvSpPr>
-          <p:cNvPr id="15" name="TextBox 14"/>
-          <p:cNvSpPr txBox="1"/>
-          <p:nvPr/>
-        </p:nvSpPr>
-        <p:spPr>
-          <a:xfrm>
-            <a:off x="8412480" y="4754880"/>
-            <a:ext cx="3474720" cy="2286000"/>
-          </a:xfrm>
-          <a:prstGeom prst="rect">
-            <a:avLst/>
-          </a:prstGeom>
-          <a:noFill/>
-        </p:spPr>
-        <p:txBody>
-          <a:bodyPr wrap="square">
-            <a:spAutoFit/>
-          </a:bodyPr>
-          <a:lstStyle/>
-          <a:p>
-            <a:pPr algn="l">
-              <a:spcAft>
-                <a:spcPts val="400"/>
-              </a:spcAft>
-              <a:defRPr sz="1300" b="0">
-                <a:solidFill>
-                  <a:srgbClr val="333333"/>
-                </a:solidFill>
-                <a:latin typeface="Calibri"/>
-              </a:defRPr>
-            </a:pPr>
-            <a:r>
-              <a:t>• Digital rewards storefront</a:t>
+              <a:t>• TAC RSVP &amp; role sign-ups</a:t>
             </a:r>
           </a:p>
           <a:p>
@@ -5753,7 +6116,7 @@
               </a:defRPr>
             </a:pPr>
             <a:r>
-              <a:t>• Physical &amp; digital fulfillment</a:t>
+              <a:t>• Culture groups, volunteer forms</a:t>
             </a:r>
           </a:p>
           <a:p>
@@ -5769,7 +6132,7 @@
               </a:defRPr>
             </a:pPr>
             <a:r>
-              <a:t>• Gift card instant delivery</a:t>
+              <a:t>• Social media engagement (screenshot)</a:t>
             </a:r>
           </a:p>
           <a:p>
@@ -5785,7 +6148,82 @@
               </a:defRPr>
             </a:pPr>
             <a:r>
-              <a:t>• Inventory management</a:t>
+              <a:t>• Push/email notifications</a:t>
+            </a:r>
+          </a:p>
+        </p:txBody>
+      </p:sp>
+      <p:sp>
+        <p:nvSpPr>
+          <p:cNvPr id="14" name="TextBox 13"/>
+          <p:cNvSpPr txBox="1"/>
+          <p:nvPr/>
+        </p:nvSpPr>
+        <p:spPr>
+          <a:xfrm>
+            <a:off x="8412480" y="4389120"/>
+            <a:ext cx="3474720" cy="365760"/>
+          </a:xfrm>
+          <a:prstGeom prst="rect">
+            <a:avLst/>
+          </a:prstGeom>
+          <a:noFill/>
+        </p:spPr>
+        <p:txBody>
+          <a:bodyPr wrap="square">
+            <a:spAutoFit/>
+          </a:bodyPr>
+          <a:lstStyle/>
+          <a:p>
+            <a:pPr algn="l">
+              <a:defRPr sz="1600" b="1">
+                <a:solidFill>
+                  <a:srgbClr val="E67E22"/>
+                </a:solidFill>
+                <a:latin typeface="Calibri"/>
+              </a:defRPr>
+            </a:pPr>
+            <a:r>
+              <a:t>Phase 3 Deliverables</a:t>
+            </a:r>
+          </a:p>
+        </p:txBody>
+      </p:sp>
+      <p:sp>
+        <p:nvSpPr>
+          <p:cNvPr id="15" name="TextBox 14"/>
+          <p:cNvSpPr txBox="1"/>
+          <p:nvPr/>
+        </p:nvSpPr>
+        <p:spPr>
+          <a:xfrm>
+            <a:off x="8412480" y="4754880"/>
+            <a:ext cx="3474720" cy="2286000"/>
+          </a:xfrm>
+          <a:prstGeom prst="rect">
+            <a:avLst/>
+          </a:prstGeom>
+          <a:noFill/>
+        </p:spPr>
+        <p:txBody>
+          <a:bodyPr wrap="square">
+            <a:spAutoFit/>
+          </a:bodyPr>
+          <a:lstStyle/>
+          <a:p>
+            <a:pPr algn="l">
+              <a:spcAft>
+                <a:spcPts val="400"/>
+              </a:spcAft>
+              <a:defRPr sz="1300" b="0">
+                <a:solidFill>
+                  <a:srgbClr val="333333"/>
+                </a:solidFill>
+                <a:latin typeface="Calibri"/>
+              </a:defRPr>
+            </a:pPr>
+            <a:r>
+              <a:t>• Digital rewards storefront</a:t>
             </a:r>
           </a:p>
           <a:p>
@@ -5801,7 +6239,55 @@
               </a:defRPr>
             </a:pPr>
             <a:r>
-              <a:t>• Complete platform go-live</a:t>
+              <a:t>• Café cashier redemption screen</a:t>
+            </a:r>
+          </a:p>
+          <a:p>
+            <a:pPr>
+              <a:spcAft>
+                <a:spcPts val="400"/>
+              </a:spcAft>
+              <a:defRPr sz="1300">
+                <a:solidFill>
+                  <a:srgbClr val="333333"/>
+                </a:solidFill>
+                <a:latin typeface="Calibri"/>
+              </a:defRPr>
+            </a:pPr>
+            <a:r>
+              <a:t>• In-person store QR code scanning</a:t>
+            </a:r>
+          </a:p>
+          <a:p>
+            <a:pPr>
+              <a:spcAft>
+                <a:spcPts val="400"/>
+              </a:spcAft>
+              <a:defRPr sz="1300">
+                <a:solidFill>
+                  <a:srgbClr val="333333"/>
+                </a:solidFill>
+                <a:latin typeface="Calibri"/>
+              </a:defRPr>
+            </a:pPr>
+            <a:r>
+              <a:t>• Gift card instant delivery</a:t>
+            </a:r>
+          </a:p>
+          <a:p>
+            <a:pPr>
+              <a:spcAft>
+                <a:spcPts val="400"/>
+              </a:spcAft>
+              <a:defRPr sz="1300">
+                <a:solidFill>
+                  <a:srgbClr val="333333"/>
+                </a:solidFill>
+                <a:latin typeface="Calibri"/>
+              </a:defRPr>
+            </a:pPr>
+            <a:r>
+              <a:t>• Inventory management &amp; fulfillment</a:t>
             </a:r>
           </a:p>
         </p:txBody>
@@ -6258,7 +6744,7 @@
               </a:defRPr>
             </a:pPr>
             <a:r>
-              <a:t>Phase 1: Nominations, Paycom, SSO, Infrastructure</a:t>
+              <a:t>Phase 1: Nominations, Voting, Paycom, Badge ID Auth, SSO</a:t>
             </a:r>
           </a:p>
         </p:txBody>
@@ -6495,7 +6981,7 @@
               </a:defRPr>
             </a:pPr>
             <a:r>
-              <a:t>Phase 2: Dashboards, Tracking, Notifications</a:t>
+              <a:t>Phase 2: Dashboards, Engagement Modules, Dark Mode, Notifications</a:t>
             </a:r>
           </a:p>
         </p:txBody>
@@ -6732,7 +7218,7 @@
               </a:defRPr>
             </a:pPr>
             <a:r>
-              <a:t>Phase 3: Marketplace, Gift Cards, Fulfillment</a:t>
+              <a:t>Phase 3: Marketplace, Café Redemption, QR Store, Gift Cards</a:t>
             </a:r>
           </a:p>
         </p:txBody>
@@ -9646,7 +10132,7 @@
           <a:p>
             <a:pPr algn="l">
               <a:spcAft>
-                <a:spcPts val="800"/>
+                <a:spcPts val="700"/>
               </a:spcAft>
               <a:defRPr sz="1400" b="0">
                 <a:solidFill>
@@ -9662,7 +10148,7 @@
           <a:p>
             <a:pPr>
               <a:spcAft>
-                <a:spcPts val="800"/>
+                <a:spcPts val="700"/>
               </a:spcAft>
               <a:defRPr sz="1400">
                 <a:solidFill>
@@ -9678,7 +10164,7 @@
           <a:p>
             <a:pPr>
               <a:spcAft>
-                <a:spcPts val="800"/>
+                <a:spcPts val="700"/>
               </a:spcAft>
               <a:defRPr sz="1400">
                 <a:solidFill>
@@ -9694,7 +10180,7 @@
           <a:p>
             <a:pPr>
               <a:spcAft>
-                <a:spcPts val="800"/>
+                <a:spcPts val="700"/>
               </a:spcAft>
               <a:defRPr sz="1400">
                 <a:solidFill>
@@ -9704,13 +10190,13 @@
               </a:defRPr>
             </a:pPr>
             <a:r>
-              <a:t>• Production platforms: SpringBoard, BrainBook, Guardian, BrainClaw</a:t>
+              <a:t>• Badge ID + PIN login for frontline staff without email</a:t>
             </a:r>
           </a:p>
           <a:p>
             <a:pPr>
               <a:spcAft>
-                <a:spcPts val="800"/>
+                <a:spcPts val="700"/>
               </a:spcAft>
               <a:defRPr sz="1400">
                 <a:solidFill>
@@ -9720,13 +10206,13 @@
               </a:defRPr>
             </a:pPr>
             <a:r>
-              <a:t>• Same tech stack (React, Supabase, Python, AWS) — proven</a:t>
+              <a:t>• Ranked-choice committee voting — matching your current process</a:t>
             </a:r>
           </a:p>
           <a:p>
             <a:pPr>
               <a:spcAft>
-                <a:spcPts val="800"/>
+                <a:spcPts val="700"/>
               </a:spcAft>
               <a:defRPr sz="1400">
                 <a:solidFill>
@@ -9736,13 +10222,13 @@
               </a:defRPr>
             </a:pPr>
             <a:r>
-              <a:t>• Mobile-first, accessible design as a core competency</a:t>
+              <a:t>• Full engagement suite: TAC RSVP, culture groups, volunteering</a:t>
             </a:r>
           </a:p>
           <a:p>
             <a:pPr>
               <a:spcAft>
-                <a:spcPts val="800"/>
+                <a:spcPts val="700"/>
               </a:spcAft>
               <a:defRPr sz="1400">
                 <a:solidFill>
@@ -9752,13 +10238,13 @@
               </a:defRPr>
             </a:pPr>
             <a:r>
-              <a:t>• All add-ons FREE — pay only AI LLM usage (pass-through)</a:t>
+              <a:t>• Café cashier screen + in-person store QR redemption</a:t>
             </a:r>
           </a:p>
           <a:p>
             <a:pPr>
               <a:spcAft>
-                <a:spcPts val="800"/>
+                <a:spcPts val="700"/>
               </a:spcAft>
               <a:defRPr sz="1400">
                 <a:solidFill>
@@ -9768,7 +10254,39 @@
               </a:defRPr>
             </a:pPr>
             <a:r>
-              <a:t>• Flexible pricing: own the code or pay-as-you-go SaaS</a:t>
+              <a:t>• Dark mode for night-shift staff at group homes</a:t>
+            </a:r>
+          </a:p>
+          <a:p>
+            <a:pPr>
+              <a:spcAft>
+                <a:spcPts val="700"/>
+              </a:spcAft>
+              <a:defRPr sz="1400">
+                <a:solidFill>
+                  <a:srgbClr val="FFFFFF"/>
+                </a:solidFill>
+                <a:latin typeface="Calibri"/>
+              </a:defRPr>
+            </a:pPr>
+            <a:r>
+              <a:t>• WCAG AAA accessibility — 7:1 contrast, screen reader tested</a:t>
+            </a:r>
+          </a:p>
+          <a:p>
+            <a:pPr>
+              <a:spcAft>
+                <a:spcPts val="700"/>
+              </a:spcAft>
+              <a:defRPr sz="1400">
+                <a:solidFill>
+                  <a:srgbClr val="FFFFFF"/>
+                </a:solidFill>
+                <a:latin typeface="Calibri"/>
+              </a:defRPr>
+            </a:pPr>
+            <a:r>
+              <a:t>• All add-ons FREE — pay only AI LLM usage (pass-through)</a:t>
             </a:r>
           </a:p>
         </p:txBody>
@@ -9891,7 +10409,7 @@
               </a:defRPr>
             </a:pPr>
             <a:r>
-              <a:t>• Configure Google Workspace SSO</a:t>
+              <a:t>• Configure Google Workspace SSO + Badge ID mapping</a:t>
             </a:r>
           </a:p>
           <a:p>
@@ -10278,7 +10796,7 @@
               </a:defRPr>
             </a:pPr>
             <a:r>
-              <a:t>5.  Key Features Deep Dive</a:t>
+              <a:t>5.  Nominations, Voting &amp; QA Engine</a:t>
             </a:r>
           </a:p>
           <a:p>
@@ -10294,7 +10812,7 @@
               </a:defRPr>
             </a:pPr>
             <a:r>
-              <a:t>6.  Paycom Integration &amp; SSO</a:t>
+              <a:t>6.  Points, Engagement &amp; Community Modules</a:t>
             </a:r>
           </a:p>
           <a:p>
@@ -10310,7 +10828,7 @@
               </a:defRPr>
             </a:pPr>
             <a:r>
-              <a:t>7.  Accessibility &amp; Mobile-First Design</a:t>
+              <a:t>7.  Rewards Marketplace — Digital, Café &amp; In-Person Store</a:t>
             </a:r>
           </a:p>
           <a:p>
@@ -10326,7 +10844,7 @@
               </a:defRPr>
             </a:pPr>
             <a:r>
-              <a:t>8.  Phased Implementation Timeline</a:t>
+              <a:t>8.  Paycom Integration &amp; Authentication (SSO + Badge ID)</a:t>
             </a:r>
           </a:p>
           <a:p>
@@ -10342,7 +10860,7 @@
               </a:defRPr>
             </a:pPr>
             <a:r>
-              <a:t>9.  Pricing Options</a:t>
+              <a:t>9.  Accessibility, Dark Mode &amp; Mobile-First Design</a:t>
             </a:r>
           </a:p>
           <a:p>
@@ -10358,7 +10876,55 @@
               </a:defRPr>
             </a:pPr>
             <a:r>
-              <a:t>10. Why IoTeye — Next Steps</a:t>
+              <a:t>10. Dashboards — Employee &amp; Leadership</a:t>
+            </a:r>
+          </a:p>
+          <a:p>
+            <a:pPr>
+              <a:spcAft>
+                <a:spcPts val="1000"/>
+              </a:spcAft>
+              <a:defRPr sz="2200">
+                <a:solidFill>
+                  <a:srgbClr val="333333"/>
+                </a:solidFill>
+                <a:latin typeface="Calibri"/>
+              </a:defRPr>
+            </a:pPr>
+            <a:r>
+              <a:t>11. Phased Implementation Timeline</a:t>
+            </a:r>
+          </a:p>
+          <a:p>
+            <a:pPr>
+              <a:spcAft>
+                <a:spcPts val="1000"/>
+              </a:spcAft>
+              <a:defRPr sz="2200">
+                <a:solidFill>
+                  <a:srgbClr val="333333"/>
+                </a:solidFill>
+                <a:latin typeface="Calibri"/>
+              </a:defRPr>
+            </a:pPr>
+            <a:r>
+              <a:t>12. Pricing Options</a:t>
+            </a:r>
+          </a:p>
+          <a:p>
+            <a:pPr>
+              <a:spcAft>
+                <a:spcPts val="1000"/>
+              </a:spcAft>
+              <a:defRPr sz="2200">
+                <a:solidFill>
+                  <a:srgbClr val="333333"/>
+                </a:solidFill>
+                <a:latin typeface="Calibri"/>
+              </a:defRPr>
+            </a:pPr>
+            <a:r>
+              <a:t>13. Why IoTeye — Next Steps</a:t>
             </a:r>
           </a:p>
         </p:txBody>
@@ -12284,7 +12850,7 @@
               </a:defRPr>
             </a:pPr>
             <a:r>
-              <a:t>• No centralized system for nominations or point tracking</a:t>
+              <a:t>• Many frontline DSPs lack company email addresses</a:t>
             </a:r>
           </a:p>
           <a:p>
@@ -12300,82 +12866,7 @@
               </a:defRPr>
             </a:pPr>
             <a:r>
-              <a:t>• No connection to Paycom HRIS for employee data</a:t>
-            </a:r>
-          </a:p>
-        </p:txBody>
-      </p:sp>
-      <p:sp>
-        <p:nvSpPr>
-          <p:cNvPr id="6" name="TextBox 5"/>
-          <p:cNvSpPr txBox="1"/>
-          <p:nvPr/>
-        </p:nvSpPr>
-        <p:spPr>
-          <a:xfrm>
-            <a:off x="6400800" y="1280160"/>
-            <a:ext cx="5029200" cy="457200"/>
-          </a:xfrm>
-          <a:prstGeom prst="rect">
-            <a:avLst/>
-          </a:prstGeom>
-          <a:noFill/>
-        </p:spPr>
-        <p:txBody>
-          <a:bodyPr wrap="square">
-            <a:spAutoFit/>
-          </a:bodyPr>
-          <a:lstStyle/>
-          <a:p>
-            <a:pPr algn="l">
-              <a:defRPr sz="2400" b="1">
-                <a:solidFill>
-                  <a:srgbClr val="2E86C1"/>
-                </a:solidFill>
-                <a:latin typeface="Calibri"/>
-              </a:defRPr>
-            </a:pPr>
-            <a:r>
-              <a:t>What You Need</a:t>
-            </a:r>
-          </a:p>
-        </p:txBody>
-      </p:sp>
-      <p:sp>
-        <p:nvSpPr>
-          <p:cNvPr id="7" name="TextBox 6"/>
-          <p:cNvSpPr txBox="1"/>
-          <p:nvPr/>
-        </p:nvSpPr>
-        <p:spPr>
-          <a:xfrm>
-            <a:off x="6400800" y="1920240"/>
-            <a:ext cx="5029200" cy="3657600"/>
-          </a:xfrm>
-          <a:prstGeom prst="rect">
-            <a:avLst/>
-          </a:prstGeom>
-          <a:noFill/>
-        </p:spPr>
-        <p:txBody>
-          <a:bodyPr wrap="square">
-            <a:spAutoFit/>
-          </a:bodyPr>
-          <a:lstStyle/>
-          <a:p>
-            <a:pPr algn="l">
-              <a:spcAft>
-                <a:spcPts val="1000"/>
-              </a:spcAft>
-              <a:defRPr sz="1600" b="0">
-                <a:solidFill>
-                  <a:srgbClr val="333333"/>
-                </a:solidFill>
-                <a:latin typeface="Calibri"/>
-              </a:defRPr>
-            </a:pPr>
-            <a:r>
-              <a:t>• Centralized, web-based recognition platform</a:t>
+              <a:t>• Selection committee uses ranked-choice voting — no digital tool</a:t>
             </a:r>
           </a:p>
           <a:p>
@@ -12391,7 +12882,7 @@
               </a:defRPr>
             </a:pPr>
             <a:r>
-              <a:t>• Program-based competition engine</a:t>
+              <a:t>• No centralized system for nominations or point tracking</a:t>
             </a:r>
           </a:p>
           <a:p>
@@ -12407,7 +12898,82 @@
               </a:defRPr>
             </a:pPr>
             <a:r>
-              <a:t>• Multi-stream point system with audit trails</a:t>
+              <a:t>• No connection to Paycom HRIS for employee data</a:t>
+            </a:r>
+          </a:p>
+        </p:txBody>
+      </p:sp>
+      <p:sp>
+        <p:nvSpPr>
+          <p:cNvPr id="6" name="TextBox 5"/>
+          <p:cNvSpPr txBox="1"/>
+          <p:nvPr/>
+        </p:nvSpPr>
+        <p:spPr>
+          <a:xfrm>
+            <a:off x="6400800" y="1280160"/>
+            <a:ext cx="5029200" cy="457200"/>
+          </a:xfrm>
+          <a:prstGeom prst="rect">
+            <a:avLst/>
+          </a:prstGeom>
+          <a:noFill/>
+        </p:spPr>
+        <p:txBody>
+          <a:bodyPr wrap="square">
+            <a:spAutoFit/>
+          </a:bodyPr>
+          <a:lstStyle/>
+          <a:p>
+            <a:pPr algn="l">
+              <a:defRPr sz="2400" b="1">
+                <a:solidFill>
+                  <a:srgbClr val="2E86C1"/>
+                </a:solidFill>
+                <a:latin typeface="Calibri"/>
+              </a:defRPr>
+            </a:pPr>
+            <a:r>
+              <a:t>What You Need</a:t>
+            </a:r>
+          </a:p>
+        </p:txBody>
+      </p:sp>
+      <p:sp>
+        <p:nvSpPr>
+          <p:cNvPr id="7" name="TextBox 6"/>
+          <p:cNvSpPr txBox="1"/>
+          <p:nvPr/>
+        </p:nvSpPr>
+        <p:spPr>
+          <a:xfrm>
+            <a:off x="6400800" y="1920240"/>
+            <a:ext cx="5029200" cy="3657600"/>
+          </a:xfrm>
+          <a:prstGeom prst="rect">
+            <a:avLst/>
+          </a:prstGeom>
+          <a:noFill/>
+        </p:spPr>
+        <p:txBody>
+          <a:bodyPr wrap="square">
+            <a:spAutoFit/>
+          </a:bodyPr>
+          <a:lstStyle/>
+          <a:p>
+            <a:pPr algn="l">
+              <a:spcAft>
+                <a:spcPts val="1000"/>
+              </a:spcAft>
+              <a:defRPr sz="1600" b="0">
+                <a:solidFill>
+                  <a:srgbClr val="333333"/>
+                </a:solidFill>
+                <a:latin typeface="Calibri"/>
+              </a:defRPr>
+            </a:pPr>
+            <a:r>
+              <a:t>• Centralized, web-based recognition platform</a:t>
             </a:r>
           </a:p>
           <a:p>
@@ -12423,7 +12989,7 @@
               </a:defRPr>
             </a:pPr>
             <a:r>
-              <a:t>• Rewards marketplace for merchandise &amp; gift cards</a:t>
+              <a:t>• Program-based competition engine with committee voting</a:t>
             </a:r>
           </a:p>
           <a:p>
@@ -12439,7 +13005,7 @@
               </a:defRPr>
             </a:pPr>
             <a:r>
-              <a:t>• Paycom integration &amp; SSO</a:t>
+              <a:t>• Multi-stream point system with audit trails</a:t>
             </a:r>
           </a:p>
           <a:p>
@@ -12455,7 +13021,55 @@
               </a:defRPr>
             </a:pPr>
             <a:r>
-              <a:t>• Mobile-first, accessible to all staff</a:t>
+              <a:t>• Rewards marketplace — digital, café, and in-person store</a:t>
+            </a:r>
+          </a:p>
+          <a:p>
+            <a:pPr>
+              <a:spcAft>
+                <a:spcPts val="1000"/>
+              </a:spcAft>
+              <a:defRPr sz="1600">
+                <a:solidFill>
+                  <a:srgbClr val="333333"/>
+                </a:solidFill>
+                <a:latin typeface="Calibri"/>
+              </a:defRPr>
+            </a:pPr>
+            <a:r>
+              <a:t>• Paycom integration &amp; flexible auth (SSO + Badge ID + PIN)</a:t>
+            </a:r>
+          </a:p>
+          <a:p>
+            <a:pPr>
+              <a:spcAft>
+                <a:spcPts val="1000"/>
+              </a:spcAft>
+              <a:defRPr sz="1600">
+                <a:solidFill>
+                  <a:srgbClr val="333333"/>
+                </a:solidFill>
+                <a:latin typeface="Calibri"/>
+              </a:defRPr>
+            </a:pPr>
+            <a:r>
+              <a:t>• Community engagement: TAC, culture groups, volunteering</a:t>
+            </a:r>
+          </a:p>
+          <a:p>
+            <a:pPr>
+              <a:spcAft>
+                <a:spcPts val="1000"/>
+              </a:spcAft>
+              <a:defRPr sz="1600">
+                <a:solidFill>
+                  <a:srgbClr val="333333"/>
+                </a:solidFill>
+                <a:latin typeface="Calibri"/>
+              </a:defRPr>
+            </a:pPr>
+            <a:r>
+              <a:t>• Mobile-first, accessible to all staff (incl. dark mode)</a:t>
             </a:r>
           </a:p>
         </p:txBody>
@@ -13197,7 +13811,7 @@
               </a:defRPr>
             </a:pPr>
             <a:r>
-              <a:t>Program-Based Competition Engine</a:t>
+              <a:t>Nominations, Voting &amp; QA Engine</a:t>
             </a:r>
           </a:p>
         </p:txBody>
@@ -13247,7 +13861,7 @@
         <p:spPr>
           <a:xfrm>
             <a:off x="365760" y="1691640"/>
-            <a:ext cx="5029200" cy="2011680"/>
+            <a:ext cx="5029200" cy="1463040"/>
           </a:xfrm>
           <a:prstGeom prst="rect">
             <a:avLst/>
@@ -13262,7 +13876,7 @@
           <a:p>
             <a:pPr algn="l">
               <a:spcAft>
-                <a:spcPts val="800"/>
+                <a:spcPts val="600"/>
               </a:spcAft>
               <a:defRPr sz="1400" b="0">
                 <a:solidFill>
@@ -13278,7 +13892,7 @@
           <a:p>
             <a:pPr>
               <a:spcAft>
-                <a:spcPts val="800"/>
+                <a:spcPts val="600"/>
               </a:spcAft>
               <a:defRPr sz="1400">
                 <a:solidFill>
@@ -13294,7 +13908,7 @@
           <a:p>
             <a:pPr>
               <a:spcAft>
-                <a:spcPts val="800"/>
+                <a:spcPts val="600"/>
               </a:spcAft>
               <a:defRPr sz="1400">
                 <a:solidFill>
@@ -13307,10 +13921,85 @@
               <a:t>• 1 nomination per candidate/month, 5 total/month</a:t>
             </a:r>
           </a:p>
+        </p:txBody>
+      </p:sp>
+      <p:sp>
+        <p:nvSpPr>
+          <p:cNvPr id="6" name="TextBox 5"/>
+          <p:cNvSpPr txBox="1"/>
+          <p:nvPr/>
+        </p:nvSpPr>
+        <p:spPr>
+          <a:xfrm>
+            <a:off x="365760" y="3108960"/>
+            <a:ext cx="5029200" cy="411480"/>
+          </a:xfrm>
+          <a:prstGeom prst="rect">
+            <a:avLst/>
+          </a:prstGeom>
+          <a:noFill/>
+        </p:spPr>
+        <p:txBody>
+          <a:bodyPr wrap="square">
+            <a:spAutoFit/>
+          </a:bodyPr>
+          <a:lstStyle/>
+          <a:p>
+            <a:pPr algn="l">
+              <a:defRPr sz="2200" b="1">
+                <a:solidFill>
+                  <a:srgbClr val="2E86C1"/>
+                </a:solidFill>
+                <a:latin typeface="Calibri"/>
+              </a:defRPr>
+            </a:pPr>
+            <a:r>
+              <a:t>Selection Committee Voting</a:t>
+            </a:r>
+          </a:p>
+        </p:txBody>
+      </p:sp>
+      <p:sp>
+        <p:nvSpPr>
+          <p:cNvPr id="7" name="TextBox 6"/>
+          <p:cNvSpPr txBox="1"/>
+          <p:nvPr/>
+        </p:nvSpPr>
+        <p:spPr>
+          <a:xfrm>
+            <a:off x="365760" y="3566160"/>
+            <a:ext cx="5029200" cy="1371600"/>
+          </a:xfrm>
+          <a:prstGeom prst="rect">
+            <a:avLst/>
+          </a:prstGeom>
+          <a:noFill/>
+        </p:spPr>
+        <p:txBody>
+          <a:bodyPr wrap="square">
+            <a:spAutoFit/>
+          </a:bodyPr>
+          <a:lstStyle/>
+          <a:p>
+            <a:pPr algn="l">
+              <a:spcAft>
+                <a:spcPts val="600"/>
+              </a:spcAft>
+              <a:defRPr sz="1400" b="0">
+                <a:solidFill>
+                  <a:srgbClr val="333333"/>
+                </a:solidFill>
+                <a:latin typeface="Calibri"/>
+              </a:defRPr>
+            </a:pPr>
+            <a:r>
+              <a:t>• Ranked-choice drag-and-drop voting interface</a:t>
+            </a:r>
+          </a:p>
           <a:p>
             <a:pPr>
               <a:spcAft>
-                <a:spcPts val="800"/>
+                <a:spcPts val="600"/>
               </a:spcAft>
               <a:defRPr sz="1400">
                 <a:solidFill>
@@ -13320,20 +14009,52 @@
               </a:defRPr>
             </a:pPr>
             <a:r>
-              <a:t>• Friendly feedback when limits reached</a:t>
-            </a:r>
-          </a:p>
-        </p:txBody>
-      </p:sp>
-      <p:sp>
-        <p:nvSpPr>
-          <p:cNvPr id="6" name="TextBox 5"/>
-          <p:cNvSpPr txBox="1"/>
-          <p:nvPr/>
-        </p:nvSpPr>
-        <p:spPr>
-          <a:xfrm>
-            <a:off x="365760" y="3749039"/>
+              <a:t>• Private ballots — not visible until window closes</a:t>
+            </a:r>
+          </a:p>
+          <a:p>
+            <a:pPr>
+              <a:spcAft>
+                <a:spcPts val="600"/>
+              </a:spcAft>
+              <a:defRPr sz="1400">
+                <a:solidFill>
+                  <a:srgbClr val="333333"/>
+                </a:solidFill>
+                <a:latin typeface="Calibri"/>
+              </a:defRPr>
+            </a:pPr>
+            <a:r>
+              <a:t>• Automated tally (Borda count / weighted rank)</a:t>
+            </a:r>
+          </a:p>
+          <a:p>
+            <a:pPr>
+              <a:spcAft>
+                <a:spcPts val="600"/>
+              </a:spcAft>
+              <a:defRPr sz="1400">
+                <a:solidFill>
+                  <a:srgbClr val="333333"/>
+                </a:solidFill>
+                <a:latin typeface="Calibri"/>
+              </a:defRPr>
+            </a:pPr>
+            <a:r>
+              <a:t>• Per-voter audit trail &amp; historical ballot archive</a:t>
+            </a:r>
+          </a:p>
+        </p:txBody>
+      </p:sp>
+      <p:sp>
+        <p:nvSpPr>
+          <p:cNvPr id="8" name="TextBox 7"/>
+          <p:cNvSpPr txBox="1"/>
+          <p:nvPr/>
+        </p:nvSpPr>
+        <p:spPr>
+          <a:xfrm>
+            <a:off x="365760" y="4937760"/>
             <a:ext cx="5029200" cy="411480"/>
           </a:xfrm>
           <a:prstGeom prst="rect">
@@ -13356,21 +14077,21 @@
               </a:defRPr>
             </a:pPr>
             <a:r>
-              <a:t>QA Queue &amp; Programs</a:t>
-            </a:r>
-          </a:p>
-        </p:txBody>
-      </p:sp>
-      <p:sp>
-        <p:nvSpPr>
-          <p:cNvPr id="7" name="TextBox 6"/>
-          <p:cNvSpPr txBox="1"/>
-          <p:nvPr/>
-        </p:nvSpPr>
-        <p:spPr>
-          <a:xfrm>
-            <a:off x="365760" y="4206240"/>
-            <a:ext cx="5029200" cy="2286000"/>
+              <a:t>QA Queue &amp; Revise-Resubmit</a:t>
+            </a:r>
+          </a:p>
+        </p:txBody>
+      </p:sp>
+      <p:sp>
+        <p:nvSpPr>
+          <p:cNvPr id="9" name="TextBox 8"/>
+          <p:cNvSpPr txBox="1"/>
+          <p:nvPr/>
+        </p:nvSpPr>
+        <p:spPr>
+          <a:xfrm>
+            <a:off x="365760" y="5394960"/>
+            <a:ext cx="5029200" cy="1280160"/>
           </a:xfrm>
           <a:prstGeom prst="rect">
             <a:avLst/>
@@ -13385,7 +14106,7 @@
           <a:p>
             <a:pPr algn="l">
               <a:spcAft>
-                <a:spcPts val="800"/>
+                <a:spcPts val="600"/>
               </a:spcAft>
               <a:defRPr sz="1400" b="0">
                 <a:solidFill>
@@ -13395,13 +14116,13 @@
               </a:defRPr>
             </a:pPr>
             <a:r>
-              <a:t>• Approve / Return for Edits / Decline</a:t>
+              <a:t>• Approve / Return for Edits / Decline with batch operations</a:t>
             </a:r>
           </a:p>
           <a:p>
             <a:pPr>
               <a:spcAft>
-                <a:spcPts val="800"/>
+                <a:spcPts val="600"/>
               </a:spcAft>
               <a:defRPr sz="1400">
                 <a:solidFill>
@@ -13411,13 +14132,13 @@
               </a:defRPr>
             </a:pPr>
             <a:r>
-              <a:t>• Points awarded only upon admin approval</a:t>
+              <a:t>• Formal resubmission loop: status tracking through full cycle</a:t>
             </a:r>
           </a:p>
           <a:p>
             <a:pPr>
               <a:spcAft>
-                <a:spcPts val="800"/>
+                <a:spcPts val="600"/>
               </a:spcAft>
               <a:defRPr sz="1400">
                 <a:solidFill>
@@ -13427,30 +14148,14 @@
               </a:defRPr>
             </a:pPr>
             <a:r>
-              <a:t>• Filter by program, award type, date, status</a:t>
-            </a:r>
-          </a:p>
-          <a:p>
-            <a:pPr>
-              <a:spcAft>
-                <a:spcPts val="800"/>
-              </a:spcAft>
-              <a:defRPr sz="1400">
-                <a:solidFill>
-                  <a:srgbClr val="333333"/>
-                </a:solidFill>
-                <a:latin typeface="Calibri"/>
-              </a:defRPr>
-            </a:pPr>
-            <a:r>
-              <a:t>• Programs synced from Paycom automatically</a:t>
+              <a:t>• Admin comments → nominator notification → edit &amp; resubmit</a:t>
             </a:r>
           </a:p>
         </p:txBody>
       </p:sp>
       <p:pic>
         <p:nvPicPr>
-          <p:cNvPr id="8" name="Picture 7" descr="reward_2.png"/>
+          <p:cNvPr id="10" name="Picture 9" descr="reward_2.png"/>
           <p:cNvPicPr>
             <a:picLocks noChangeAspect="1"/>
           </p:cNvPicPr>
@@ -13572,7 +14277,7 @@
               </a:defRPr>
             </a:pPr>
             <a:r>
-              <a:t>Point Allocation &amp; Engagement Tracking</a:t>
+              <a:t>Points, Engagement &amp; Community Modules</a:t>
             </a:r>
           </a:p>
         </p:txBody>
@@ -13622,7 +14327,7 @@
         <p:spPr>
           <a:xfrm>
             <a:off x="731520" y="1828800"/>
-            <a:ext cx="6400800" cy="411480"/>
+            <a:ext cx="6400800" cy="347472"/>
           </a:xfrm>
           <a:prstGeom prst="rect">
             <a:avLst/>
@@ -13664,22 +14369,22 @@
         </p:nvSpPr>
         <p:spPr>
           <a:xfrm>
-            <a:off x="822960" y="1847088"/>
-            <a:ext cx="4114800" cy="365760"/>
-          </a:xfrm>
-          <a:prstGeom prst="rect">
-            <a:avLst/>
-          </a:prstGeom>
-          <a:noFill/>
-        </p:spPr>
-        <p:txBody>
-          <a:bodyPr wrap="square">
-            <a:spAutoFit/>
-          </a:bodyPr>
-          <a:lstStyle/>
-          <a:p>
-            <a:pPr algn="l">
-              <a:defRPr sz="1300" b="1">
+            <a:off x="822960" y="1837944"/>
+            <a:ext cx="4114800" cy="320040"/>
+          </a:xfrm>
+          <a:prstGeom prst="rect">
+            <a:avLst/>
+          </a:prstGeom>
+          <a:noFill/>
+        </p:spPr>
+        <p:txBody>
+          <a:bodyPr wrap="square">
+            <a:spAutoFit/>
+          </a:bodyPr>
+          <a:lstStyle/>
+          <a:p>
+            <a:pPr algn="l">
+              <a:defRPr sz="1200" b="1">
                 <a:solidFill>
                   <a:srgbClr val="FFFFFF"/>
                 </a:solidFill>
@@ -13700,22 +14405,22 @@
         </p:nvSpPr>
         <p:spPr>
           <a:xfrm>
-            <a:off x="5029200" y="1847088"/>
-            <a:ext cx="2011680" cy="365760"/>
-          </a:xfrm>
-          <a:prstGeom prst="rect">
-            <a:avLst/>
-          </a:prstGeom>
-          <a:noFill/>
-        </p:spPr>
-        <p:txBody>
-          <a:bodyPr wrap="square">
-            <a:spAutoFit/>
-          </a:bodyPr>
-          <a:lstStyle/>
-          <a:p>
-            <a:pPr algn="l">
-              <a:defRPr sz="1300" b="1">
+            <a:off x="5029200" y="1837944"/>
+            <a:ext cx="2011680" cy="320040"/>
+          </a:xfrm>
+          <a:prstGeom prst="rect">
+            <a:avLst/>
+          </a:prstGeom>
+          <a:noFill/>
+        </p:spPr>
+        <p:txBody>
+          <a:bodyPr wrap="square">
+            <a:spAutoFit/>
+          </a:bodyPr>
+          <a:lstStyle/>
+          <a:p>
+            <a:pPr algn="l">
+              <a:defRPr sz="1200" b="1">
                 <a:solidFill>
                   <a:srgbClr val="FFFFFF"/>
                 </a:solidFill>
@@ -13736,8 +14441,8 @@
         </p:nvSpPr>
         <p:spPr>
           <a:xfrm>
-            <a:off x="731520" y="2240280"/>
-            <a:ext cx="6400800" cy="411480"/>
+            <a:off x="731520" y="2176272"/>
+            <a:ext cx="6400800" cy="347472"/>
           </a:xfrm>
           <a:prstGeom prst="rect">
             <a:avLst/>
@@ -13779,22 +14484,22 @@
         </p:nvSpPr>
         <p:spPr>
           <a:xfrm>
-            <a:off x="822960" y="2258568"/>
-            <a:ext cx="4114800" cy="365760"/>
-          </a:xfrm>
-          <a:prstGeom prst="rect">
-            <a:avLst/>
-          </a:prstGeom>
-          <a:noFill/>
-        </p:spPr>
-        <p:txBody>
-          <a:bodyPr wrap="square">
-            <a:spAutoFit/>
-          </a:bodyPr>
-          <a:lstStyle/>
-          <a:p>
-            <a:pPr algn="l">
-              <a:defRPr sz="1300" b="0">
+            <a:off x="822960" y="2185416"/>
+            <a:ext cx="4114800" cy="320040"/>
+          </a:xfrm>
+          <a:prstGeom prst="rect">
+            <a:avLst/>
+          </a:prstGeom>
+          <a:noFill/>
+        </p:spPr>
+        <p:txBody>
+          <a:bodyPr wrap="square">
+            <a:spAutoFit/>
+          </a:bodyPr>
+          <a:lstStyle/>
+          <a:p>
+            <a:pPr algn="l">
+              <a:defRPr sz="1200" b="0">
                 <a:solidFill>
                   <a:srgbClr val="333333"/>
                 </a:solidFill>
@@ -13815,22 +14520,22 @@
         </p:nvSpPr>
         <p:spPr>
           <a:xfrm>
-            <a:off x="5029200" y="2258568"/>
-            <a:ext cx="2011680" cy="365760"/>
-          </a:xfrm>
-          <a:prstGeom prst="rect">
-            <a:avLst/>
-          </a:prstGeom>
-          <a:noFill/>
-        </p:spPr>
-        <p:txBody>
-          <a:bodyPr wrap="square">
-            <a:spAutoFit/>
-          </a:bodyPr>
-          <a:lstStyle/>
-          <a:p>
-            <a:pPr algn="l">
-              <a:defRPr sz="1300" b="0">
+            <a:off x="5029200" y="2185416"/>
+            <a:ext cx="2011680" cy="320040"/>
+          </a:xfrm>
+          <a:prstGeom prst="rect">
+            <a:avLst/>
+          </a:prstGeom>
+          <a:noFill/>
+        </p:spPr>
+        <p:txBody>
+          <a:bodyPr wrap="square">
+            <a:spAutoFit/>
+          </a:bodyPr>
+          <a:lstStyle/>
+          <a:p>
+            <a:pPr algn="l">
+              <a:defRPr sz="1200" b="0">
                 <a:solidFill>
                   <a:srgbClr val="333333"/>
                 </a:solidFill>
@@ -13851,8 +14556,8 @@
         </p:nvSpPr>
         <p:spPr>
           <a:xfrm>
-            <a:off x="731520" y="2651760"/>
-            <a:ext cx="6400800" cy="411480"/>
+            <a:off x="731520" y="2523744"/>
+            <a:ext cx="6400800" cy="347472"/>
           </a:xfrm>
           <a:prstGeom prst="rect">
             <a:avLst/>
@@ -13894,22 +14599,22 @@
         </p:nvSpPr>
         <p:spPr>
           <a:xfrm>
-            <a:off x="822960" y="2670048"/>
-            <a:ext cx="4114800" cy="365760"/>
-          </a:xfrm>
-          <a:prstGeom prst="rect">
-            <a:avLst/>
-          </a:prstGeom>
-          <a:noFill/>
-        </p:spPr>
-        <p:txBody>
-          <a:bodyPr wrap="square">
-            <a:spAutoFit/>
-          </a:bodyPr>
-          <a:lstStyle/>
-          <a:p>
-            <a:pPr algn="l">
-              <a:defRPr sz="1300" b="0">
+            <a:off x="822960" y="2532888"/>
+            <a:ext cx="4114800" cy="320040"/>
+          </a:xfrm>
+          <a:prstGeom prst="rect">
+            <a:avLst/>
+          </a:prstGeom>
+          <a:noFill/>
+        </p:spPr>
+        <p:txBody>
+          <a:bodyPr wrap="square">
+            <a:spAutoFit/>
+          </a:bodyPr>
+          <a:lstStyle/>
+          <a:p>
+            <a:pPr algn="l">
+              <a:defRPr sz="1200" b="0">
                 <a:solidFill>
                   <a:srgbClr val="333333"/>
                 </a:solidFill>
@@ -13930,22 +14635,22 @@
         </p:nvSpPr>
         <p:spPr>
           <a:xfrm>
-            <a:off x="5029200" y="2670048"/>
-            <a:ext cx="2011680" cy="365760"/>
-          </a:xfrm>
-          <a:prstGeom prst="rect">
-            <a:avLst/>
-          </a:prstGeom>
-          <a:noFill/>
-        </p:spPr>
-        <p:txBody>
-          <a:bodyPr wrap="square">
-            <a:spAutoFit/>
-          </a:bodyPr>
-          <a:lstStyle/>
-          <a:p>
-            <a:pPr algn="l">
-              <a:defRPr sz="1300" b="0">
+            <a:off x="5029200" y="2532888"/>
+            <a:ext cx="2011680" cy="320040"/>
+          </a:xfrm>
+          <a:prstGeom prst="rect">
+            <a:avLst/>
+          </a:prstGeom>
+          <a:noFill/>
+        </p:spPr>
+        <p:txBody>
+          <a:bodyPr wrap="square">
+            <a:spAutoFit/>
+          </a:bodyPr>
+          <a:lstStyle/>
+          <a:p>
+            <a:pPr algn="l">
+              <a:defRPr sz="1200" b="0">
                 <a:solidFill>
                   <a:srgbClr val="333333"/>
                 </a:solidFill>
@@ -13966,8 +14671,8 @@
         </p:nvSpPr>
         <p:spPr>
           <a:xfrm>
-            <a:off x="731520" y="3063240"/>
-            <a:ext cx="6400800" cy="411480"/>
+            <a:off x="731520" y="2871216"/>
+            <a:ext cx="6400800" cy="347472"/>
           </a:xfrm>
           <a:prstGeom prst="rect">
             <a:avLst/>
@@ -14009,30 +14714,30 @@
         </p:nvSpPr>
         <p:spPr>
           <a:xfrm>
-            <a:off x="822960" y="3081528"/>
-            <a:ext cx="4114800" cy="365760"/>
-          </a:xfrm>
-          <a:prstGeom prst="rect">
-            <a:avLst/>
-          </a:prstGeom>
-          <a:noFill/>
-        </p:spPr>
-        <p:txBody>
-          <a:bodyPr wrap="square">
-            <a:spAutoFit/>
-          </a:bodyPr>
-          <a:lstStyle/>
-          <a:p>
-            <a:pPr algn="l">
-              <a:defRPr sz="1300" b="0">
-                <a:solidFill>
-                  <a:srgbClr val="333333"/>
-                </a:solidFill>
-                <a:latin typeface="Calibri"/>
-              </a:defRPr>
-            </a:pPr>
-            <a:r>
-              <a:t>Newsletter Trivia</a:t>
+            <a:off x="822960" y="2880360"/>
+            <a:ext cx="4114800" cy="320040"/>
+          </a:xfrm>
+          <a:prstGeom prst="rect">
+            <a:avLst/>
+          </a:prstGeom>
+          <a:noFill/>
+        </p:spPr>
+        <p:txBody>
+          <a:bodyPr wrap="square">
+            <a:spAutoFit/>
+          </a:bodyPr>
+          <a:lstStyle/>
+          <a:p>
+            <a:pPr algn="l">
+              <a:defRPr sz="1200" b="0">
+                <a:solidFill>
+                  <a:srgbClr val="333333"/>
+                </a:solidFill>
+                <a:latin typeface="Calibri"/>
+              </a:defRPr>
+            </a:pPr>
+            <a:r>
+              <a:t>TAC Meeting Role Completion</a:t>
             </a:r>
           </a:p>
         </p:txBody>
@@ -14045,30 +14750,30 @@
         </p:nvSpPr>
         <p:spPr>
           <a:xfrm>
-            <a:off x="5029200" y="3081528"/>
-            <a:ext cx="2011680" cy="365760"/>
-          </a:xfrm>
-          <a:prstGeom prst="rect">
-            <a:avLst/>
-          </a:prstGeom>
-          <a:noFill/>
-        </p:spPr>
-        <p:txBody>
-          <a:bodyPr wrap="square">
-            <a:spAutoFit/>
-          </a:bodyPr>
-          <a:lstStyle/>
-          <a:p>
-            <a:pPr algn="l">
-              <a:defRPr sz="1300" b="0">
-                <a:solidFill>
-                  <a:srgbClr val="333333"/>
-                </a:solidFill>
-                <a:latin typeface="Calibri"/>
-              </a:defRPr>
-            </a:pPr>
-            <a:r>
-              <a:t>Correct answer</a:t>
+            <a:off x="5029200" y="2880360"/>
+            <a:ext cx="2011680" cy="320040"/>
+          </a:xfrm>
+          <a:prstGeom prst="rect">
+            <a:avLst/>
+          </a:prstGeom>
+          <a:noFill/>
+        </p:spPr>
+        <p:txBody>
+          <a:bodyPr wrap="square">
+            <a:spAutoFit/>
+          </a:bodyPr>
+          <a:lstStyle/>
+          <a:p>
+            <a:pPr algn="l">
+              <a:defRPr sz="1200" b="0">
+                <a:solidFill>
+                  <a:srgbClr val="333333"/>
+                </a:solidFill>
+                <a:latin typeface="Calibri"/>
+              </a:defRPr>
+            </a:pPr>
+            <a:r>
+              <a:t>Role fulfilled</a:t>
             </a:r>
           </a:p>
         </p:txBody>
@@ -14081,8 +14786,8 @@
         </p:nvSpPr>
         <p:spPr>
           <a:xfrm>
-            <a:off x="731520" y="3474720"/>
-            <a:ext cx="6400800" cy="411480"/>
+            <a:off x="731520" y="3218688"/>
+            <a:ext cx="6400800" cy="347472"/>
           </a:xfrm>
           <a:prstGeom prst="rect">
             <a:avLst/>
@@ -14124,30 +14829,30 @@
         </p:nvSpPr>
         <p:spPr>
           <a:xfrm>
-            <a:off x="822960" y="3493008"/>
-            <a:ext cx="4114800" cy="365760"/>
-          </a:xfrm>
-          <a:prstGeom prst="rect">
-            <a:avLst/>
-          </a:prstGeom>
-          <a:noFill/>
-        </p:spPr>
-        <p:txBody>
-          <a:bodyPr wrap="square">
-            <a:spAutoFit/>
-          </a:bodyPr>
-          <a:lstStyle/>
-          <a:p>
-            <a:pPr algn="l">
-              <a:defRPr sz="1300" b="0">
-                <a:solidFill>
-                  <a:srgbClr val="333333"/>
-                </a:solidFill>
-                <a:latin typeface="Calibri"/>
-              </a:defRPr>
-            </a:pPr>
-            <a:r>
-              <a:t>Birthday / Anniversary</a:t>
+            <a:off x="822960" y="3227832"/>
+            <a:ext cx="4114800" cy="320040"/>
+          </a:xfrm>
+          <a:prstGeom prst="rect">
+            <a:avLst/>
+          </a:prstGeom>
+          <a:noFill/>
+        </p:spPr>
+        <p:txBody>
+          <a:bodyPr wrap="square">
+            <a:spAutoFit/>
+          </a:bodyPr>
+          <a:lstStyle/>
+          <a:p>
+            <a:pPr algn="l">
+              <a:defRPr sz="1200" b="0">
+                <a:solidFill>
+                  <a:srgbClr val="333333"/>
+                </a:solidFill>
+                <a:latin typeface="Calibri"/>
+              </a:defRPr>
+            </a:pPr>
+            <a:r>
+              <a:t>Culture Group Participation</a:t>
             </a:r>
           </a:p>
         </p:txBody>
@@ -14160,30 +14865,30 @@
         </p:nvSpPr>
         <p:spPr>
           <a:xfrm>
-            <a:off x="5029200" y="3493008"/>
-            <a:ext cx="2011680" cy="365760"/>
-          </a:xfrm>
-          <a:prstGeom prst="rect">
-            <a:avLst/>
-          </a:prstGeom>
-          <a:noFill/>
-        </p:spPr>
-        <p:txBody>
-          <a:bodyPr wrap="square">
-            <a:spAutoFit/>
-          </a:bodyPr>
-          <a:lstStyle/>
-          <a:p>
-            <a:pPr algn="l">
-              <a:defRPr sz="1300" b="0">
-                <a:solidFill>
-                  <a:srgbClr val="333333"/>
-                </a:solidFill>
-                <a:latin typeface="Calibri"/>
-              </a:defRPr>
-            </a:pPr>
-            <a:r>
-              <a:t>Automated (Paycom sync)</a:t>
+            <a:off x="5029200" y="3227832"/>
+            <a:ext cx="2011680" cy="320040"/>
+          </a:xfrm>
+          <a:prstGeom prst="rect">
+            <a:avLst/>
+          </a:prstGeom>
+          <a:noFill/>
+        </p:spPr>
+        <p:txBody>
+          <a:bodyPr wrap="square">
+            <a:spAutoFit/>
+          </a:bodyPr>
+          <a:lstStyle/>
+          <a:p>
+            <a:pPr algn="l">
+              <a:defRPr sz="1200" b="0">
+                <a:solidFill>
+                  <a:srgbClr val="333333"/>
+                </a:solidFill>
+                <a:latin typeface="Calibri"/>
+              </a:defRPr>
+            </a:pPr>
+            <a:r>
+              <a:t>Leader/admin log</a:t>
             </a:r>
           </a:p>
         </p:txBody>
@@ -14196,8 +14901,8 @@
         </p:nvSpPr>
         <p:spPr>
           <a:xfrm>
-            <a:off x="731520" y="3886200"/>
-            <a:ext cx="6400800" cy="411480"/>
+            <a:off x="731520" y="3566160"/>
+            <a:ext cx="6400800" cy="347472"/>
           </a:xfrm>
           <a:prstGeom prst="rect">
             <a:avLst/>
@@ -14239,22 +14944,482 @@
         </p:nvSpPr>
         <p:spPr>
           <a:xfrm>
-            <a:off x="822960" y="3904488"/>
-            <a:ext cx="4114800" cy="365760"/>
-          </a:xfrm>
-          <a:prstGeom prst="rect">
-            <a:avLst/>
-          </a:prstGeom>
-          <a:noFill/>
-        </p:spPr>
-        <p:txBody>
-          <a:bodyPr wrap="square">
-            <a:spAutoFit/>
-          </a:bodyPr>
-          <a:lstStyle/>
-          <a:p>
-            <a:pPr algn="l">
-              <a:defRPr sz="1300" b="0">
+            <a:off x="822960" y="3575304"/>
+            <a:ext cx="4114800" cy="320040"/>
+          </a:xfrm>
+          <a:prstGeom prst="rect">
+            <a:avLst/>
+          </a:prstGeom>
+          <a:noFill/>
+        </p:spPr>
+        <p:txBody>
+          <a:bodyPr wrap="square">
+            <a:spAutoFit/>
+          </a:bodyPr>
+          <a:lstStyle/>
+          <a:p>
+            <a:pPr algn="l">
+              <a:defRPr sz="1200" b="0">
+                <a:solidFill>
+                  <a:srgbClr val="333333"/>
+                </a:solidFill>
+                <a:latin typeface="Calibri"/>
+              </a:defRPr>
+            </a:pPr>
+            <a:r>
+              <a:t>Volunteer / Event Help</a:t>
+            </a:r>
+          </a:p>
+        </p:txBody>
+      </p:sp>
+      <p:sp>
+        <p:nvSpPr>
+          <p:cNvPr id="22" name="TextBox 21"/>
+          <p:cNvSpPr txBox="1"/>
+          <p:nvPr/>
+        </p:nvSpPr>
+        <p:spPr>
+          <a:xfrm>
+            <a:off x="5029200" y="3575304"/>
+            <a:ext cx="2011680" cy="320040"/>
+          </a:xfrm>
+          <a:prstGeom prst="rect">
+            <a:avLst/>
+          </a:prstGeom>
+          <a:noFill/>
+        </p:spPr>
+        <p:txBody>
+          <a:bodyPr wrap="square">
+            <a:spAutoFit/>
+          </a:bodyPr>
+          <a:lstStyle/>
+          <a:p>
+            <a:pPr algn="l">
+              <a:defRPr sz="1200" b="0">
+                <a:solidFill>
+                  <a:srgbClr val="333333"/>
+                </a:solidFill>
+                <a:latin typeface="Calibri"/>
+              </a:defRPr>
+            </a:pPr>
+            <a:r>
+              <a:t>Post-event confirmation</a:t>
+            </a:r>
+          </a:p>
+        </p:txBody>
+      </p:sp>
+      <p:sp>
+        <p:nvSpPr>
+          <p:cNvPr id="23" name="Rectangle 22"/>
+          <p:cNvSpPr/>
+          <p:nvPr/>
+        </p:nvSpPr>
+        <p:spPr>
+          <a:xfrm>
+            <a:off x="731520" y="3913632"/>
+            <a:ext cx="6400800" cy="347472"/>
+          </a:xfrm>
+          <a:prstGeom prst="rect">
+            <a:avLst/>
+          </a:prstGeom>
+          <a:solidFill>
+            <a:srgbClr val="F2F2F2"/>
+          </a:solidFill>
+          <a:ln>
+            <a:noFill/>
+          </a:ln>
+        </p:spPr>
+        <p:style>
+          <a:lnRef idx="1">
+            <a:schemeClr val="accent1"/>
+          </a:lnRef>
+          <a:fillRef idx="3">
+            <a:schemeClr val="accent1"/>
+          </a:fillRef>
+          <a:effectRef idx="2">
+            <a:schemeClr val="accent1"/>
+          </a:effectRef>
+          <a:fontRef idx="minor">
+            <a:schemeClr val="lt1"/>
+          </a:fontRef>
+        </p:style>
+        <p:txBody>
+          <a:bodyPr rtlCol="0" anchor="ctr"/>
+          <a:lstStyle/>
+          <a:p>
+            <a:pPr algn="ctr"/>
+          </a:p>
+        </p:txBody>
+      </p:sp>
+      <p:sp>
+        <p:nvSpPr>
+          <p:cNvPr id="24" name="TextBox 23"/>
+          <p:cNvSpPr txBox="1"/>
+          <p:nvPr/>
+        </p:nvSpPr>
+        <p:spPr>
+          <a:xfrm>
+            <a:off x="822960" y="3922776"/>
+            <a:ext cx="4114800" cy="320040"/>
+          </a:xfrm>
+          <a:prstGeom prst="rect">
+            <a:avLst/>
+          </a:prstGeom>
+          <a:noFill/>
+        </p:spPr>
+        <p:txBody>
+          <a:bodyPr wrap="square">
+            <a:spAutoFit/>
+          </a:bodyPr>
+          <a:lstStyle/>
+          <a:p>
+            <a:pPr algn="l">
+              <a:defRPr sz="1200" b="0">
+                <a:solidFill>
+                  <a:srgbClr val="333333"/>
+                </a:solidFill>
+                <a:latin typeface="Calibri"/>
+              </a:defRPr>
+            </a:pPr>
+            <a:r>
+              <a:t>Social Media Engagement</a:t>
+            </a:r>
+          </a:p>
+        </p:txBody>
+      </p:sp>
+      <p:sp>
+        <p:nvSpPr>
+          <p:cNvPr id="25" name="TextBox 24"/>
+          <p:cNvSpPr txBox="1"/>
+          <p:nvPr/>
+        </p:nvSpPr>
+        <p:spPr>
+          <a:xfrm>
+            <a:off x="5029200" y="3922776"/>
+            <a:ext cx="2011680" cy="320040"/>
+          </a:xfrm>
+          <a:prstGeom prst="rect">
+            <a:avLst/>
+          </a:prstGeom>
+          <a:noFill/>
+        </p:spPr>
+        <p:txBody>
+          <a:bodyPr wrap="square">
+            <a:spAutoFit/>
+          </a:bodyPr>
+          <a:lstStyle/>
+          <a:p>
+            <a:pPr algn="l">
+              <a:defRPr sz="1200" b="0">
+                <a:solidFill>
+                  <a:srgbClr val="333333"/>
+                </a:solidFill>
+                <a:latin typeface="Calibri"/>
+              </a:defRPr>
+            </a:pPr>
+            <a:r>
+              <a:t>Screenshot review</a:t>
+            </a:r>
+          </a:p>
+        </p:txBody>
+      </p:sp>
+      <p:sp>
+        <p:nvSpPr>
+          <p:cNvPr id="26" name="Rectangle 25"/>
+          <p:cNvSpPr/>
+          <p:nvPr/>
+        </p:nvSpPr>
+        <p:spPr>
+          <a:xfrm>
+            <a:off x="731520" y="4261104"/>
+            <a:ext cx="6400800" cy="347472"/>
+          </a:xfrm>
+          <a:prstGeom prst="rect">
+            <a:avLst/>
+          </a:prstGeom>
+          <a:solidFill>
+            <a:srgbClr val="FFFFFF"/>
+          </a:solidFill>
+          <a:ln>
+            <a:noFill/>
+          </a:ln>
+        </p:spPr>
+        <p:style>
+          <a:lnRef idx="1">
+            <a:schemeClr val="accent1"/>
+          </a:lnRef>
+          <a:fillRef idx="3">
+            <a:schemeClr val="accent1"/>
+          </a:fillRef>
+          <a:effectRef idx="2">
+            <a:schemeClr val="accent1"/>
+          </a:effectRef>
+          <a:fontRef idx="minor">
+            <a:schemeClr val="lt1"/>
+          </a:fontRef>
+        </p:style>
+        <p:txBody>
+          <a:bodyPr rtlCol="0" anchor="ctr"/>
+          <a:lstStyle/>
+          <a:p>
+            <a:pPr algn="ctr"/>
+          </a:p>
+        </p:txBody>
+      </p:sp>
+      <p:sp>
+        <p:nvSpPr>
+          <p:cNvPr id="27" name="TextBox 26"/>
+          <p:cNvSpPr txBox="1"/>
+          <p:nvPr/>
+        </p:nvSpPr>
+        <p:spPr>
+          <a:xfrm>
+            <a:off x="822960" y="4270248"/>
+            <a:ext cx="4114800" cy="320040"/>
+          </a:xfrm>
+          <a:prstGeom prst="rect">
+            <a:avLst/>
+          </a:prstGeom>
+          <a:noFill/>
+        </p:spPr>
+        <p:txBody>
+          <a:bodyPr wrap="square">
+            <a:spAutoFit/>
+          </a:bodyPr>
+          <a:lstStyle/>
+          <a:p>
+            <a:pPr algn="l">
+              <a:defRPr sz="1200" b="0">
+                <a:solidFill>
+                  <a:srgbClr val="333333"/>
+                </a:solidFill>
+                <a:latin typeface="Calibri"/>
+              </a:defRPr>
+            </a:pPr>
+            <a:r>
+              <a:t>Newsletter Trivia</a:t>
+            </a:r>
+          </a:p>
+        </p:txBody>
+      </p:sp>
+      <p:sp>
+        <p:nvSpPr>
+          <p:cNvPr id="28" name="TextBox 27"/>
+          <p:cNvSpPr txBox="1"/>
+          <p:nvPr/>
+        </p:nvSpPr>
+        <p:spPr>
+          <a:xfrm>
+            <a:off x="5029200" y="4270248"/>
+            <a:ext cx="2011680" cy="320040"/>
+          </a:xfrm>
+          <a:prstGeom prst="rect">
+            <a:avLst/>
+          </a:prstGeom>
+          <a:noFill/>
+        </p:spPr>
+        <p:txBody>
+          <a:bodyPr wrap="square">
+            <a:spAutoFit/>
+          </a:bodyPr>
+          <a:lstStyle/>
+          <a:p>
+            <a:pPr algn="l">
+              <a:defRPr sz="1200" b="0">
+                <a:solidFill>
+                  <a:srgbClr val="333333"/>
+                </a:solidFill>
+                <a:latin typeface="Calibri"/>
+              </a:defRPr>
+            </a:pPr>
+            <a:r>
+              <a:t>Correct answer</a:t>
+            </a:r>
+          </a:p>
+        </p:txBody>
+      </p:sp>
+      <p:sp>
+        <p:nvSpPr>
+          <p:cNvPr id="29" name="Rectangle 28"/>
+          <p:cNvSpPr/>
+          <p:nvPr/>
+        </p:nvSpPr>
+        <p:spPr>
+          <a:xfrm>
+            <a:off x="731520" y="4608576"/>
+            <a:ext cx="6400800" cy="347472"/>
+          </a:xfrm>
+          <a:prstGeom prst="rect">
+            <a:avLst/>
+          </a:prstGeom>
+          <a:solidFill>
+            <a:srgbClr val="F2F2F2"/>
+          </a:solidFill>
+          <a:ln>
+            <a:noFill/>
+          </a:ln>
+        </p:spPr>
+        <p:style>
+          <a:lnRef idx="1">
+            <a:schemeClr val="accent1"/>
+          </a:lnRef>
+          <a:fillRef idx="3">
+            <a:schemeClr val="accent1"/>
+          </a:fillRef>
+          <a:effectRef idx="2">
+            <a:schemeClr val="accent1"/>
+          </a:effectRef>
+          <a:fontRef idx="minor">
+            <a:schemeClr val="lt1"/>
+          </a:fontRef>
+        </p:style>
+        <p:txBody>
+          <a:bodyPr rtlCol="0" anchor="ctr"/>
+          <a:lstStyle/>
+          <a:p>
+            <a:pPr algn="ctr"/>
+          </a:p>
+        </p:txBody>
+      </p:sp>
+      <p:sp>
+        <p:nvSpPr>
+          <p:cNvPr id="30" name="TextBox 29"/>
+          <p:cNvSpPr txBox="1"/>
+          <p:nvPr/>
+        </p:nvSpPr>
+        <p:spPr>
+          <a:xfrm>
+            <a:off x="822960" y="4617720"/>
+            <a:ext cx="4114800" cy="320040"/>
+          </a:xfrm>
+          <a:prstGeom prst="rect">
+            <a:avLst/>
+          </a:prstGeom>
+          <a:noFill/>
+        </p:spPr>
+        <p:txBody>
+          <a:bodyPr wrap="square">
+            <a:spAutoFit/>
+          </a:bodyPr>
+          <a:lstStyle/>
+          <a:p>
+            <a:pPr algn="l">
+              <a:defRPr sz="1200" b="0">
+                <a:solidFill>
+                  <a:srgbClr val="333333"/>
+                </a:solidFill>
+                <a:latin typeface="Calibri"/>
+              </a:defRPr>
+            </a:pPr>
+            <a:r>
+              <a:t>Birthday / Anniversary</a:t>
+            </a:r>
+          </a:p>
+        </p:txBody>
+      </p:sp>
+      <p:sp>
+        <p:nvSpPr>
+          <p:cNvPr id="31" name="TextBox 30"/>
+          <p:cNvSpPr txBox="1"/>
+          <p:nvPr/>
+        </p:nvSpPr>
+        <p:spPr>
+          <a:xfrm>
+            <a:off x="5029200" y="4617720"/>
+            <a:ext cx="2011680" cy="320040"/>
+          </a:xfrm>
+          <a:prstGeom prst="rect">
+            <a:avLst/>
+          </a:prstGeom>
+          <a:noFill/>
+        </p:spPr>
+        <p:txBody>
+          <a:bodyPr wrap="square">
+            <a:spAutoFit/>
+          </a:bodyPr>
+          <a:lstStyle/>
+          <a:p>
+            <a:pPr algn="l">
+              <a:defRPr sz="1200" b="0">
+                <a:solidFill>
+                  <a:srgbClr val="333333"/>
+                </a:solidFill>
+                <a:latin typeface="Calibri"/>
+              </a:defRPr>
+            </a:pPr>
+            <a:r>
+              <a:t>Automated (Paycom)</a:t>
+            </a:r>
+          </a:p>
+        </p:txBody>
+      </p:sp>
+      <p:sp>
+        <p:nvSpPr>
+          <p:cNvPr id="32" name="Rectangle 31"/>
+          <p:cNvSpPr/>
+          <p:nvPr/>
+        </p:nvSpPr>
+        <p:spPr>
+          <a:xfrm>
+            <a:off x="731520" y="4956048"/>
+            <a:ext cx="6400800" cy="347472"/>
+          </a:xfrm>
+          <a:prstGeom prst="rect">
+            <a:avLst/>
+          </a:prstGeom>
+          <a:solidFill>
+            <a:srgbClr val="FFFFFF"/>
+          </a:solidFill>
+          <a:ln>
+            <a:noFill/>
+          </a:ln>
+        </p:spPr>
+        <p:style>
+          <a:lnRef idx="1">
+            <a:schemeClr val="accent1"/>
+          </a:lnRef>
+          <a:fillRef idx="3">
+            <a:schemeClr val="accent1"/>
+          </a:fillRef>
+          <a:effectRef idx="2">
+            <a:schemeClr val="accent1"/>
+          </a:effectRef>
+          <a:fontRef idx="minor">
+            <a:schemeClr val="lt1"/>
+          </a:fontRef>
+        </p:style>
+        <p:txBody>
+          <a:bodyPr rtlCol="0" anchor="ctr"/>
+          <a:lstStyle/>
+          <a:p>
+            <a:pPr algn="ctr"/>
+          </a:p>
+        </p:txBody>
+      </p:sp>
+      <p:sp>
+        <p:nvSpPr>
+          <p:cNvPr id="33" name="TextBox 32"/>
+          <p:cNvSpPr txBox="1"/>
+          <p:nvPr/>
+        </p:nvSpPr>
+        <p:spPr>
+          <a:xfrm>
+            <a:off x="822960" y="4965192"/>
+            <a:ext cx="4114800" cy="320040"/>
+          </a:xfrm>
+          <a:prstGeom prst="rect">
+            <a:avLst/>
+          </a:prstGeom>
+          <a:noFill/>
+        </p:spPr>
+        <p:txBody>
+          <a:bodyPr wrap="square">
+            <a:spAutoFit/>
+          </a:bodyPr>
+          <a:lstStyle/>
+          <a:p>
+            <a:pPr algn="l">
+              <a:defRPr sz="1200" b="0">
                 <a:solidFill>
                   <a:srgbClr val="333333"/>
                 </a:solidFill>
@@ -14269,28 +15434,28 @@
       </p:sp>
       <p:sp>
         <p:nvSpPr>
-          <p:cNvPr id="22" name="TextBox 21"/>
-          <p:cNvSpPr txBox="1"/>
-          <p:nvPr/>
-        </p:nvSpPr>
-        <p:spPr>
-          <a:xfrm>
-            <a:off x="5029200" y="3904488"/>
-            <a:ext cx="2011680" cy="365760"/>
-          </a:xfrm>
-          <a:prstGeom prst="rect">
-            <a:avLst/>
-          </a:prstGeom>
-          <a:noFill/>
-        </p:spPr>
-        <p:txBody>
-          <a:bodyPr wrap="square">
-            <a:spAutoFit/>
-          </a:bodyPr>
-          <a:lstStyle/>
-          <a:p>
-            <a:pPr algn="l">
-              <a:defRPr sz="1300" b="0">
+          <p:cNvPr id="34" name="TextBox 33"/>
+          <p:cNvSpPr txBox="1"/>
+          <p:nvPr/>
+        </p:nvSpPr>
+        <p:spPr>
+          <a:xfrm>
+            <a:off x="5029200" y="4965192"/>
+            <a:ext cx="2011680" cy="320040"/>
+          </a:xfrm>
+          <a:prstGeom prst="rect">
+            <a:avLst/>
+          </a:prstGeom>
+          <a:noFill/>
+        </p:spPr>
+        <p:txBody>
+          <a:bodyPr wrap="square">
+            <a:spAutoFit/>
+          </a:bodyPr>
+          <a:lstStyle/>
+          <a:p>
+            <a:pPr algn="l">
+              <a:defRPr sz="1200" b="0">
                 <a:solidFill>
                   <a:srgbClr val="333333"/>
                 </a:solidFill>
@@ -14305,13 +15470,13 @@
       </p:sp>
       <p:sp>
         <p:nvSpPr>
-          <p:cNvPr id="23" name="TextBox 22"/>
-          <p:cNvSpPr txBox="1"/>
-          <p:nvPr/>
-        </p:nvSpPr>
-        <p:spPr>
-          <a:xfrm>
-            <a:off x="731520" y="4480560"/>
+          <p:cNvPr id="35" name="TextBox 34"/>
+          <p:cNvSpPr txBox="1"/>
+          <p:nvPr/>
+        </p:nvSpPr>
+        <p:spPr>
+          <a:xfrm>
+            <a:off x="731520" y="5440680"/>
             <a:ext cx="6400800" cy="365760"/>
           </a:xfrm>
           <a:prstGeom prst="rect">
@@ -14341,7 +15506,7 @@
       </p:sp>
       <p:sp>
         <p:nvSpPr>
-          <p:cNvPr id="24" name="TextBox 23"/>
+          <p:cNvPr id="36" name="TextBox 35"/>
           <p:cNvSpPr txBox="1"/>
           <p:nvPr/>
         </p:nvSpPr>
@@ -14370,21 +15535,21 @@
               </a:defRPr>
             </a:pPr>
             <a:r>
-              <a:t>Audit &amp; Transparency</a:t>
-            </a:r>
-          </a:p>
-        </p:txBody>
-      </p:sp>
-      <p:sp>
-        <p:nvSpPr>
-          <p:cNvPr id="25" name="TextBox 24"/>
+              <a:t>Community Engagement</a:t>
+            </a:r>
+          </a:p>
+        </p:txBody>
+      </p:sp>
+      <p:sp>
+        <p:nvSpPr>
+          <p:cNvPr id="37" name="TextBox 36"/>
           <p:cNvSpPr txBox="1"/>
           <p:nvPr/>
         </p:nvSpPr>
         <p:spPr>
           <a:xfrm>
             <a:off x="7772400" y="1828800"/>
-            <a:ext cx="4114800" cy="3657600"/>
+            <a:ext cx="4114800" cy="4572000"/>
           </a:xfrm>
           <a:prstGeom prst="rect">
             <a:avLst/>
@@ -14401,15 +15566,30 @@
               <a:spcAft>
                 <a:spcPts val="1000"/>
               </a:spcAft>
-              <a:defRPr sz="1500" b="0">
-                <a:solidFill>
-                  <a:srgbClr val="333333"/>
-                </a:solidFill>
-                <a:latin typeface="Calibri"/>
-              </a:defRPr>
-            </a:pPr>
-            <a:r>
-              <a:t>• Immutable transaction log for every point change</a:t>
+              <a:defRPr sz="1300" b="0">
+                <a:solidFill>
+                  <a:srgbClr val="333333"/>
+                </a:solidFill>
+                <a:latin typeface="Calibri"/>
+              </a:defRPr>
+            </a:pPr>
+            <a:r>
+              <a:rPr sz="1300" b="1">
+                <a:solidFill>
+                  <a:srgbClr val="333333"/>
+                </a:solidFill>
+                <a:latin typeface="Calibri"/>
+              </a:rPr>
+              <a:t>• TAC RSVP &amp; Role Sign-Ups: </a:t>
+            </a:r>
+            <a:r>
+              <a:rPr sz="1300" b="0">
+                <a:solidFill>
+                  <a:srgbClr val="333333"/>
+                </a:solidFill>
+                <a:latin typeface="Calibri"/>
+              </a:rPr>
+              <a:t>RSVP workflow, role selection (setup, check-in, cleanup), automated reminders</a:t>
             </a:r>
           </a:p>
           <a:p>
@@ -14417,15 +15597,25 @@
               <a:spcAft>
                 <a:spcPts val="1000"/>
               </a:spcAft>
-              <a:defRPr sz="1500">
-                <a:solidFill>
-                  <a:srgbClr val="333333"/>
-                </a:solidFill>
-                <a:latin typeface="Calibri"/>
-              </a:defRPr>
-            </a:pPr>
-            <a:r>
-              <a:t>• Timestamp, actor, action, amount, reason</a:t>
+              <a:defRPr sz="1300"/>
+            </a:pPr>
+            <a:r>
+              <a:rPr sz="1300" b="1">
+                <a:solidFill>
+                  <a:srgbClr val="333333"/>
+                </a:solidFill>
+                <a:latin typeface="Calibri"/>
+              </a:rPr>
+              <a:t>• Culture Groups: </a:t>
+            </a:r>
+            <a:r>
+              <a:rPr sz="1300" b="0">
+                <a:solidFill>
+                  <a:srgbClr val="333333"/>
+                </a:solidFill>
+                <a:latin typeface="Calibri"/>
+              </a:rPr>
+              <a:t>Self-service directory, one-tap sign-up, attendance tracking, participation points</a:t>
             </a:r>
           </a:p>
           <a:p>
@@ -14433,15 +15623,25 @@
               <a:spcAft>
                 <a:spcPts val="1000"/>
               </a:spcAft>
-              <a:defRPr sz="1500">
-                <a:solidFill>
-                  <a:srgbClr val="333333"/>
-                </a:solidFill>
-                <a:latin typeface="Calibri"/>
-              </a:defRPr>
-            </a:pPr>
-            <a:r>
-              <a:t>• Filterable by employee, program, date, type</a:t>
+              <a:defRPr sz="1300"/>
+            </a:pPr>
+            <a:r>
+              <a:rPr sz="1300" b="1">
+                <a:solidFill>
+                  <a:srgbClr val="333333"/>
+                </a:solidFill>
+                <a:latin typeface="Calibri"/>
+              </a:rPr>
+              <a:t>• Volunteer Forms: </a:t>
+            </a:r>
+            <a:r>
+              <a:rPr sz="1300" b="0">
+                <a:solidFill>
+                  <a:srgbClr val="333333"/>
+                </a:solidFill>
+                <a:latin typeface="Calibri"/>
+              </a:rPr>
+              <a:t>Event help board, volunteer slots, completion tracking, engagement score</a:t>
             </a:r>
           </a:p>
           <a:p>
@@ -14449,15 +15649,25 @@
               <a:spcAft>
                 <a:spcPts val="1000"/>
               </a:spcAft>
-              <a:defRPr sz="1500">
-                <a:solidFill>
-                  <a:srgbClr val="333333"/>
-                </a:solidFill>
-                <a:latin typeface="Calibri"/>
-              </a:defRPr>
-            </a:pPr>
-            <a:r>
-              <a:t>• Export to CSV for external review</a:t>
+              <a:defRPr sz="1300"/>
+            </a:pPr>
+            <a:r>
+              <a:rPr sz="1300" b="1">
+                <a:solidFill>
+                  <a:srgbClr val="333333"/>
+                </a:solidFill>
+                <a:latin typeface="Calibri"/>
+              </a:rPr>
+              <a:t>• Social Media: </a:t>
+            </a:r>
+            <a:r>
+              <a:rPr sz="1300" b="0">
+                <a:solidFill>
+                  <a:srgbClr val="333333"/>
+                </a:solidFill>
+                <a:latin typeface="Calibri"/>
+              </a:rPr>
+              <a:t>Screenshot upload, admin review queue, campaign tracking</a:t>
             </a:r>
           </a:p>
           <a:p>
@@ -14465,31 +15675,25 @@
               <a:spcAft>
                 <a:spcPts val="1000"/>
               </a:spcAft>
-              <a:defRPr sz="1500">
-                <a:solidFill>
-                  <a:srgbClr val="333333"/>
-                </a:solidFill>
-                <a:latin typeface="Calibri"/>
-              </a:defRPr>
-            </a:pPr>
-            <a:r>
-              <a:t>• Anomaly highlighting for oversight</a:t>
-            </a:r>
-          </a:p>
-          <a:p>
-            <a:pPr>
-              <a:spcAft>
-                <a:spcPts val="1000"/>
-              </a:spcAft>
-              <a:defRPr sz="1500">
-                <a:solidFill>
-                  <a:srgbClr val="333333"/>
-                </a:solidFill>
-                <a:latin typeface="Calibri"/>
-              </a:defRPr>
-            </a:pPr>
-            <a:r>
-              <a:t>• Top-down bestowal with instant notifications</a:t>
+              <a:defRPr sz="1300"/>
+            </a:pPr>
+            <a:r>
+              <a:rPr sz="1300" b="1">
+                <a:solidFill>
+                  <a:srgbClr val="333333"/>
+                </a:solidFill>
+                <a:latin typeface="Calibri"/>
+              </a:rPr>
+              <a:t>• Audit &amp; Transparency: </a:t>
+            </a:r>
+            <a:r>
+              <a:rPr sz="1300" b="0">
+                <a:solidFill>
+                  <a:srgbClr val="333333"/>
+                </a:solidFill>
+                <a:latin typeface="Calibri"/>
+              </a:rPr>
+              <a:t>Immutable transaction log, anomaly detection, CSV export</a:t>
             </a:r>
           </a:p>
         </p:txBody>

</xml_diff>

<commit_message>
Add Option C (Shared Ownership): 50% implementation fee, recognition platform code ownership, excludes BrainBook/SpringBoard/Guardian/BrainClaw
</commit_message>
<xml_diff>
--- a/RFP/IoTeye - Arc Mercer Pitch.pptx
+++ b/RFP/IoTeye - Arc Mercer Pitch.pptx
@@ -8024,57 +8024,21 @@
               </a:defRPr>
             </a:pPr>
             <a:r>
-              <a:t>Pricing — Option B: IoTeye-Hosted SaaS</a:t>
-            </a:r>
-          </a:p>
-        </p:txBody>
-      </p:sp>
-      <p:sp>
-        <p:nvSpPr>
-          <p:cNvPr id="4" name="TextBox 3"/>
-          <p:cNvSpPr txBox="1"/>
-          <p:nvPr/>
-        </p:nvSpPr>
-        <p:spPr>
-          <a:xfrm>
-            <a:off x="731520" y="1188720"/>
-            <a:ext cx="10058400" cy="457200"/>
-          </a:xfrm>
-          <a:prstGeom prst="rect">
-            <a:avLst/>
-          </a:prstGeom>
-          <a:noFill/>
-        </p:spPr>
-        <p:txBody>
-          <a:bodyPr wrap="square">
-            <a:spAutoFit/>
-          </a:bodyPr>
-          <a:lstStyle/>
-          <a:p>
-            <a:pPr algn="l">
-              <a:defRPr sz="1800" b="1">
-                <a:solidFill>
-                  <a:srgbClr val="27AE60"/>
-                </a:solidFill>
-                <a:latin typeface="Calibri"/>
-              </a:defRPr>
-            </a:pPr>
-            <a:r>
-              <a:t>No upfront cost — IoTeye retains platform ownership &amp; offers managed service</a:t>
-            </a:r>
-          </a:p>
-        </p:txBody>
-      </p:sp>
-      <p:sp>
-        <p:nvSpPr>
-          <p:cNvPr id="5" name="Rectangle 4"/>
+              <a:t>Pricing — Option B (SaaS) &amp; Option C (Shared Ownership)</a:t>
+            </a:r>
+          </a:p>
+        </p:txBody>
+      </p:sp>
+      <p:sp>
+        <p:nvSpPr>
+          <p:cNvPr id="4" name="Rectangle 3"/>
           <p:cNvSpPr/>
           <p:nvPr/>
         </p:nvSpPr>
         <p:spPr>
           <a:xfrm>
-            <a:off x="1371600" y="1828800"/>
-            <a:ext cx="4114800" cy="2286000"/>
+            <a:off x="365760" y="1188720"/>
+            <a:ext cx="5394960" cy="2743200"/>
           </a:xfrm>
           <a:prstGeom prst="rect">
             <a:avLst/>
@@ -8110,50 +8074,50 @@
       </p:sp>
       <p:sp>
         <p:nvSpPr>
+          <p:cNvPr id="5" name="TextBox 4"/>
+          <p:cNvSpPr txBox="1"/>
+          <p:nvPr/>
+        </p:nvSpPr>
+        <p:spPr>
+          <a:xfrm>
+            <a:off x="548640" y="1234440"/>
+            <a:ext cx="5029200" cy="411480"/>
+          </a:xfrm>
+          <a:prstGeom prst="rect">
+            <a:avLst/>
+          </a:prstGeom>
+          <a:noFill/>
+        </p:spPr>
+        <p:txBody>
+          <a:bodyPr wrap="square">
+            <a:spAutoFit/>
+          </a:bodyPr>
+          <a:lstStyle/>
+          <a:p>
+            <a:pPr algn="l">
+              <a:defRPr sz="2000" b="1">
+                <a:solidFill>
+                  <a:srgbClr val="1B2A4A"/>
+                </a:solidFill>
+                <a:latin typeface="Calibri"/>
+              </a:defRPr>
+            </a:pPr>
+            <a:r>
+              <a:t>Option B: IoTeye-Hosted SaaS</a:t>
+            </a:r>
+          </a:p>
+        </p:txBody>
+      </p:sp>
+      <p:sp>
+        <p:nvSpPr>
           <p:cNvPr id="6" name="TextBox 5"/>
           <p:cNvSpPr txBox="1"/>
           <p:nvPr/>
         </p:nvSpPr>
         <p:spPr>
           <a:xfrm>
-            <a:off x="1554480" y="1920240"/>
-            <a:ext cx="3657600" cy="457200"/>
-          </a:xfrm>
-          <a:prstGeom prst="rect">
-            <a:avLst/>
-          </a:prstGeom>
-          <a:noFill/>
-        </p:spPr>
-        <p:txBody>
-          <a:bodyPr wrap="square">
-            <a:spAutoFit/>
-          </a:bodyPr>
-          <a:lstStyle/>
-          <a:p>
-            <a:pPr algn="l">
-              <a:defRPr sz="2200" b="1">
-                <a:solidFill>
-                  <a:srgbClr val="1B2A4A"/>
-                </a:solidFill>
-                <a:latin typeface="Calibri"/>
-              </a:defRPr>
-            </a:pPr>
-            <a:r>
-              <a:t>Pricing</a:t>
-            </a:r>
-          </a:p>
-        </p:txBody>
-      </p:sp>
-      <p:sp>
-        <p:nvSpPr>
-          <p:cNvPr id="7" name="TextBox 6"/>
-          <p:cNvSpPr txBox="1"/>
-          <p:nvPr/>
-        </p:nvSpPr>
-        <p:spPr>
-          <a:xfrm>
-            <a:off x="1554480" y="2468880"/>
-            <a:ext cx="3657600" cy="1645920"/>
+            <a:off x="548640" y="1691640"/>
+            <a:ext cx="5029200" cy="2103120"/>
           </a:xfrm>
           <a:prstGeom prst="rect">
             <a:avLst/>
@@ -8168,9 +8132,9 @@
           <a:p>
             <a:pPr algn="l">
               <a:spcAft>
-                <a:spcPts val="1000"/>
+                <a:spcPts val="700"/>
               </a:spcAft>
-              <a:defRPr sz="1600" b="0">
+              <a:defRPr sz="1400" b="0">
                 <a:solidFill>
                   <a:srgbClr val="333333"/>
                 </a:solidFill>
@@ -8184,63 +8148,79 @@
           <a:p>
             <a:pPr>
               <a:spcAft>
-                <a:spcPts val="1000"/>
+                <a:spcPts val="700"/>
               </a:spcAft>
-              <a:defRPr sz="1600">
-                <a:solidFill>
-                  <a:srgbClr val="333333"/>
-                </a:solidFill>
-                <a:latin typeface="Calibri"/>
-              </a:defRPr>
-            </a:pPr>
-            <a:r>
-              <a:t>• Monthly subscription: $2,500/month</a:t>
+              <a:defRPr sz="1400">
+                <a:solidFill>
+                  <a:srgbClr val="333333"/>
+                </a:solidFill>
+                <a:latin typeface="Calibri"/>
+              </a:defRPr>
+            </a:pPr>
+            <a:r>
+              <a:t>• Subscription: $2,500/month ($30,000/year)</a:t>
             </a:r>
           </a:p>
           <a:p>
             <a:pPr>
               <a:spcAft>
-                <a:spcPts val="1000"/>
+                <a:spcPts val="700"/>
               </a:spcAft>
-              <a:defRPr sz="1600">
-                <a:solidFill>
-                  <a:srgbClr val="333333"/>
-                </a:solidFill>
-                <a:latin typeface="Calibri"/>
-              </a:defRPr>
-            </a:pPr>
-            <a:r>
-              <a:t>• Annual total: $30,000/year</a:t>
+              <a:defRPr sz="1400">
+                <a:solidFill>
+                  <a:srgbClr val="333333"/>
+                </a:solidFill>
+                <a:latin typeface="Calibri"/>
+              </a:defRPr>
+            </a:pPr>
+            <a:r>
+              <a:t>• 3-year minimum commitment</a:t>
             </a:r>
           </a:p>
           <a:p>
             <a:pPr>
               <a:spcAft>
-                <a:spcPts val="1000"/>
+                <a:spcPts val="700"/>
               </a:spcAft>
-              <a:defRPr sz="1600">
-                <a:solidFill>
-                  <a:srgbClr val="333333"/>
-                </a:solidFill>
-                <a:latin typeface="Calibri"/>
-              </a:defRPr>
-            </a:pPr>
-            <a:r>
-              <a:t>• Minimum commitment: 3-year term</a:t>
-            </a:r>
-          </a:p>
-        </p:txBody>
-      </p:sp>
-      <p:sp>
-        <p:nvSpPr>
-          <p:cNvPr id="8" name="Rectangle 7"/>
+              <a:defRPr sz="1400">
+                <a:solidFill>
+                  <a:srgbClr val="333333"/>
+                </a:solidFill>
+                <a:latin typeface="Calibri"/>
+              </a:defRPr>
+            </a:pPr>
+            <a:r>
+              <a:t>• IoTeye retains all source code ownership</a:t>
+            </a:r>
+          </a:p>
+          <a:p>
+            <a:pPr>
+              <a:spcAft>
+                <a:spcPts val="700"/>
+              </a:spcAft>
+              <a:defRPr sz="1400">
+                <a:solidFill>
+                  <a:srgbClr val="333333"/>
+                </a:solidFill>
+                <a:latin typeface="Calibri"/>
+              </a:defRPr>
+            </a:pPr>
+            <a:r>
+              <a:t>• Hosting, maintenance, updates all included</a:t>
+            </a:r>
+          </a:p>
+        </p:txBody>
+      </p:sp>
+      <p:sp>
+        <p:nvSpPr>
+          <p:cNvPr id="7" name="Rectangle 6"/>
           <p:cNvSpPr/>
           <p:nvPr/>
         </p:nvSpPr>
         <p:spPr>
           <a:xfrm>
-            <a:off x="6400800" y="1828800"/>
-            <a:ext cx="4572000" cy="2286000"/>
+            <a:off x="6400800" y="1188720"/>
+            <a:ext cx="5394960" cy="2743200"/>
           </a:xfrm>
           <a:prstGeom prst="rect">
             <a:avLst/>
@@ -8276,50 +8256,50 @@
       </p:sp>
       <p:sp>
         <p:nvSpPr>
+          <p:cNvPr id="8" name="TextBox 7"/>
+          <p:cNvSpPr txBox="1"/>
+          <p:nvPr/>
+        </p:nvSpPr>
+        <p:spPr>
+          <a:xfrm>
+            <a:off x="6583680" y="1234440"/>
+            <a:ext cx="5029200" cy="411480"/>
+          </a:xfrm>
+          <a:prstGeom prst="rect">
+            <a:avLst/>
+          </a:prstGeom>
+          <a:noFill/>
+        </p:spPr>
+        <p:txBody>
+          <a:bodyPr wrap="square">
+            <a:spAutoFit/>
+          </a:bodyPr>
+          <a:lstStyle/>
+          <a:p>
+            <a:pPr algn="l">
+              <a:defRPr sz="2000" b="1">
+                <a:solidFill>
+                  <a:srgbClr val="1B2A4A"/>
+                </a:solidFill>
+                <a:latin typeface="Calibri"/>
+              </a:defRPr>
+            </a:pPr>
+            <a:r>
+              <a:t>Option C: Shared Ownership (Hybrid)</a:t>
+            </a:r>
+          </a:p>
+        </p:txBody>
+      </p:sp>
+      <p:sp>
+        <p:nvSpPr>
           <p:cNvPr id="9" name="TextBox 8"/>
           <p:cNvSpPr txBox="1"/>
           <p:nvPr/>
         </p:nvSpPr>
         <p:spPr>
           <a:xfrm>
-            <a:off x="6583680" y="1920240"/>
-            <a:ext cx="4114800" cy="457200"/>
-          </a:xfrm>
-          <a:prstGeom prst="rect">
-            <a:avLst/>
-          </a:prstGeom>
-          <a:noFill/>
-        </p:spPr>
-        <p:txBody>
-          <a:bodyPr wrap="square">
-            <a:spAutoFit/>
-          </a:bodyPr>
-          <a:lstStyle/>
-          <a:p>
-            <a:pPr algn="l">
-              <a:defRPr sz="2200" b="1">
-                <a:solidFill>
-                  <a:srgbClr val="1B2A4A"/>
-                </a:solidFill>
-                <a:latin typeface="Calibri"/>
-              </a:defRPr>
-            </a:pPr>
-            <a:r>
-              <a:t>What's Included</a:t>
-            </a:r>
-          </a:p>
-        </p:txBody>
-      </p:sp>
-      <p:sp>
-        <p:nvSpPr>
-          <p:cNvPr id="10" name="TextBox 9"/>
-          <p:cNvSpPr txBox="1"/>
-          <p:nvPr/>
-        </p:nvSpPr>
-        <p:spPr>
-          <a:xfrm>
-            <a:off x="6583680" y="2468880"/>
-            <a:ext cx="4114800" cy="1645920"/>
+            <a:off x="6583680" y="1691640"/>
+            <a:ext cx="5029200" cy="2103120"/>
           </a:xfrm>
           <a:prstGeom prst="rect">
             <a:avLst/>
@@ -8334,95 +8314,95 @@
           <a:p>
             <a:pPr algn="l">
               <a:spcAft>
-                <a:spcPts val="800"/>
+                <a:spcPts val="700"/>
               </a:spcAft>
-              <a:defRPr sz="1500" b="0">
-                <a:solidFill>
-                  <a:srgbClr val="333333"/>
-                </a:solidFill>
-                <a:latin typeface="Calibri"/>
-              </a:defRPr>
-            </a:pPr>
-            <a:r>
-              <a:t>• All 3 phases (same 36-week timeline)</a:t>
+              <a:defRPr sz="1400" b="0">
+                <a:solidFill>
+                  <a:srgbClr val="333333"/>
+                </a:solidFill>
+                <a:latin typeface="Calibri"/>
+              </a:defRPr>
+            </a:pPr>
+            <a:r>
+              <a:t>• Implementation fee: $55,000 (50% of full build)</a:t>
             </a:r>
           </a:p>
           <a:p>
             <a:pPr>
               <a:spcAft>
-                <a:spcPts val="800"/>
+                <a:spcPts val="700"/>
               </a:spcAft>
-              <a:defRPr sz="1500">
-                <a:solidFill>
-                  <a:srgbClr val="333333"/>
-                </a:solidFill>
-                <a:latin typeface="Calibri"/>
-              </a:defRPr>
-            </a:pPr>
-            <a:r>
-              <a:t>• Hosting, maintenance, security updates</a:t>
+              <a:defRPr sz="1400">
+                <a:solidFill>
+                  <a:srgbClr val="333333"/>
+                </a:solidFill>
+                <a:latin typeface="Calibri"/>
+              </a:defRPr>
+            </a:pPr>
+            <a:r>
+              <a:t>• Annual platform fee: $30,000/year (managed service)</a:t>
             </a:r>
           </a:p>
           <a:p>
             <a:pPr>
               <a:spcAft>
-                <a:spcPts val="800"/>
+                <a:spcPts val="700"/>
               </a:spcAft>
-              <a:defRPr sz="1500">
-                <a:solidFill>
-                  <a:srgbClr val="333333"/>
-                </a:solidFill>
-                <a:latin typeface="Calibri"/>
-              </a:defRPr>
-            </a:pPr>
-            <a:r>
-              <a:t>• Ongoing support &amp; platform updates</a:t>
+              <a:defRPr sz="1400">
+                <a:solidFill>
+                  <a:srgbClr val="333333"/>
+                </a:solidFill>
+                <a:latin typeface="Calibri"/>
+              </a:defRPr>
+            </a:pPr>
+            <a:r>
+              <a:t>• Arc Mercer owns recognition platform code</a:t>
             </a:r>
           </a:p>
           <a:p>
             <a:pPr>
               <a:spcAft>
-                <a:spcPts val="800"/>
+                <a:spcPts val="700"/>
               </a:spcAft>
-              <a:defRPr sz="1500">
-                <a:solidFill>
-                  <a:srgbClr val="333333"/>
-                </a:solidFill>
-                <a:latin typeface="Calibri"/>
-              </a:defRPr>
-            </a:pPr>
-            <a:r>
-              <a:t>• No per-user fees</a:t>
+              <a:defRPr sz="1400">
+                <a:solidFill>
+                  <a:srgbClr val="333333"/>
+                </a:solidFill>
+                <a:latin typeface="Calibri"/>
+              </a:defRPr>
+            </a:pPr>
+            <a:r>
+              <a:t>• Excludes: BrainBook, SpringBoard, Guardian, BrainClaw</a:t>
             </a:r>
           </a:p>
           <a:p>
             <a:pPr>
               <a:spcAft>
-                <a:spcPts val="800"/>
+                <a:spcPts val="700"/>
               </a:spcAft>
-              <a:defRPr sz="1500">
-                <a:solidFill>
-                  <a:srgbClr val="333333"/>
-                </a:solidFill>
-                <a:latin typeface="Calibri"/>
-              </a:defRPr>
-            </a:pPr>
-            <a:r>
-              <a:t>• All add-ons: $0 (AI LLM usage only)</a:t>
-            </a:r>
-          </a:p>
-        </p:txBody>
-      </p:sp>
-      <p:sp>
-        <p:nvSpPr>
-          <p:cNvPr id="11" name="Rectangle 10"/>
+              <a:defRPr sz="1400">
+                <a:solidFill>
+                  <a:srgbClr val="333333"/>
+                </a:solidFill>
+                <a:latin typeface="Calibri"/>
+              </a:defRPr>
+            </a:pPr>
+            <a:r>
+              <a:t>• Reuse rights deferred to legal agreement</a:t>
+            </a:r>
+          </a:p>
+        </p:txBody>
+      </p:sp>
+      <p:sp>
+        <p:nvSpPr>
+          <p:cNvPr id="10" name="Rectangle 9"/>
           <p:cNvSpPr/>
           <p:nvPr/>
         </p:nvSpPr>
         <p:spPr>
           <a:xfrm>
-            <a:off x="6400800" y="4160520"/>
-            <a:ext cx="4572000" cy="457200"/>
+            <a:off x="365760" y="4023360"/>
+            <a:ext cx="11430000" cy="411480"/>
           </a:xfrm>
           <a:prstGeom prst="rect">
             <a:avLst/>
@@ -8458,50 +8438,50 @@
       </p:sp>
       <p:sp>
         <p:nvSpPr>
+          <p:cNvPr id="11" name="TextBox 10"/>
+          <p:cNvSpPr txBox="1"/>
+          <p:nvPr/>
+        </p:nvSpPr>
+        <p:spPr>
+          <a:xfrm>
+            <a:off x="548640" y="4050791"/>
+            <a:ext cx="10972800" cy="365760"/>
+          </a:xfrm>
+          <a:prstGeom prst="rect">
+            <a:avLst/>
+          </a:prstGeom>
+          <a:noFill/>
+        </p:spPr>
+        <p:txBody>
+          <a:bodyPr wrap="square">
+            <a:spAutoFit/>
+          </a:bodyPr>
+          <a:lstStyle/>
+          <a:p>
+            <a:pPr algn="ctr">
+              <a:defRPr sz="1300" b="1">
+                <a:solidFill>
+                  <a:srgbClr val="FFFFFF"/>
+                </a:solidFill>
+                <a:latin typeface="Calibri"/>
+              </a:defRPr>
+            </a:pPr>
+            <a:r>
+              <a:t>★  All add-ons INCLUDED at $0 — only AI LLM usage fee applies (billed at cost, pass-through)  ★</a:t>
+            </a:r>
+          </a:p>
+        </p:txBody>
+      </p:sp>
+      <p:sp>
+        <p:nvSpPr>
           <p:cNvPr id="12" name="TextBox 11"/>
           <p:cNvSpPr txBox="1"/>
           <p:nvPr/>
         </p:nvSpPr>
         <p:spPr>
           <a:xfrm>
-            <a:off x="6537960" y="4206240"/>
-            <a:ext cx="4297680" cy="365760"/>
-          </a:xfrm>
-          <a:prstGeom prst="rect">
-            <a:avLst/>
-          </a:prstGeom>
-          <a:noFill/>
-        </p:spPr>
-        <p:txBody>
-          <a:bodyPr wrap="square">
-            <a:spAutoFit/>
-          </a:bodyPr>
-          <a:lstStyle/>
-          <a:p>
-            <a:pPr algn="ctr">
-              <a:defRPr sz="1400" b="1">
-                <a:solidFill>
-                  <a:srgbClr val="FFFFFF"/>
-                </a:solidFill>
-                <a:latin typeface="Calibri"/>
-              </a:defRPr>
-            </a:pPr>
-            <a:r>
-              <a:t>★ AI Agents, Reports, Training — all at $0</a:t>
-            </a:r>
-          </a:p>
-        </p:txBody>
-      </p:sp>
-      <p:sp>
-        <p:nvSpPr>
-          <p:cNvPr id="13" name="TextBox 12"/>
-          <p:cNvSpPr txBox="1"/>
-          <p:nvPr/>
-        </p:nvSpPr>
-        <p:spPr>
-          <a:xfrm>
-            <a:off x="731520" y="4389120"/>
-            <a:ext cx="10058400" cy="457200"/>
+            <a:off x="365760" y="4572000"/>
+            <a:ext cx="10972800" cy="365760"/>
           </a:xfrm>
           <a:prstGeom prst="rect">
             <a:avLst/>
@@ -8515,7 +8495,7 @@
           <a:lstStyle/>
           <a:p>
             <a:pPr algn="l">
-              <a:defRPr sz="2000" b="1">
+              <a:defRPr sz="1800" b="1">
                 <a:solidFill>
                   <a:srgbClr val="1B2A4A"/>
                 </a:solidFill>
@@ -8523,21 +8503,21 @@
               </a:defRPr>
             </a:pPr>
             <a:r>
-              <a:t>Option A vs. Option B — Cost Comparison</a:t>
-            </a:r>
-          </a:p>
-        </p:txBody>
-      </p:sp>
-      <p:sp>
-        <p:nvSpPr>
-          <p:cNvPr id="14" name="Rectangle 13"/>
+              <a:t>Option A vs. B vs. C — Cost Comparison</a:t>
+            </a:r>
+          </a:p>
+        </p:txBody>
+      </p:sp>
+      <p:sp>
+        <p:nvSpPr>
+          <p:cNvPr id="13" name="Rectangle 12"/>
           <p:cNvSpPr/>
           <p:nvPr/>
         </p:nvSpPr>
         <p:spPr>
           <a:xfrm>
-            <a:off x="1645920" y="4846320"/>
-            <a:ext cx="2286000" cy="365760"/>
+            <a:off x="1097280" y="4937760"/>
+            <a:ext cx="2011680" cy="320040"/>
           </a:xfrm>
           <a:prstGeom prst="rect">
             <a:avLst/>
@@ -8573,14 +8553,14 @@
       </p:sp>
       <p:sp>
         <p:nvSpPr>
-          <p:cNvPr id="15" name="TextBox 14"/>
-          <p:cNvSpPr txBox="1"/>
-          <p:nvPr/>
-        </p:nvSpPr>
-        <p:spPr>
-          <a:xfrm>
-            <a:off x="1737360" y="4864608"/>
-            <a:ext cx="2103120" cy="320040"/>
+          <p:cNvPr id="14" name="TextBox 13"/>
+          <p:cNvSpPr txBox="1"/>
+          <p:nvPr/>
+        </p:nvSpPr>
+        <p:spPr>
+          <a:xfrm>
+            <a:off x="1170432" y="4946904"/>
+            <a:ext cx="1865376" cy="292608"/>
           </a:xfrm>
           <a:prstGeom prst="rect">
             <a:avLst/>
@@ -8594,7 +8574,7 @@
           <a:lstStyle/>
           <a:p>
             <a:pPr algn="l">
-              <a:defRPr sz="1300" b="1">
+              <a:defRPr sz="1200" b="1">
                 <a:solidFill>
                   <a:srgbClr val="FFFFFF"/>
                 </a:solidFill>
@@ -8606,14 +8586,14 @@
       </p:sp>
       <p:sp>
         <p:nvSpPr>
-          <p:cNvPr id="16" name="Rectangle 15"/>
+          <p:cNvPr id="15" name="Rectangle 14"/>
           <p:cNvSpPr/>
           <p:nvPr/>
         </p:nvSpPr>
         <p:spPr>
           <a:xfrm>
-            <a:off x="3931920" y="4846320"/>
-            <a:ext cx="3200400" cy="365760"/>
+            <a:off x="3108960" y="4937760"/>
+            <a:ext cx="2377440" cy="320040"/>
           </a:xfrm>
           <a:prstGeom prst="rect">
             <a:avLst/>
@@ -8649,14 +8629,14 @@
       </p:sp>
       <p:sp>
         <p:nvSpPr>
-          <p:cNvPr id="17" name="TextBox 16"/>
-          <p:cNvSpPr txBox="1"/>
-          <p:nvPr/>
-        </p:nvSpPr>
-        <p:spPr>
-          <a:xfrm>
-            <a:off x="4023360" y="4864608"/>
-            <a:ext cx="3017520" cy="320040"/>
+          <p:cNvPr id="16" name="TextBox 15"/>
+          <p:cNvSpPr txBox="1"/>
+          <p:nvPr/>
+        </p:nvSpPr>
+        <p:spPr>
+          <a:xfrm>
+            <a:off x="3182112" y="4946904"/>
+            <a:ext cx="2231136" cy="292608"/>
           </a:xfrm>
           <a:prstGeom prst="rect">
             <a:avLst/>
@@ -8670,7 +8650,7 @@
           <a:lstStyle/>
           <a:p>
             <a:pPr algn="l">
-              <a:defRPr sz="1300" b="1">
+              <a:defRPr sz="1200" b="1">
                 <a:solidFill>
                   <a:srgbClr val="FFFFFF"/>
                 </a:solidFill>
@@ -8678,21 +8658,21 @@
               </a:defRPr>
             </a:pPr>
             <a:r>
-              <a:t>Option A (Own Code)</a:t>
-            </a:r>
-          </a:p>
-        </p:txBody>
-      </p:sp>
-      <p:sp>
-        <p:nvSpPr>
-          <p:cNvPr id="18" name="Rectangle 17"/>
+              <a:t>A: Own Code</a:t>
+            </a:r>
+          </a:p>
+        </p:txBody>
+      </p:sp>
+      <p:sp>
+        <p:nvSpPr>
+          <p:cNvPr id="17" name="Rectangle 16"/>
           <p:cNvSpPr/>
           <p:nvPr/>
         </p:nvSpPr>
         <p:spPr>
           <a:xfrm>
-            <a:off x="7132320" y="4846320"/>
-            <a:ext cx="3200400" cy="365760"/>
+            <a:off x="5486400" y="4937760"/>
+            <a:ext cx="2377440" cy="320040"/>
           </a:xfrm>
           <a:prstGeom prst="rect">
             <a:avLst/>
@@ -8728,14 +8708,14 @@
       </p:sp>
       <p:sp>
         <p:nvSpPr>
-          <p:cNvPr id="19" name="TextBox 18"/>
-          <p:cNvSpPr txBox="1"/>
-          <p:nvPr/>
-        </p:nvSpPr>
-        <p:spPr>
-          <a:xfrm>
-            <a:off x="7223760" y="4864608"/>
-            <a:ext cx="3017520" cy="320040"/>
+          <p:cNvPr id="18" name="TextBox 17"/>
+          <p:cNvSpPr txBox="1"/>
+          <p:nvPr/>
+        </p:nvSpPr>
+        <p:spPr>
+          <a:xfrm>
+            <a:off x="5559552" y="4946904"/>
+            <a:ext cx="2231136" cy="292608"/>
           </a:xfrm>
           <a:prstGeom prst="rect">
             <a:avLst/>
@@ -8749,7 +8729,7 @@
           <a:lstStyle/>
           <a:p>
             <a:pPr algn="l">
-              <a:defRPr sz="1300" b="1">
+              <a:defRPr sz="1200" b="1">
                 <a:solidFill>
                   <a:srgbClr val="FFFFFF"/>
                 </a:solidFill>
@@ -8757,21 +8737,100 @@
               </a:defRPr>
             </a:pPr>
             <a:r>
-              <a:t>Option B (SaaS)</a:t>
-            </a:r>
-          </a:p>
-        </p:txBody>
-      </p:sp>
-      <p:sp>
-        <p:nvSpPr>
-          <p:cNvPr id="20" name="Rectangle 19"/>
+              <a:t>B: SaaS</a:t>
+            </a:r>
+          </a:p>
+        </p:txBody>
+      </p:sp>
+      <p:sp>
+        <p:nvSpPr>
+          <p:cNvPr id="19" name="Rectangle 18"/>
           <p:cNvSpPr/>
           <p:nvPr/>
         </p:nvSpPr>
         <p:spPr>
           <a:xfrm>
-            <a:off x="1645920" y="5212080"/>
-            <a:ext cx="2286000" cy="320040"/>
+            <a:off x="7863840" y="4937760"/>
+            <a:ext cx="2377440" cy="320040"/>
+          </a:xfrm>
+          <a:prstGeom prst="rect">
+            <a:avLst/>
+          </a:prstGeom>
+          <a:solidFill>
+            <a:srgbClr val="2E86C1"/>
+          </a:solidFill>
+          <a:ln>
+            <a:noFill/>
+          </a:ln>
+        </p:spPr>
+        <p:style>
+          <a:lnRef idx="1">
+            <a:schemeClr val="accent1"/>
+          </a:lnRef>
+          <a:fillRef idx="3">
+            <a:schemeClr val="accent1"/>
+          </a:fillRef>
+          <a:effectRef idx="2">
+            <a:schemeClr val="accent1"/>
+          </a:effectRef>
+          <a:fontRef idx="minor">
+            <a:schemeClr val="lt1"/>
+          </a:fontRef>
+        </p:style>
+        <p:txBody>
+          <a:bodyPr rtlCol="0" anchor="ctr"/>
+          <a:lstStyle/>
+          <a:p>
+            <a:pPr algn="ctr"/>
+          </a:p>
+        </p:txBody>
+      </p:sp>
+      <p:sp>
+        <p:nvSpPr>
+          <p:cNvPr id="20" name="TextBox 19"/>
+          <p:cNvSpPr txBox="1"/>
+          <p:nvPr/>
+        </p:nvSpPr>
+        <p:spPr>
+          <a:xfrm>
+            <a:off x="7936992" y="4946904"/>
+            <a:ext cx="2231136" cy="292608"/>
+          </a:xfrm>
+          <a:prstGeom prst="rect">
+            <a:avLst/>
+          </a:prstGeom>
+          <a:noFill/>
+        </p:spPr>
+        <p:txBody>
+          <a:bodyPr wrap="square">
+            <a:spAutoFit/>
+          </a:bodyPr>
+          <a:lstStyle/>
+          <a:p>
+            <a:pPr algn="l">
+              <a:defRPr sz="1200" b="1">
+                <a:solidFill>
+                  <a:srgbClr val="FFFFFF"/>
+                </a:solidFill>
+                <a:latin typeface="Calibri"/>
+              </a:defRPr>
+            </a:pPr>
+            <a:r>
+              <a:t>C: Shared</a:t>
+            </a:r>
+          </a:p>
+        </p:txBody>
+      </p:sp>
+      <p:sp>
+        <p:nvSpPr>
+          <p:cNvPr id="21" name="Rectangle 20"/>
+          <p:cNvSpPr/>
+          <p:nvPr/>
+        </p:nvSpPr>
+        <p:spPr>
+          <a:xfrm>
+            <a:off x="1097280" y="5257800"/>
+            <a:ext cx="2011680" cy="292608"/>
           </a:xfrm>
           <a:prstGeom prst="rect">
             <a:avLst/>
@@ -8807,14 +8866,14 @@
       </p:sp>
       <p:sp>
         <p:nvSpPr>
-          <p:cNvPr id="21" name="TextBox 20"/>
-          <p:cNvSpPr txBox="1"/>
-          <p:nvPr/>
-        </p:nvSpPr>
-        <p:spPr>
-          <a:xfrm>
-            <a:off x="1737360" y="5221224"/>
-            <a:ext cx="2103120" cy="274320"/>
+          <p:cNvPr id="22" name="TextBox 21"/>
+          <p:cNvSpPr txBox="1"/>
+          <p:nvPr/>
+        </p:nvSpPr>
+        <p:spPr>
+          <a:xfrm>
+            <a:off x="1170432" y="5266944"/>
+            <a:ext cx="1865376" cy="256032"/>
           </a:xfrm>
           <a:prstGeom prst="rect">
             <a:avLst/>
@@ -8828,7 +8887,7 @@
           <a:lstStyle/>
           <a:p>
             <a:pPr algn="l">
-              <a:defRPr sz="1200" b="1">
+              <a:defRPr sz="1100" b="1">
                 <a:solidFill>
                   <a:srgbClr val="333333"/>
                 </a:solidFill>
@@ -8843,14 +8902,14 @@
       </p:sp>
       <p:sp>
         <p:nvSpPr>
-          <p:cNvPr id="22" name="Rectangle 21"/>
+          <p:cNvPr id="23" name="Rectangle 22"/>
           <p:cNvSpPr/>
           <p:nvPr/>
         </p:nvSpPr>
         <p:spPr>
           <a:xfrm>
-            <a:off x="3931920" y="5212080"/>
-            <a:ext cx="3200400" cy="320040"/>
+            <a:off x="3108960" y="5257800"/>
+            <a:ext cx="2377440" cy="292608"/>
           </a:xfrm>
           <a:prstGeom prst="rect">
             <a:avLst/>
@@ -8886,14 +8945,14 @@
       </p:sp>
       <p:sp>
         <p:nvSpPr>
-          <p:cNvPr id="23" name="TextBox 22"/>
-          <p:cNvSpPr txBox="1"/>
-          <p:nvPr/>
-        </p:nvSpPr>
-        <p:spPr>
-          <a:xfrm>
-            <a:off x="4023360" y="5221224"/>
-            <a:ext cx="3017520" cy="274320"/>
+          <p:cNvPr id="24" name="TextBox 23"/>
+          <p:cNvSpPr txBox="1"/>
+          <p:nvPr/>
+        </p:nvSpPr>
+        <p:spPr>
+          <a:xfrm>
+            <a:off x="3182112" y="5266944"/>
+            <a:ext cx="2231136" cy="256032"/>
           </a:xfrm>
           <a:prstGeom prst="rect">
             <a:avLst/>
@@ -8907,7 +8966,7 @@
           <a:lstStyle/>
           <a:p>
             <a:pPr algn="l">
-              <a:defRPr sz="1200" b="0">
+              <a:defRPr sz="1100" b="0">
                 <a:solidFill>
                   <a:srgbClr val="333333"/>
                 </a:solidFill>
@@ -8922,14 +8981,14 @@
       </p:sp>
       <p:sp>
         <p:nvSpPr>
-          <p:cNvPr id="24" name="Rectangle 23"/>
+          <p:cNvPr id="25" name="Rectangle 24"/>
           <p:cNvSpPr/>
           <p:nvPr/>
         </p:nvSpPr>
         <p:spPr>
           <a:xfrm>
-            <a:off x="7132320" y="5212080"/>
-            <a:ext cx="3200400" cy="320040"/>
+            <a:off x="5486400" y="5257800"/>
+            <a:ext cx="2377440" cy="292608"/>
           </a:xfrm>
           <a:prstGeom prst="rect">
             <a:avLst/>
@@ -8965,14 +9024,14 @@
       </p:sp>
       <p:sp>
         <p:nvSpPr>
-          <p:cNvPr id="25" name="TextBox 24"/>
-          <p:cNvSpPr txBox="1"/>
-          <p:nvPr/>
-        </p:nvSpPr>
-        <p:spPr>
-          <a:xfrm>
-            <a:off x="7223760" y="5221224"/>
-            <a:ext cx="3017520" cy="274320"/>
+          <p:cNvPr id="26" name="TextBox 25"/>
+          <p:cNvSpPr txBox="1"/>
+          <p:nvPr/>
+        </p:nvSpPr>
+        <p:spPr>
+          <a:xfrm>
+            <a:off x="5559552" y="5266944"/>
+            <a:ext cx="2231136" cy="256032"/>
           </a:xfrm>
           <a:prstGeom prst="rect">
             <a:avLst/>
@@ -8986,7 +9045,7 @@
           <a:lstStyle/>
           <a:p>
             <a:pPr algn="l">
-              <a:defRPr sz="1200" b="0">
+              <a:defRPr sz="1100" b="0">
                 <a:solidFill>
                   <a:srgbClr val="333333"/>
                 </a:solidFill>
@@ -9001,14 +9060,93 @@
       </p:sp>
       <p:sp>
         <p:nvSpPr>
-          <p:cNvPr id="26" name="Rectangle 25"/>
+          <p:cNvPr id="27" name="Rectangle 26"/>
           <p:cNvSpPr/>
           <p:nvPr/>
         </p:nvSpPr>
         <p:spPr>
           <a:xfrm>
-            <a:off x="1645920" y="5532120"/>
-            <a:ext cx="2286000" cy="320040"/>
+            <a:off x="7863840" y="5257800"/>
+            <a:ext cx="2377440" cy="292608"/>
+          </a:xfrm>
+          <a:prstGeom prst="rect">
+            <a:avLst/>
+          </a:prstGeom>
+          <a:solidFill>
+            <a:srgbClr val="F2F2F2"/>
+          </a:solidFill>
+          <a:ln>
+            <a:noFill/>
+          </a:ln>
+        </p:spPr>
+        <p:style>
+          <a:lnRef idx="1">
+            <a:schemeClr val="accent1"/>
+          </a:lnRef>
+          <a:fillRef idx="3">
+            <a:schemeClr val="accent1"/>
+          </a:fillRef>
+          <a:effectRef idx="2">
+            <a:schemeClr val="accent1"/>
+          </a:effectRef>
+          <a:fontRef idx="minor">
+            <a:schemeClr val="lt1"/>
+          </a:fontRef>
+        </p:style>
+        <p:txBody>
+          <a:bodyPr rtlCol="0" anchor="ctr"/>
+          <a:lstStyle/>
+          <a:p>
+            <a:pPr algn="ctr"/>
+          </a:p>
+        </p:txBody>
+      </p:sp>
+      <p:sp>
+        <p:nvSpPr>
+          <p:cNvPr id="28" name="TextBox 27"/>
+          <p:cNvSpPr txBox="1"/>
+          <p:nvPr/>
+        </p:nvSpPr>
+        <p:spPr>
+          <a:xfrm>
+            <a:off x="7936992" y="5266944"/>
+            <a:ext cx="2231136" cy="256032"/>
+          </a:xfrm>
+          <a:prstGeom prst="rect">
+            <a:avLst/>
+          </a:prstGeom>
+          <a:noFill/>
+        </p:spPr>
+        <p:txBody>
+          <a:bodyPr wrap="square">
+            <a:spAutoFit/>
+          </a:bodyPr>
+          <a:lstStyle/>
+          <a:p>
+            <a:pPr algn="l">
+              <a:defRPr sz="1100" b="0">
+                <a:solidFill>
+                  <a:srgbClr val="333333"/>
+                </a:solidFill>
+                <a:latin typeface="Calibri"/>
+              </a:defRPr>
+            </a:pPr>
+            <a:r>
+              <a:t>$55,000</a:t>
+            </a:r>
+          </a:p>
+        </p:txBody>
+      </p:sp>
+      <p:sp>
+        <p:nvSpPr>
+          <p:cNvPr id="29" name="Rectangle 28"/>
+          <p:cNvSpPr/>
+          <p:nvPr/>
+        </p:nvSpPr>
+        <p:spPr>
+          <a:xfrm>
+            <a:off x="1097280" y="5550408"/>
+            <a:ext cx="2011680" cy="292608"/>
           </a:xfrm>
           <a:prstGeom prst="rect">
             <a:avLst/>
@@ -9044,14 +9182,14 @@
       </p:sp>
       <p:sp>
         <p:nvSpPr>
-          <p:cNvPr id="27" name="TextBox 26"/>
-          <p:cNvSpPr txBox="1"/>
-          <p:nvPr/>
-        </p:nvSpPr>
-        <p:spPr>
-          <a:xfrm>
-            <a:off x="1737360" y="5541264"/>
-            <a:ext cx="2103120" cy="274320"/>
+          <p:cNvPr id="30" name="TextBox 29"/>
+          <p:cNvSpPr txBox="1"/>
+          <p:nvPr/>
+        </p:nvSpPr>
+        <p:spPr>
+          <a:xfrm>
+            <a:off x="1170432" y="5559552"/>
+            <a:ext cx="1865376" cy="256032"/>
           </a:xfrm>
           <a:prstGeom prst="rect">
             <a:avLst/>
@@ -9065,7 +9203,7 @@
           <a:lstStyle/>
           <a:p>
             <a:pPr algn="l">
-              <a:defRPr sz="1200" b="1">
+              <a:defRPr sz="1100" b="1">
                 <a:solidFill>
                   <a:srgbClr val="333333"/>
                 </a:solidFill>
@@ -9080,14 +9218,14 @@
       </p:sp>
       <p:sp>
         <p:nvSpPr>
-          <p:cNvPr id="28" name="Rectangle 27"/>
+          <p:cNvPr id="31" name="Rectangle 30"/>
           <p:cNvSpPr/>
           <p:nvPr/>
         </p:nvSpPr>
         <p:spPr>
           <a:xfrm>
-            <a:off x="3931920" y="5532120"/>
-            <a:ext cx="3200400" cy="320040"/>
+            <a:off x="3108960" y="5550408"/>
+            <a:ext cx="2377440" cy="292608"/>
           </a:xfrm>
           <a:prstGeom prst="rect">
             <a:avLst/>
@@ -9123,14 +9261,14 @@
       </p:sp>
       <p:sp>
         <p:nvSpPr>
-          <p:cNvPr id="29" name="TextBox 28"/>
-          <p:cNvSpPr txBox="1"/>
-          <p:nvPr/>
-        </p:nvSpPr>
-        <p:spPr>
-          <a:xfrm>
-            <a:off x="4023360" y="5541264"/>
-            <a:ext cx="3017520" cy="274320"/>
+          <p:cNvPr id="32" name="TextBox 31"/>
+          <p:cNvSpPr txBox="1"/>
+          <p:nvPr/>
+        </p:nvSpPr>
+        <p:spPr>
+          <a:xfrm>
+            <a:off x="3182112" y="5559552"/>
+            <a:ext cx="2231136" cy="256032"/>
           </a:xfrm>
           <a:prstGeom prst="rect">
             <a:avLst/>
@@ -9144,29 +9282,29 @@
           <a:lstStyle/>
           <a:p>
             <a:pPr algn="l">
-              <a:defRPr sz="1200" b="0">
-                <a:solidFill>
-                  <a:srgbClr val="333333"/>
-                </a:solidFill>
-                <a:latin typeface="Calibri"/>
-              </a:defRPr>
-            </a:pPr>
-            <a:r>
-              <a:t>$21,200/year</a:t>
-            </a:r>
-          </a:p>
-        </p:txBody>
-      </p:sp>
-      <p:sp>
-        <p:nvSpPr>
-          <p:cNvPr id="30" name="Rectangle 29"/>
+              <a:defRPr sz="1100" b="0">
+                <a:solidFill>
+                  <a:srgbClr val="333333"/>
+                </a:solidFill>
+                <a:latin typeface="Calibri"/>
+              </a:defRPr>
+            </a:pPr>
+            <a:r>
+              <a:t>$21,200/yr</a:t>
+            </a:r>
+          </a:p>
+        </p:txBody>
+      </p:sp>
+      <p:sp>
+        <p:nvSpPr>
+          <p:cNvPr id="33" name="Rectangle 32"/>
           <p:cNvSpPr/>
           <p:nvPr/>
         </p:nvSpPr>
         <p:spPr>
           <a:xfrm>
-            <a:off x="7132320" y="5532120"/>
-            <a:ext cx="3200400" cy="320040"/>
+            <a:off x="5486400" y="5550408"/>
+            <a:ext cx="2377440" cy="292608"/>
           </a:xfrm>
           <a:prstGeom prst="rect">
             <a:avLst/>
@@ -9202,14 +9340,14 @@
       </p:sp>
       <p:sp>
         <p:nvSpPr>
-          <p:cNvPr id="31" name="TextBox 30"/>
-          <p:cNvSpPr txBox="1"/>
-          <p:nvPr/>
-        </p:nvSpPr>
-        <p:spPr>
-          <a:xfrm>
-            <a:off x="7223760" y="5541264"/>
-            <a:ext cx="3017520" cy="274320"/>
+          <p:cNvPr id="34" name="TextBox 33"/>
+          <p:cNvSpPr txBox="1"/>
+          <p:nvPr/>
+        </p:nvSpPr>
+        <p:spPr>
+          <a:xfrm>
+            <a:off x="5559552" y="5559552"/>
+            <a:ext cx="2231136" cy="256032"/>
           </a:xfrm>
           <a:prstGeom prst="rect">
             <a:avLst/>
@@ -9223,29 +9361,108 @@
           <a:lstStyle/>
           <a:p>
             <a:pPr algn="l">
-              <a:defRPr sz="1200" b="0">
-                <a:solidFill>
-                  <a:srgbClr val="333333"/>
-                </a:solidFill>
-                <a:latin typeface="Calibri"/>
-              </a:defRPr>
-            </a:pPr>
-            <a:r>
-              <a:t>$30,000/year</a:t>
-            </a:r>
-          </a:p>
-        </p:txBody>
-      </p:sp>
-      <p:sp>
-        <p:nvSpPr>
-          <p:cNvPr id="32" name="Rectangle 31"/>
+              <a:defRPr sz="1100" b="0">
+                <a:solidFill>
+                  <a:srgbClr val="333333"/>
+                </a:solidFill>
+                <a:latin typeface="Calibri"/>
+              </a:defRPr>
+            </a:pPr>
+            <a:r>
+              <a:t>$30,000/yr</a:t>
+            </a:r>
+          </a:p>
+        </p:txBody>
+      </p:sp>
+      <p:sp>
+        <p:nvSpPr>
+          <p:cNvPr id="35" name="Rectangle 34"/>
           <p:cNvSpPr/>
           <p:nvPr/>
         </p:nvSpPr>
         <p:spPr>
           <a:xfrm>
-            <a:off x="1645920" y="5852160"/>
-            <a:ext cx="2286000" cy="320040"/>
+            <a:off x="7863840" y="5550408"/>
+            <a:ext cx="2377440" cy="292608"/>
+          </a:xfrm>
+          <a:prstGeom prst="rect">
+            <a:avLst/>
+          </a:prstGeom>
+          <a:solidFill>
+            <a:srgbClr val="FFFFFF"/>
+          </a:solidFill>
+          <a:ln>
+            <a:noFill/>
+          </a:ln>
+        </p:spPr>
+        <p:style>
+          <a:lnRef idx="1">
+            <a:schemeClr val="accent1"/>
+          </a:lnRef>
+          <a:fillRef idx="3">
+            <a:schemeClr val="accent1"/>
+          </a:fillRef>
+          <a:effectRef idx="2">
+            <a:schemeClr val="accent1"/>
+          </a:effectRef>
+          <a:fontRef idx="minor">
+            <a:schemeClr val="lt1"/>
+          </a:fontRef>
+        </p:style>
+        <p:txBody>
+          <a:bodyPr rtlCol="0" anchor="ctr"/>
+          <a:lstStyle/>
+          <a:p>
+            <a:pPr algn="ctr"/>
+          </a:p>
+        </p:txBody>
+      </p:sp>
+      <p:sp>
+        <p:nvSpPr>
+          <p:cNvPr id="36" name="TextBox 35"/>
+          <p:cNvSpPr txBox="1"/>
+          <p:nvPr/>
+        </p:nvSpPr>
+        <p:spPr>
+          <a:xfrm>
+            <a:off x="7936992" y="5559552"/>
+            <a:ext cx="2231136" cy="256032"/>
+          </a:xfrm>
+          <a:prstGeom prst="rect">
+            <a:avLst/>
+          </a:prstGeom>
+          <a:noFill/>
+        </p:spPr>
+        <p:txBody>
+          <a:bodyPr wrap="square">
+            <a:spAutoFit/>
+          </a:bodyPr>
+          <a:lstStyle/>
+          <a:p>
+            <a:pPr algn="l">
+              <a:defRPr sz="1100" b="0">
+                <a:solidFill>
+                  <a:srgbClr val="333333"/>
+                </a:solidFill>
+                <a:latin typeface="Calibri"/>
+              </a:defRPr>
+            </a:pPr>
+            <a:r>
+              <a:t>$30,000/yr</a:t>
+            </a:r>
+          </a:p>
+        </p:txBody>
+      </p:sp>
+      <p:sp>
+        <p:nvSpPr>
+          <p:cNvPr id="37" name="Rectangle 36"/>
+          <p:cNvSpPr/>
+          <p:nvPr/>
+        </p:nvSpPr>
+        <p:spPr>
+          <a:xfrm>
+            <a:off x="1097280" y="5843016"/>
+            <a:ext cx="2011680" cy="292608"/>
           </a:xfrm>
           <a:prstGeom prst="rect">
             <a:avLst/>
@@ -9281,14 +9498,14 @@
       </p:sp>
       <p:sp>
         <p:nvSpPr>
-          <p:cNvPr id="33" name="TextBox 32"/>
-          <p:cNvSpPr txBox="1"/>
-          <p:nvPr/>
-        </p:nvSpPr>
-        <p:spPr>
-          <a:xfrm>
-            <a:off x="1737360" y="5861304"/>
-            <a:ext cx="2103120" cy="274320"/>
+          <p:cNvPr id="38" name="TextBox 37"/>
+          <p:cNvSpPr txBox="1"/>
+          <p:nvPr/>
+        </p:nvSpPr>
+        <p:spPr>
+          <a:xfrm>
+            <a:off x="1170432" y="5852160"/>
+            <a:ext cx="1865376" cy="256032"/>
           </a:xfrm>
           <a:prstGeom prst="rect">
             <a:avLst/>
@@ -9302,7 +9519,7 @@
           <a:lstStyle/>
           <a:p>
             <a:pPr algn="l">
-              <a:defRPr sz="1200" b="1">
+              <a:defRPr sz="1100" b="1">
                 <a:solidFill>
                   <a:srgbClr val="333333"/>
                 </a:solidFill>
@@ -9317,14 +9534,14 @@
       </p:sp>
       <p:sp>
         <p:nvSpPr>
-          <p:cNvPr id="34" name="Rectangle 33"/>
+          <p:cNvPr id="39" name="Rectangle 38"/>
           <p:cNvSpPr/>
           <p:nvPr/>
         </p:nvSpPr>
         <p:spPr>
           <a:xfrm>
-            <a:off x="3931920" y="5852160"/>
-            <a:ext cx="3200400" cy="320040"/>
+            <a:off x="3108960" y="5843016"/>
+            <a:ext cx="2377440" cy="292608"/>
           </a:xfrm>
           <a:prstGeom prst="rect">
             <a:avLst/>
@@ -9360,14 +9577,14 @@
       </p:sp>
       <p:sp>
         <p:nvSpPr>
-          <p:cNvPr id="35" name="TextBox 34"/>
-          <p:cNvSpPr txBox="1"/>
-          <p:nvPr/>
-        </p:nvSpPr>
-        <p:spPr>
-          <a:xfrm>
-            <a:off x="4023360" y="5861304"/>
-            <a:ext cx="3017520" cy="274320"/>
+          <p:cNvPr id="40" name="TextBox 39"/>
+          <p:cNvSpPr txBox="1"/>
+          <p:nvPr/>
+        </p:nvSpPr>
+        <p:spPr>
+          <a:xfrm>
+            <a:off x="3182112" y="5852160"/>
+            <a:ext cx="2231136" cy="256032"/>
           </a:xfrm>
           <a:prstGeom prst="rect">
             <a:avLst/>
@@ -9381,7 +9598,7 @@
           <a:lstStyle/>
           <a:p>
             <a:pPr algn="l">
-              <a:defRPr sz="1200" b="0">
+              <a:defRPr sz="1100" b="0">
                 <a:solidFill>
                   <a:srgbClr val="333333"/>
                 </a:solidFill>
@@ -9396,14 +9613,14 @@
       </p:sp>
       <p:sp>
         <p:nvSpPr>
-          <p:cNvPr id="36" name="Rectangle 35"/>
+          <p:cNvPr id="41" name="Rectangle 40"/>
           <p:cNvSpPr/>
           <p:nvPr/>
         </p:nvSpPr>
         <p:spPr>
           <a:xfrm>
-            <a:off x="7132320" y="5852160"/>
-            <a:ext cx="3200400" cy="320040"/>
+            <a:off x="5486400" y="5843016"/>
+            <a:ext cx="2377440" cy="292608"/>
           </a:xfrm>
           <a:prstGeom prst="rect">
             <a:avLst/>
@@ -9439,14 +9656,14 @@
       </p:sp>
       <p:sp>
         <p:nvSpPr>
-          <p:cNvPr id="37" name="TextBox 36"/>
-          <p:cNvSpPr txBox="1"/>
-          <p:nvPr/>
-        </p:nvSpPr>
-        <p:spPr>
-          <a:xfrm>
-            <a:off x="7223760" y="5861304"/>
-            <a:ext cx="3017520" cy="274320"/>
+          <p:cNvPr id="42" name="TextBox 41"/>
+          <p:cNvSpPr txBox="1"/>
+          <p:nvPr/>
+        </p:nvSpPr>
+        <p:spPr>
+          <a:xfrm>
+            <a:off x="5559552" y="5852160"/>
+            <a:ext cx="2231136" cy="256032"/>
           </a:xfrm>
           <a:prstGeom prst="rect">
             <a:avLst/>
@@ -9460,7 +9677,7 @@
           <a:lstStyle/>
           <a:p>
             <a:pPr algn="l">
-              <a:defRPr sz="1200" b="0">
+              <a:defRPr sz="1100" b="0">
                 <a:solidFill>
                   <a:srgbClr val="333333"/>
                 </a:solidFill>
@@ -9475,14 +9692,93 @@
       </p:sp>
       <p:sp>
         <p:nvSpPr>
-          <p:cNvPr id="38" name="Rectangle 37"/>
+          <p:cNvPr id="43" name="Rectangle 42"/>
           <p:cNvSpPr/>
           <p:nvPr/>
         </p:nvSpPr>
         <p:spPr>
           <a:xfrm>
-            <a:off x="1645920" y="6172200"/>
-            <a:ext cx="2286000" cy="320040"/>
+            <a:off x="7863840" y="5843016"/>
+            <a:ext cx="2377440" cy="292608"/>
+          </a:xfrm>
+          <a:prstGeom prst="rect">
+            <a:avLst/>
+          </a:prstGeom>
+          <a:solidFill>
+            <a:srgbClr val="F2F2F2"/>
+          </a:solidFill>
+          <a:ln>
+            <a:noFill/>
+          </a:ln>
+        </p:spPr>
+        <p:style>
+          <a:lnRef idx="1">
+            <a:schemeClr val="accent1"/>
+          </a:lnRef>
+          <a:fillRef idx="3">
+            <a:schemeClr val="accent1"/>
+          </a:fillRef>
+          <a:effectRef idx="2">
+            <a:schemeClr val="accent1"/>
+          </a:effectRef>
+          <a:fontRef idx="minor">
+            <a:schemeClr val="lt1"/>
+          </a:fontRef>
+        </p:style>
+        <p:txBody>
+          <a:bodyPr rtlCol="0" anchor="ctr"/>
+          <a:lstStyle/>
+          <a:p>
+            <a:pPr algn="ctr"/>
+          </a:p>
+        </p:txBody>
+      </p:sp>
+      <p:sp>
+        <p:nvSpPr>
+          <p:cNvPr id="44" name="TextBox 43"/>
+          <p:cNvSpPr txBox="1"/>
+          <p:nvPr/>
+        </p:nvSpPr>
+        <p:spPr>
+          <a:xfrm>
+            <a:off x="7936992" y="5852160"/>
+            <a:ext cx="2231136" cy="256032"/>
+          </a:xfrm>
+          <a:prstGeom prst="rect">
+            <a:avLst/>
+          </a:prstGeom>
+          <a:noFill/>
+        </p:spPr>
+        <p:txBody>
+          <a:bodyPr wrap="square">
+            <a:spAutoFit/>
+          </a:bodyPr>
+          <a:lstStyle/>
+          <a:p>
+            <a:pPr algn="l">
+              <a:defRPr sz="1100" b="0">
+                <a:solidFill>
+                  <a:srgbClr val="333333"/>
+                </a:solidFill>
+                <a:latin typeface="Calibri"/>
+              </a:defRPr>
+            </a:pPr>
+            <a:r>
+              <a:t>$145,000</a:t>
+            </a:r>
+          </a:p>
+        </p:txBody>
+      </p:sp>
+      <p:sp>
+        <p:nvSpPr>
+          <p:cNvPr id="45" name="Rectangle 44"/>
+          <p:cNvSpPr/>
+          <p:nvPr/>
+        </p:nvSpPr>
+        <p:spPr>
+          <a:xfrm>
+            <a:off x="1097280" y="6135624"/>
+            <a:ext cx="2011680" cy="292608"/>
           </a:xfrm>
           <a:prstGeom prst="rect">
             <a:avLst/>
@@ -9518,14 +9814,14 @@
       </p:sp>
       <p:sp>
         <p:nvSpPr>
-          <p:cNvPr id="39" name="TextBox 38"/>
-          <p:cNvSpPr txBox="1"/>
-          <p:nvPr/>
-        </p:nvSpPr>
-        <p:spPr>
-          <a:xfrm>
-            <a:off x="1737360" y="6181344"/>
-            <a:ext cx="2103120" cy="274320"/>
+          <p:cNvPr id="46" name="TextBox 45"/>
+          <p:cNvSpPr txBox="1"/>
+          <p:nvPr/>
+        </p:nvSpPr>
+        <p:spPr>
+          <a:xfrm>
+            <a:off x="1170432" y="6144768"/>
+            <a:ext cx="1865376" cy="256032"/>
           </a:xfrm>
           <a:prstGeom prst="rect">
             <a:avLst/>
@@ -9539,7 +9835,7 @@
           <a:lstStyle/>
           <a:p>
             <a:pPr algn="l">
-              <a:defRPr sz="1200" b="1">
+              <a:defRPr sz="1100" b="1">
                 <a:solidFill>
                   <a:srgbClr val="333333"/>
                 </a:solidFill>
@@ -9554,14 +9850,14 @@
       </p:sp>
       <p:sp>
         <p:nvSpPr>
-          <p:cNvPr id="40" name="Rectangle 39"/>
+          <p:cNvPr id="47" name="Rectangle 46"/>
           <p:cNvSpPr/>
           <p:nvPr/>
         </p:nvSpPr>
         <p:spPr>
           <a:xfrm>
-            <a:off x="3931920" y="6172200"/>
-            <a:ext cx="3200400" cy="320040"/>
+            <a:off x="3108960" y="6135624"/>
+            <a:ext cx="2377440" cy="292608"/>
           </a:xfrm>
           <a:prstGeom prst="rect">
             <a:avLst/>
@@ -9597,14 +9893,14 @@
       </p:sp>
       <p:sp>
         <p:nvSpPr>
-          <p:cNvPr id="41" name="TextBox 40"/>
-          <p:cNvSpPr txBox="1"/>
-          <p:nvPr/>
-        </p:nvSpPr>
-        <p:spPr>
-          <a:xfrm>
-            <a:off x="4023360" y="6181344"/>
-            <a:ext cx="3017520" cy="274320"/>
+          <p:cNvPr id="48" name="TextBox 47"/>
+          <p:cNvSpPr txBox="1"/>
+          <p:nvPr/>
+        </p:nvSpPr>
+        <p:spPr>
+          <a:xfrm>
+            <a:off x="3182112" y="6144768"/>
+            <a:ext cx="2231136" cy="256032"/>
           </a:xfrm>
           <a:prstGeom prst="rect">
             <a:avLst/>
@@ -9618,7 +9914,7 @@
           <a:lstStyle/>
           <a:p>
             <a:pPr algn="l">
-              <a:defRPr sz="1200" b="0">
+              <a:defRPr sz="1100" b="0">
                 <a:solidFill>
                   <a:srgbClr val="333333"/>
                 </a:solidFill>
@@ -9633,14 +9929,14 @@
       </p:sp>
       <p:sp>
         <p:nvSpPr>
-          <p:cNvPr id="42" name="Rectangle 41"/>
+          <p:cNvPr id="49" name="Rectangle 48"/>
           <p:cNvSpPr/>
           <p:nvPr/>
         </p:nvSpPr>
         <p:spPr>
           <a:xfrm>
-            <a:off x="7132320" y="6172200"/>
-            <a:ext cx="3200400" cy="320040"/>
+            <a:off x="5486400" y="6135624"/>
+            <a:ext cx="2377440" cy="292608"/>
           </a:xfrm>
           <a:prstGeom prst="rect">
             <a:avLst/>
@@ -9676,14 +9972,14 @@
       </p:sp>
       <p:sp>
         <p:nvSpPr>
-          <p:cNvPr id="43" name="TextBox 42"/>
-          <p:cNvSpPr txBox="1"/>
-          <p:nvPr/>
-        </p:nvSpPr>
-        <p:spPr>
-          <a:xfrm>
-            <a:off x="7223760" y="6181344"/>
-            <a:ext cx="3017520" cy="274320"/>
+          <p:cNvPr id="50" name="TextBox 49"/>
+          <p:cNvSpPr txBox="1"/>
+          <p:nvPr/>
+        </p:nvSpPr>
+        <p:spPr>
+          <a:xfrm>
+            <a:off x="5559552" y="6144768"/>
+            <a:ext cx="2231136" cy="256032"/>
           </a:xfrm>
           <a:prstGeom prst="rect">
             <a:avLst/>
@@ -9697,7 +9993,7 @@
           <a:lstStyle/>
           <a:p>
             <a:pPr algn="l">
-              <a:defRPr sz="1200" b="0">
+              <a:defRPr sz="1100" b="0">
                 <a:solidFill>
                   <a:srgbClr val="333333"/>
                 </a:solidFill>
@@ -9712,14 +10008,93 @@
       </p:sp>
       <p:sp>
         <p:nvSpPr>
-          <p:cNvPr id="44" name="Rectangle 43"/>
+          <p:cNvPr id="51" name="Rectangle 50"/>
           <p:cNvSpPr/>
           <p:nvPr/>
         </p:nvSpPr>
         <p:spPr>
           <a:xfrm>
-            <a:off x="1645920" y="6492240"/>
-            <a:ext cx="2286000" cy="320040"/>
+            <a:off x="7863840" y="6135624"/>
+            <a:ext cx="2377440" cy="292608"/>
+          </a:xfrm>
+          <a:prstGeom prst="rect">
+            <a:avLst/>
+          </a:prstGeom>
+          <a:solidFill>
+            <a:srgbClr val="FFFFFF"/>
+          </a:solidFill>
+          <a:ln>
+            <a:noFill/>
+          </a:ln>
+        </p:spPr>
+        <p:style>
+          <a:lnRef idx="1">
+            <a:schemeClr val="accent1"/>
+          </a:lnRef>
+          <a:fillRef idx="3">
+            <a:schemeClr val="accent1"/>
+          </a:fillRef>
+          <a:effectRef idx="2">
+            <a:schemeClr val="accent1"/>
+          </a:effectRef>
+          <a:fontRef idx="minor">
+            <a:schemeClr val="lt1"/>
+          </a:fontRef>
+        </p:style>
+        <p:txBody>
+          <a:bodyPr rtlCol="0" anchor="ctr"/>
+          <a:lstStyle/>
+          <a:p>
+            <a:pPr algn="ctr"/>
+          </a:p>
+        </p:txBody>
+      </p:sp>
+      <p:sp>
+        <p:nvSpPr>
+          <p:cNvPr id="52" name="TextBox 51"/>
+          <p:cNvSpPr txBox="1"/>
+          <p:nvPr/>
+        </p:nvSpPr>
+        <p:spPr>
+          <a:xfrm>
+            <a:off x="7936992" y="6144768"/>
+            <a:ext cx="2231136" cy="256032"/>
+          </a:xfrm>
+          <a:prstGeom prst="rect">
+            <a:avLst/>
+          </a:prstGeom>
+          <a:noFill/>
+        </p:spPr>
+        <p:txBody>
+          <a:bodyPr wrap="square">
+            <a:spAutoFit/>
+          </a:bodyPr>
+          <a:lstStyle/>
+          <a:p>
+            <a:pPr algn="l">
+              <a:defRPr sz="1100" b="0">
+                <a:solidFill>
+                  <a:srgbClr val="333333"/>
+                </a:solidFill>
+                <a:latin typeface="Calibri"/>
+              </a:defRPr>
+            </a:pPr>
+            <a:r>
+              <a:t>$205,000</a:t>
+            </a:r>
+          </a:p>
+        </p:txBody>
+      </p:sp>
+      <p:sp>
+        <p:nvSpPr>
+          <p:cNvPr id="53" name="Rectangle 52"/>
+          <p:cNvSpPr/>
+          <p:nvPr/>
+        </p:nvSpPr>
+        <p:spPr>
+          <a:xfrm>
+            <a:off x="1097280" y="6428232"/>
+            <a:ext cx="2011680" cy="292608"/>
           </a:xfrm>
           <a:prstGeom prst="rect">
             <a:avLst/>
@@ -9755,14 +10130,14 @@
       </p:sp>
       <p:sp>
         <p:nvSpPr>
-          <p:cNvPr id="45" name="TextBox 44"/>
-          <p:cNvSpPr txBox="1"/>
-          <p:nvPr/>
-        </p:nvSpPr>
-        <p:spPr>
-          <a:xfrm>
-            <a:off x="1737360" y="6501384"/>
-            <a:ext cx="2103120" cy="274320"/>
+          <p:cNvPr id="54" name="TextBox 53"/>
+          <p:cNvSpPr txBox="1"/>
+          <p:nvPr/>
+        </p:nvSpPr>
+        <p:spPr>
+          <a:xfrm>
+            <a:off x="1170432" y="6437376"/>
+            <a:ext cx="1865376" cy="256032"/>
           </a:xfrm>
           <a:prstGeom prst="rect">
             <a:avLst/>
@@ -9776,7 +10151,7 @@
           <a:lstStyle/>
           <a:p>
             <a:pPr algn="l">
-              <a:defRPr sz="1200" b="1">
+              <a:defRPr sz="1100" b="1">
                 <a:solidFill>
                   <a:srgbClr val="333333"/>
                 </a:solidFill>
@@ -9791,14 +10166,14 @@
       </p:sp>
       <p:sp>
         <p:nvSpPr>
-          <p:cNvPr id="46" name="Rectangle 45"/>
+          <p:cNvPr id="55" name="Rectangle 54"/>
           <p:cNvSpPr/>
           <p:nvPr/>
         </p:nvSpPr>
         <p:spPr>
           <a:xfrm>
-            <a:off x="3931920" y="6492240"/>
-            <a:ext cx="3200400" cy="320040"/>
+            <a:off x="3108960" y="6428232"/>
+            <a:ext cx="2377440" cy="292608"/>
           </a:xfrm>
           <a:prstGeom prst="rect">
             <a:avLst/>
@@ -9834,14 +10209,14 @@
       </p:sp>
       <p:sp>
         <p:nvSpPr>
-          <p:cNvPr id="47" name="TextBox 46"/>
-          <p:cNvSpPr txBox="1"/>
-          <p:nvPr/>
-        </p:nvSpPr>
-        <p:spPr>
-          <a:xfrm>
-            <a:off x="4023360" y="6501384"/>
-            <a:ext cx="3017520" cy="274320"/>
+          <p:cNvPr id="56" name="TextBox 55"/>
+          <p:cNvSpPr txBox="1"/>
+          <p:nvPr/>
+        </p:nvSpPr>
+        <p:spPr>
+          <a:xfrm>
+            <a:off x="3182112" y="6437376"/>
+            <a:ext cx="2231136" cy="256032"/>
           </a:xfrm>
           <a:prstGeom prst="rect">
             <a:avLst/>
@@ -9855,29 +10230,29 @@
           <a:lstStyle/>
           <a:p>
             <a:pPr algn="l">
-              <a:defRPr sz="1200" b="0">
-                <a:solidFill>
-                  <a:srgbClr val="333333"/>
-                </a:solidFill>
-                <a:latin typeface="Calibri"/>
-              </a:defRPr>
-            </a:pPr>
-            <a:r>
-              <a:t>Yes — you own it</a:t>
-            </a:r>
-          </a:p>
-        </p:txBody>
-      </p:sp>
-      <p:sp>
-        <p:nvSpPr>
-          <p:cNvPr id="48" name="Rectangle 47"/>
+              <a:defRPr sz="1100" b="0">
+                <a:solidFill>
+                  <a:srgbClr val="333333"/>
+                </a:solidFill>
+                <a:latin typeface="Calibri"/>
+              </a:defRPr>
+            </a:pPr>
+            <a:r>
+              <a:t>Full</a:t>
+            </a:r>
+          </a:p>
+        </p:txBody>
+      </p:sp>
+      <p:sp>
+        <p:nvSpPr>
+          <p:cNvPr id="57" name="Rectangle 56"/>
           <p:cNvSpPr/>
           <p:nvPr/>
         </p:nvSpPr>
         <p:spPr>
           <a:xfrm>
-            <a:off x="7132320" y="6492240"/>
-            <a:ext cx="3200400" cy="320040"/>
+            <a:off x="5486400" y="6428232"/>
+            <a:ext cx="2377440" cy="292608"/>
           </a:xfrm>
           <a:prstGeom prst="rect">
             <a:avLst/>
@@ -9913,14 +10288,14 @@
       </p:sp>
       <p:sp>
         <p:nvSpPr>
-          <p:cNvPr id="49" name="TextBox 48"/>
-          <p:cNvSpPr txBox="1"/>
-          <p:nvPr/>
-        </p:nvSpPr>
-        <p:spPr>
-          <a:xfrm>
-            <a:off x="7223760" y="6501384"/>
-            <a:ext cx="3017520" cy="274320"/>
+          <p:cNvPr id="58" name="TextBox 57"/>
+          <p:cNvSpPr txBox="1"/>
+          <p:nvPr/>
+        </p:nvSpPr>
+        <p:spPr>
+          <a:xfrm>
+            <a:off x="5559552" y="6437376"/>
+            <a:ext cx="2231136" cy="256032"/>
           </a:xfrm>
           <a:prstGeom prst="rect">
             <a:avLst/>
@@ -9934,15 +10309,94 @@
           <a:lstStyle/>
           <a:p>
             <a:pPr algn="l">
-              <a:defRPr sz="1200" b="0">
-                <a:solidFill>
-                  <a:srgbClr val="333333"/>
-                </a:solidFill>
-                <a:latin typeface="Calibri"/>
-              </a:defRPr>
-            </a:pPr>
-            <a:r>
-              <a:t>No — IoTeye retains</a:t>
+              <a:defRPr sz="1100" b="0">
+                <a:solidFill>
+                  <a:srgbClr val="333333"/>
+                </a:solidFill>
+                <a:latin typeface="Calibri"/>
+              </a:defRPr>
+            </a:pPr>
+            <a:r>
+              <a:t>None</a:t>
+            </a:r>
+          </a:p>
+        </p:txBody>
+      </p:sp>
+      <p:sp>
+        <p:nvSpPr>
+          <p:cNvPr id="59" name="Rectangle 58"/>
+          <p:cNvSpPr/>
+          <p:nvPr/>
+        </p:nvSpPr>
+        <p:spPr>
+          <a:xfrm>
+            <a:off x="7863840" y="6428232"/>
+            <a:ext cx="2377440" cy="292608"/>
+          </a:xfrm>
+          <a:prstGeom prst="rect">
+            <a:avLst/>
+          </a:prstGeom>
+          <a:solidFill>
+            <a:srgbClr val="F2F2F2"/>
+          </a:solidFill>
+          <a:ln>
+            <a:noFill/>
+          </a:ln>
+        </p:spPr>
+        <p:style>
+          <a:lnRef idx="1">
+            <a:schemeClr val="accent1"/>
+          </a:lnRef>
+          <a:fillRef idx="3">
+            <a:schemeClr val="accent1"/>
+          </a:fillRef>
+          <a:effectRef idx="2">
+            <a:schemeClr val="accent1"/>
+          </a:effectRef>
+          <a:fontRef idx="minor">
+            <a:schemeClr val="lt1"/>
+          </a:fontRef>
+        </p:style>
+        <p:txBody>
+          <a:bodyPr rtlCol="0" anchor="ctr"/>
+          <a:lstStyle/>
+          <a:p>
+            <a:pPr algn="ctr"/>
+          </a:p>
+        </p:txBody>
+      </p:sp>
+      <p:sp>
+        <p:nvSpPr>
+          <p:cNvPr id="60" name="TextBox 59"/>
+          <p:cNvSpPr txBox="1"/>
+          <p:nvPr/>
+        </p:nvSpPr>
+        <p:spPr>
+          <a:xfrm>
+            <a:off x="7936992" y="6437376"/>
+            <a:ext cx="2231136" cy="256032"/>
+          </a:xfrm>
+          <a:prstGeom prst="rect">
+            <a:avLst/>
+          </a:prstGeom>
+          <a:noFill/>
+        </p:spPr>
+        <p:txBody>
+          <a:bodyPr wrap="square">
+            <a:spAutoFit/>
+          </a:bodyPr>
+          <a:lstStyle/>
+          <a:p>
+            <a:pPr algn="l">
+              <a:defRPr sz="1100" b="0">
+                <a:solidFill>
+                  <a:srgbClr val="333333"/>
+                </a:solidFill>
+                <a:latin typeface="Calibri"/>
+              </a:defRPr>
+            </a:pPr>
+            <a:r>
+              <a:t>Recognition only</a:t>
             </a:r>
           </a:p>
         </p:txBody>

</xml_diff>

<commit_message>
Update Option C to 50/50 shared ownership of recognition platform code (DB & infra remain Arc Mercer sole ownership)
</commit_message>
<xml_diff>
--- a/RFP/IoTeye - Arc Mercer Pitch.pptx
+++ b/RFP/IoTeye - Arc Mercer Pitch.pptx
@@ -8356,7 +8356,7 @@
               </a:defRPr>
             </a:pPr>
             <a:r>
-              <a:t>• Arc Mercer owns recognition platform code</a:t>
+              <a:t>• Arc Mercer &amp; IoTeye share recognition platform code (50/50)</a:t>
             </a:r>
           </a:p>
           <a:p>
@@ -10396,7 +10396,7 @@
               </a:defRPr>
             </a:pPr>
             <a:r>
-              <a:t>Recognition only</a:t>
+              <a:t>50/50 recognition</a:t>
             </a:r>
           </a:p>
         </p:txBody>

</xml_diff>

<commit_message>
Align pitch deck add-on banners with proposal: AI-assisted only, major redesigns not covered
</commit_message>
<xml_diff>
--- a/RFP/IoTeye - Arc Mercer Pitch.pptx
+++ b/RFP/IoTeye - Arc Mercer Pitch.pptx
@@ -7919,7 +7919,7 @@
               </a:defRPr>
             </a:pPr>
             <a:r>
-              <a:t>★  All add-ons INCLUDED at $0  —  only AI LLM usage fee applies (billed at cost, pass-through)</a:t>
+              <a:t>★  AI-assisted add-ons INCLUDED — LLM usage fee only (pass-through)  |  Major redesigns not covered  ★</a:t>
             </a:r>
           </a:p>
         </p:txBody>
@@ -8467,7 +8467,7 @@
               </a:defRPr>
             </a:pPr>
             <a:r>
-              <a:t>★  AI-assisted add-ons INCLUDED — LLM usage fee only (pass-through)  |  Major redesigns quoted separately  ★</a:t>
+              <a:t>★  AI-assisted add-ons INCLUDED — LLM usage fee only (pass-through)  |  Major redesigns not covered  ★</a:t>
             </a:r>
           </a:p>
         </p:txBody>
@@ -14014,7 +14014,7 @@
               </a:defRPr>
             </a:pPr>
             <a:r>
-              <a:t>• All add-ons FREE — pay only AI LLM usage (pass-through)</a:t>
+              <a:t>• AI-assisted add-ons FREE — pay only AI LLM usage (pass-through)</a:t>
             </a:r>
           </a:p>
         </p:txBody>

</xml_diff>

<commit_message>
Slide 16: shorten reuse rights text; Slide 18: add Option C to pricing selection
</commit_message>
<xml_diff>
--- a/RFP/IoTeye - Arc Mercer Pitch.pptx
+++ b/RFP/IoTeye - Arc Mercer Pitch.pptx
@@ -8388,7 +8388,7 @@
               </a:defRPr>
             </a:pPr>
             <a:r>
-              <a:t>• Reuse rights deferred to legal agreement</a:t>
+              <a:t>• Reuse rights deferred to agreement</a:t>
             </a:r>
           </a:p>
         </p:txBody>
@@ -14089,7 +14089,7 @@
               </a:defRPr>
             </a:pPr>
             <a:r>
-              <a:t>• Select pricing option (A or B)</a:t>
+              <a:t>• Select pricing option (A, B, or C)</a:t>
             </a:r>
           </a:p>
           <a:p>

</xml_diff>

<commit_message>
Add Guardian authentication to login Path 3 on Paycom & SSO slide
</commit_message>
<xml_diff>
--- a/RFP/IoTeye - Arc Mercer Pitch.pptx
+++ b/RFP/IoTeye - Arc Mercer Pitch.pptx
@@ -4469,7 +4469,7 @@
         <p:spPr>
           <a:xfrm>
             <a:off x="6400800" y="4434840"/>
-            <a:ext cx="5029200" cy="640080"/>
+            <a:ext cx="5029200" cy="822960"/>
           </a:xfrm>
           <a:prstGeom prst="rect">
             <a:avLst/>
@@ -4548,7 +4548,7 @@
         <p:spPr>
           <a:xfrm>
             <a:off x="6537960" y="4800600"/>
-            <a:ext cx="4754880" cy="274320"/>
+            <a:ext cx="4754880" cy="457200"/>
           </a:xfrm>
           <a:prstGeom prst="rect">
             <a:avLst/>
@@ -4562,6 +4562,9 @@
           <a:lstStyle/>
           <a:p>
             <a:pPr algn="l">
+              <a:spcAft>
+                <a:spcPts val="400"/>
+              </a:spcAft>
               <a:defRPr sz="1300" b="0">
                 <a:solidFill>
                   <a:srgbClr val="333333"/>
@@ -4570,7 +4573,23 @@
               </a:defRPr>
             </a:pPr>
             <a:r>
-              <a:t>For part-time or seasonal staff with email but not on SSO</a:t>
+              <a:t>• For part-time or seasonal staff with email but not on SSO</a:t>
+            </a:r>
+          </a:p>
+          <a:p>
+            <a:pPr>
+              <a:spcAft>
+                <a:spcPts val="400"/>
+              </a:spcAft>
+              <a:defRPr sz="1300">
+                <a:solidFill>
+                  <a:srgbClr val="333333"/>
+                </a:solidFill>
+                <a:latin typeface="Calibri"/>
+              </a:defRPr>
+            </a:pPr>
+            <a:r>
+              <a:t>• Guardian authentication</a:t>
             </a:r>
           </a:p>
         </p:txBody>

</xml_diff>

<commit_message>
Tighten slide 17 Why IoTeye: strategic alliance and flexible pricing, remove feature details
</commit_message>
<xml_diff>
--- a/RFP/IoTeye - Arc Mercer Pitch.pptx
+++ b/RFP/IoTeye - Arc Mercer Pitch.pptx
@@ -13427,7 +13427,7 @@
           <a:p>
             <a:pPr algn="l">
               <a:spcAft>
-                <a:spcPts val="700"/>
+                <a:spcPts val="1000"/>
               </a:spcAft>
               <a:defRPr sz="1400" b="0">
                 <a:solidFill>
@@ -13443,7 +13443,7 @@
           <a:p>
             <a:pPr>
               <a:spcAft>
-                <a:spcPts val="700"/>
+                <a:spcPts val="1000"/>
               </a:spcAft>
               <a:defRPr sz="1400">
                 <a:solidFill>
@@ -13453,13 +13453,13 @@
               </a:defRPr>
             </a:pPr>
             <a:r>
-              <a:t>• Arc Mercer is an existing SpringBoard &amp; Guardian customer</a:t>
+              <a:t>• Arc Mercer is an existing IoTeye customer (SpringBoard &amp; Guardian)</a:t>
             </a:r>
           </a:p>
           <a:p>
             <a:pPr>
               <a:spcAft>
-                <a:spcPts val="700"/>
+                <a:spcPts val="1000"/>
               </a:spcAft>
               <a:defRPr sz="1400">
                 <a:solidFill>
@@ -13469,13 +13469,13 @@
               </a:defRPr>
             </a:pPr>
             <a:r>
-              <a:t>• BrainClaw AI agents already running at Arc Mercer (37+57 tools)</a:t>
+              <a:t>• BrainClaw AI agents already in production at Arc Mercer (37+57 tools)</a:t>
             </a:r>
           </a:p>
           <a:p>
             <a:pPr>
               <a:spcAft>
-                <a:spcPts val="700"/>
+                <a:spcPts val="1000"/>
               </a:spcAft>
               <a:defRPr sz="1400">
                 <a:solidFill>
@@ -13485,13 +13485,13 @@
               </a:defRPr>
             </a:pPr>
             <a:r>
-              <a:t>• Badge ID + PIN login for frontline staff without email</a:t>
+              <a:t>• Unified vendor — one partner for operations, engagement</a:t>
             </a:r>
           </a:p>
           <a:p>
             <a:pPr>
               <a:spcAft>
-                <a:spcPts val="700"/>
+                <a:spcPts val="1000"/>
               </a:spcAft>
               <a:defRPr sz="1400">
                 <a:solidFill>
@@ -13501,77 +13501,13 @@
               </a:defRPr>
             </a:pPr>
             <a:r>
-              <a:t>• Ranked-choice committee voting — matching your current process</a:t>
+              <a:t>• Three flexible pricing options: full ownership, SaaS, or shared (50/50)</a:t>
             </a:r>
           </a:p>
           <a:p>
             <a:pPr>
               <a:spcAft>
-                <a:spcPts val="700"/>
-              </a:spcAft>
-              <a:defRPr sz="1400">
-                <a:solidFill>
-                  <a:srgbClr val="333333"/>
-                </a:solidFill>
-                <a:latin typeface="Calibri"/>
-              </a:defRPr>
-            </a:pPr>
-            <a:r>
-              <a:t>• Full engagement suite: TAC RSVP, culture groups, volunteering</a:t>
-            </a:r>
-          </a:p>
-          <a:p>
-            <a:pPr>
-              <a:spcAft>
-                <a:spcPts val="700"/>
-              </a:spcAft>
-              <a:defRPr sz="1400">
-                <a:solidFill>
-                  <a:srgbClr val="333333"/>
-                </a:solidFill>
-                <a:latin typeface="Calibri"/>
-              </a:defRPr>
-            </a:pPr>
-            <a:r>
-              <a:t>• Café cashier screen + in-person store QR redemption</a:t>
-            </a:r>
-          </a:p>
-          <a:p>
-            <a:pPr>
-              <a:spcAft>
-                <a:spcPts val="700"/>
-              </a:spcAft>
-              <a:defRPr sz="1400">
-                <a:solidFill>
-                  <a:srgbClr val="333333"/>
-                </a:solidFill>
-                <a:latin typeface="Calibri"/>
-              </a:defRPr>
-            </a:pPr>
-            <a:r>
-              <a:t>• Dark mode for night-shift staff at group homes</a:t>
-            </a:r>
-          </a:p>
-          <a:p>
-            <a:pPr>
-              <a:spcAft>
-                <a:spcPts val="700"/>
-              </a:spcAft>
-              <a:defRPr sz="1400">
-                <a:solidFill>
-                  <a:srgbClr val="333333"/>
-                </a:solidFill>
-                <a:latin typeface="Calibri"/>
-              </a:defRPr>
-            </a:pPr>
-            <a:r>
-              <a:t>• WCAG AAA accessibility — 7:1 contrast, screen reader tested</a:t>
-            </a:r>
-          </a:p>
-          <a:p>
-            <a:pPr>
-              <a:spcAft>
-                <a:spcPts val="700"/>
+                <a:spcPts val="1000"/>
               </a:spcAft>
               <a:defRPr sz="1400">
                 <a:solidFill>

</xml_diff>

<commit_message>
Slide 16: align Advantages frame with table, bigger green banner with font size 20
</commit_message>
<xml_diff>
--- a/RFP/IoTeye - Arc Mercer Pitch.pptx
+++ b/RFP/IoTeye - Arc Mercer Pitch.pptx
@@ -12962,7 +12962,7 @@
         <p:spPr>
           <a:xfrm>
             <a:off x="7863840" y="1645920"/>
-            <a:ext cx="4023360" cy="4114800"/>
+            <a:ext cx="4023360" cy="3456432"/>
           </a:xfrm>
           <a:prstGeom prst="rect">
             <a:avLst/>
@@ -13041,7 +13041,7 @@
         <p:spPr>
           <a:xfrm>
             <a:off x="8046720" y="2194560"/>
-            <a:ext cx="3657600" cy="3383280"/>
+            <a:ext cx="3657600" cy="2724912"/>
           </a:xfrm>
           <a:prstGeom prst="rect">
             <a:avLst/>
@@ -13191,8 +13191,8 @@
         </p:nvSpPr>
         <p:spPr>
           <a:xfrm>
-            <a:off x="0" y="5943600"/>
-            <a:ext cx="12191695" cy="640080"/>
+            <a:off x="0" y="5669280"/>
+            <a:ext cx="12191695" cy="914400"/>
           </a:xfrm>
           <a:prstGeom prst="rect">
             <a:avLst/>
@@ -13234,8 +13234,8 @@
         </p:nvSpPr>
         <p:spPr>
           <a:xfrm>
-            <a:off x="457200" y="5989320"/>
-            <a:ext cx="10972800" cy="548640"/>
+            <a:off x="457200" y="5760720"/>
+            <a:ext cx="10972800" cy="731520"/>
           </a:xfrm>
           <a:prstGeom prst="rect">
             <a:avLst/>
@@ -13249,7 +13249,7 @@
           <a:lstStyle/>
           <a:p>
             <a:pPr algn="ctr">
-              <a:defRPr sz="1600" b="1">
+              <a:defRPr sz="2000" b="1">
                 <a:solidFill>
                   <a:srgbClr val="FFFFFF"/>
                 </a:solidFill>

</xml_diff>

<commit_message>
Soften add-on banner tone: 'Major redesigns not covered' → 'Custom development available upon request'
</commit_message>
<xml_diff>
--- a/RFP/IoTeye - Arc Mercer Pitch.pptx
+++ b/RFP/IoTeye - Arc Mercer Pitch.pptx
@@ -7486,7 +7486,7 @@
               </a:defRPr>
             </a:pPr>
             <a:r>
-              <a:t>★  AI-assisted add-ons INCLUDED — LLM usage fee only (pass-through)  |  Major redesigns not covered  ★</a:t>
+              <a:t>★  AI-assisted add-ons INCLUDED — LLM usage fee only (pass-through)  |  Custom development available upon request  ★</a:t>
             </a:r>
           </a:p>
         </p:txBody>
@@ -8034,7 +8034,7 @@
               </a:defRPr>
             </a:pPr>
             <a:r>
-              <a:t>★  AI-assisted add-ons INCLUDED — LLM usage fee only (pass-through)  |  Major redesigns not covered  ★</a:t>
+              <a:t>★  AI-assisted add-ons INCLUDED — LLM usage fee only (pass-through)  |  Custom development available upon request  ★</a:t>
             </a:r>
           </a:p>
         </p:txBody>

</xml_diff>

<commit_message>
Update Option B & C pricing in pitch deck to match proposal: ,000/yr annual fee
</commit_message>
<xml_diff>
--- a/RFP/IoTeye - Arc Mercer Pitch.pptx
+++ b/RFP/IoTeye - Arc Mercer Pitch.pptx
@@ -7725,7 +7725,7 @@
               </a:defRPr>
             </a:pPr>
             <a:r>
-              <a:t>• Subscription: $2,500/month ($30,000/year)</a:t>
+              <a:t>• Subscription: $3,000/month ($36,000/year)</a:t>
             </a:r>
           </a:p>
           <a:p>
@@ -7907,7 +7907,7 @@
               </a:defRPr>
             </a:pPr>
             <a:r>
-              <a:t>• Annual platform fee: $30,000/year (managed service)</a:t>
+              <a:t>• Annual platform fee: $36,000/year (managed service)</a:t>
             </a:r>
           </a:p>
           <a:p>
@@ -8936,7 +8936,7 @@
               </a:defRPr>
             </a:pPr>
             <a:r>
-              <a:t>$30,000/yr</a:t>
+              <a:t>$36,000/yr</a:t>
             </a:r>
           </a:p>
         </p:txBody>
@@ -9015,7 +9015,7 @@
               </a:defRPr>
             </a:pPr>
             <a:r>
-              <a:t>$30,000/yr</a:t>
+              <a:t>$36,000/yr</a:t>
             </a:r>
           </a:p>
         </p:txBody>
@@ -9252,7 +9252,7 @@
               </a:defRPr>
             </a:pPr>
             <a:r>
-              <a:t>$90,000</a:t>
+              <a:t>$108,000</a:t>
             </a:r>
           </a:p>
         </p:txBody>
@@ -9331,7 +9331,7 @@
               </a:defRPr>
             </a:pPr>
             <a:r>
-              <a:t>$145,000</a:t>
+              <a:t>$163,000</a:t>
             </a:r>
           </a:p>
         </p:txBody>
@@ -9568,7 +9568,7 @@
               </a:defRPr>
             </a:pPr>
             <a:r>
-              <a:t>$150,000</a:t>
+              <a:t>$180,000</a:t>
             </a:r>
           </a:p>
         </p:txBody>
@@ -9647,7 +9647,7 @@
               </a:defRPr>
             </a:pPr>
             <a:r>
-              <a:t>$205,000</a:t>
+              <a:t>$235,000</a:t>
             </a:r>
           </a:p>
         </p:txBody>

</xml_diff>